<commit_message>
Update presentation overviews to full paragraph title
</commit_message>
<xml_diff>
--- a/edities/books34-v3/books/book-3/chapters/3.2/paragraph-pdfs/3.2.1 Volkomen concurrentie – presentatie.pptx
+++ b/edities/books34-v3/books/book-3/chapters/3.2/paragraph-pdfs/3.2.1 Volkomen concurrentie – presentatie.pptx
@@ -2,37 +2,37 @@
 <file path=ppt/presentation.xml><?xml version="1.0" encoding="utf-8"?>
 <p:presentation xmlns:p="http://schemas.openxmlformats.org/presentationml/2006/main">
   <p:sldMasterIdLst>
-    <p:sldMasterId xmlns:r="http://schemas.openxmlformats.org/officeDocument/2006/relationships" id="2147483648" r:id="R5c908dc09fe14e8d"/>
+    <p:sldMasterId xmlns:r="http://schemas.openxmlformats.org/officeDocument/2006/relationships" id="2147483648" r:id="R248abe271d414f7e"/>
   </p:sldMasterIdLst>
   <p:notesMasterIdLst>
-    <p:notesMasterId xmlns:r="http://schemas.openxmlformats.org/officeDocument/2006/relationships" r:id="Rf5560ad68b5e4821"/>
+    <p:notesMasterId xmlns:r="http://schemas.openxmlformats.org/officeDocument/2006/relationships" r:id="Rf2065fd1cef246a1"/>
   </p:notesMasterIdLst>
   <p:sldIdLst>
-    <p:sldId xmlns:r="http://schemas.openxmlformats.org/officeDocument/2006/relationships" id="256" r:id="Re8e3b4aef7eb423c"/>
-    <p:sldId xmlns:r="http://schemas.openxmlformats.org/officeDocument/2006/relationships" id="257" r:id="Rf9f0925e77b84539"/>
-    <p:sldId xmlns:r="http://schemas.openxmlformats.org/officeDocument/2006/relationships" id="258" r:id="R2f176228a678490d"/>
-    <p:sldId xmlns:r="http://schemas.openxmlformats.org/officeDocument/2006/relationships" id="259" r:id="R68bc4bf1cdd14234"/>
-    <p:sldId xmlns:r="http://schemas.openxmlformats.org/officeDocument/2006/relationships" id="260" r:id="Re0b0bcd93b7140e2"/>
-    <p:sldId xmlns:r="http://schemas.openxmlformats.org/officeDocument/2006/relationships" id="261" r:id="Rcb994ecdfab44b1f"/>
-    <p:sldId xmlns:r="http://schemas.openxmlformats.org/officeDocument/2006/relationships" id="262" r:id="Rca13bba92630462c"/>
-    <p:sldId xmlns:r="http://schemas.openxmlformats.org/officeDocument/2006/relationships" id="263" r:id="R7fb504038b0a4e24"/>
-    <p:sldId xmlns:r="http://schemas.openxmlformats.org/officeDocument/2006/relationships" id="264" r:id="R81bc1e2330d64ada"/>
-    <p:sldId xmlns:r="http://schemas.openxmlformats.org/officeDocument/2006/relationships" id="265" r:id="Rb1d6de8a8deb4419"/>
-    <p:sldId xmlns:r="http://schemas.openxmlformats.org/officeDocument/2006/relationships" id="266" r:id="R24efa75c41724fc2"/>
-    <p:sldId xmlns:r="http://schemas.openxmlformats.org/officeDocument/2006/relationships" id="267" r:id="Rd0d0a0b25c364f58"/>
-    <p:sldId xmlns:r="http://schemas.openxmlformats.org/officeDocument/2006/relationships" id="268" r:id="R37e9820c050a4d01"/>
-    <p:sldId xmlns:r="http://schemas.openxmlformats.org/officeDocument/2006/relationships" id="269" r:id="Rb58e685ff89b4d34"/>
-    <p:sldId xmlns:r="http://schemas.openxmlformats.org/officeDocument/2006/relationships" id="270" r:id="Radf9ac4b5e7f48e4"/>
-    <p:sldId xmlns:r="http://schemas.openxmlformats.org/officeDocument/2006/relationships" id="271" r:id="R41cec28a932b496a"/>
-    <p:sldId xmlns:r="http://schemas.openxmlformats.org/officeDocument/2006/relationships" id="272" r:id="R619ab664477f4801"/>
-    <p:sldId xmlns:r="http://schemas.openxmlformats.org/officeDocument/2006/relationships" id="273" r:id="Rb63d5ecc79a64294"/>
-    <p:sldId xmlns:r="http://schemas.openxmlformats.org/officeDocument/2006/relationships" id="274" r:id="R52b8fcdcc18a4805"/>
-    <p:sldId xmlns:r="http://schemas.openxmlformats.org/officeDocument/2006/relationships" id="275" r:id="R8c46a09add704cfa"/>
-    <p:sldId xmlns:r="http://schemas.openxmlformats.org/officeDocument/2006/relationships" id="276" r:id="R9cf128f170764286"/>
-    <p:sldId xmlns:r="http://schemas.openxmlformats.org/officeDocument/2006/relationships" id="277" r:id="Rba7b0042a9fc4425"/>
-    <p:sldId xmlns:r="http://schemas.openxmlformats.org/officeDocument/2006/relationships" id="278" r:id="R77ee5351a8184008"/>
-    <p:sldId xmlns:r="http://schemas.openxmlformats.org/officeDocument/2006/relationships" id="279" r:id="R9c6172e786834660"/>
-    <p:sldId xmlns:r="http://schemas.openxmlformats.org/officeDocument/2006/relationships" id="280" r:id="Rb2e15fcc5edf4a80"/>
+    <p:sldId xmlns:r="http://schemas.openxmlformats.org/officeDocument/2006/relationships" id="256" r:id="Rc7bd26e97be44d4a"/>
+    <p:sldId xmlns:r="http://schemas.openxmlformats.org/officeDocument/2006/relationships" id="257" r:id="R0f97ba01c7024da9"/>
+    <p:sldId xmlns:r="http://schemas.openxmlformats.org/officeDocument/2006/relationships" id="258" r:id="R2a11247ea5c348cb"/>
+    <p:sldId xmlns:r="http://schemas.openxmlformats.org/officeDocument/2006/relationships" id="259" r:id="R09e79a731c5c4e25"/>
+    <p:sldId xmlns:r="http://schemas.openxmlformats.org/officeDocument/2006/relationships" id="260" r:id="R7d4882258deb44ab"/>
+    <p:sldId xmlns:r="http://schemas.openxmlformats.org/officeDocument/2006/relationships" id="261" r:id="Rae8a6712f2da4da3"/>
+    <p:sldId xmlns:r="http://schemas.openxmlformats.org/officeDocument/2006/relationships" id="262" r:id="Rfc9b6ff334d14fd4"/>
+    <p:sldId xmlns:r="http://schemas.openxmlformats.org/officeDocument/2006/relationships" id="263" r:id="R0c399e8fbc51435d"/>
+    <p:sldId xmlns:r="http://schemas.openxmlformats.org/officeDocument/2006/relationships" id="264" r:id="R4343cc43e4a04072"/>
+    <p:sldId xmlns:r="http://schemas.openxmlformats.org/officeDocument/2006/relationships" id="265" r:id="R680d4bf4c23f4524"/>
+    <p:sldId xmlns:r="http://schemas.openxmlformats.org/officeDocument/2006/relationships" id="266" r:id="R13cf06de6b0844d9"/>
+    <p:sldId xmlns:r="http://schemas.openxmlformats.org/officeDocument/2006/relationships" id="267" r:id="R7ee91e84f2064cb2"/>
+    <p:sldId xmlns:r="http://schemas.openxmlformats.org/officeDocument/2006/relationships" id="268" r:id="R2e44145a8640464b"/>
+    <p:sldId xmlns:r="http://schemas.openxmlformats.org/officeDocument/2006/relationships" id="269" r:id="R31dc56d7a5d44154"/>
+    <p:sldId xmlns:r="http://schemas.openxmlformats.org/officeDocument/2006/relationships" id="270" r:id="R8a0564b53ffa4189"/>
+    <p:sldId xmlns:r="http://schemas.openxmlformats.org/officeDocument/2006/relationships" id="271" r:id="R7985ff7822534adb"/>
+    <p:sldId xmlns:r="http://schemas.openxmlformats.org/officeDocument/2006/relationships" id="272" r:id="R1639927d2ecc412f"/>
+    <p:sldId xmlns:r="http://schemas.openxmlformats.org/officeDocument/2006/relationships" id="273" r:id="Re3277a9216d64acf"/>
+    <p:sldId xmlns:r="http://schemas.openxmlformats.org/officeDocument/2006/relationships" id="274" r:id="Rd664df286a3e4177"/>
+    <p:sldId xmlns:r="http://schemas.openxmlformats.org/officeDocument/2006/relationships" id="275" r:id="Rf90df0ecdf324289"/>
+    <p:sldId xmlns:r="http://schemas.openxmlformats.org/officeDocument/2006/relationships" id="276" r:id="R990e073ed4e64d25"/>
+    <p:sldId xmlns:r="http://schemas.openxmlformats.org/officeDocument/2006/relationships" id="277" r:id="Ra632306a65804a8e"/>
+    <p:sldId xmlns:r="http://schemas.openxmlformats.org/officeDocument/2006/relationships" id="278" r:id="R5a53958aa7d244a0"/>
+    <p:sldId xmlns:r="http://schemas.openxmlformats.org/officeDocument/2006/relationships" id="279" r:id="R8b92541f71e44302"/>
+    <p:sldId xmlns:r="http://schemas.openxmlformats.org/officeDocument/2006/relationships" id="280" r:id="Rdae03c4e4f294f5f"/>
   </p:sldIdLst>
   <p:sldSz cx="15240000" cy="8572500"/>
   <p:notesSz cx="6858000" cy="9144000"/>
@@ -3889,7 +3889,7 @@
   </p:cSld>
   <p:clrMap bg1="lt1" tx1="dk1" bg2="lt2" tx2="dk2" accent1="accent1" accent2="accent2" accent3="accent3" accent4="accent4" accent5="accent5" accent6="accent6" hlink="hlink" folHlink="folHlink"/>
   <p:sldLayoutIdLst>
-    <p:sldLayoutId xmlns:r="http://schemas.openxmlformats.org/officeDocument/2006/relationships" id="2147483649" r:id="Rd7ceac68fcac41da"/>
+    <p:sldLayoutId xmlns:r="http://schemas.openxmlformats.org/officeDocument/2006/relationships" id="2147483649" r:id="Rdd79c64fc388450f"/>
   </p:sldLayoutIdLst>
   <p:txStyles>
     <p:titleStyle>
@@ -9410,10 +9410,10 @@
       </p:grpSpPr>
       <p:sp>
         <p:nvSpPr>
-          <p:cNvPr id="29" name="Deze les: §3.2.1 Volkomen concurrentie">
+          <p:cNvPr id="29" name="Deze les: §3.2.1 Volkomen concurrentie: kenmerken">
             <a:extLst xmlns:a="http://schemas.openxmlformats.org/drawingml/2006/main">
               <a:ext uri="{FF2B5EF4-FFF2-40B4-BE49-F238E27FC236}">
-                <a16:creationId xmlns:a16="http://schemas.microsoft.com/office/drawing/2014/main" id="{32E5E25E-BD8B-403C-8FAD-E8DCAC4FB7F2}"/>
+                <a16:creationId xmlns:a16="http://schemas.microsoft.com/office/drawing/2014/main" id="{040B119C-FE04-41CC-A828-6A8DEB6AA0D3}"/>
               </a:ext>
             </a:extLst>
           </p:cNvPr>
@@ -9460,7 +9460,7 @@
                 <a:ea typeface="Arial"/>
                 <a:cs typeface="Arial"/>
               </a:rPr>
-              <a:t>Deze les: §3.2.1 Volkomen concurrentie</a:t>
+              <a:t>Deze les: §3.2.1 Volkomen concurrentie: kenmerken</a:t>
             </a:r>
           </a:p>
         </p:txBody>
@@ -9470,7 +9470,7 @@
           <p:cNvPr id="2" name="">
             <a:extLst xmlns:a="http://schemas.openxmlformats.org/drawingml/2006/main">
               <a:ext uri="{FF2B5EF4-FFF2-40B4-BE49-F238E27FC236}">
-                <a16:creationId xmlns:a16="http://schemas.microsoft.com/office/drawing/2014/main" id="{263964C5-B399-42A6-B167-467089C95BED}"/>
+                <a16:creationId xmlns:a16="http://schemas.microsoft.com/office/drawing/2014/main" id="{95245BD0-15B2-4E0B-8A9A-EFE508E0A444}"/>
               </a:ext>
             </a:extLst>
           </p:cNvPr>
@@ -9499,7 +9499,7 @@
           <p:cNvPr id="3" name="§3.2.1 Volkomen concurrentie">
             <a:extLst xmlns:a="http://schemas.openxmlformats.org/drawingml/2006/main">
               <a:ext uri="{FF2B5EF4-FFF2-40B4-BE49-F238E27FC236}">
-                <a16:creationId xmlns:a16="http://schemas.microsoft.com/office/drawing/2014/main" id="{EBE97719-3CDC-4EE7-981F-4EA299D20107}"/>
+                <a16:creationId xmlns:a16="http://schemas.microsoft.com/office/drawing/2014/main" id="{64C20247-10C3-4504-AC77-7206A0329283}"/>
               </a:ext>
             </a:extLst>
           </p:cNvPr>
@@ -9556,7 +9556,7 @@
           <p:cNvPr id="4" name="1">
             <a:extLst xmlns:a="http://schemas.openxmlformats.org/drawingml/2006/main">
               <a:ext uri="{FF2B5EF4-FFF2-40B4-BE49-F238E27FC236}">
-                <a16:creationId xmlns:a16="http://schemas.microsoft.com/office/drawing/2014/main" id="{B9B21E85-917D-48C3-B7BB-06E9F1423081}"/>
+                <a16:creationId xmlns:a16="http://schemas.microsoft.com/office/drawing/2014/main" id="{54E99416-FDF9-4D96-AADC-6A3E2C94D2F8}"/>
               </a:ext>
             </a:extLst>
           </p:cNvPr>
@@ -9613,7 +9613,7 @@
           <p:cNvPr id="5" name="phase">
             <a:extLst xmlns:a="http://schemas.openxmlformats.org/drawingml/2006/main">
               <a:ext uri="{FF2B5EF4-FFF2-40B4-BE49-F238E27FC236}">
-                <a16:creationId xmlns:a16="http://schemas.microsoft.com/office/drawing/2014/main" id="{41844DE5-AB4B-493E-8D8A-0B94ADF32857}"/>
+                <a16:creationId xmlns:a16="http://schemas.microsoft.com/office/drawing/2014/main" id="{8E8D1483-3191-4FD4-8B1B-895A2B62DCEF}"/>
               </a:ext>
             </a:extLst>
           </p:cNvPr>
@@ -9670,7 +9670,7 @@
           <p:cNvPr id="6" name="Lesroute">
             <a:extLst xmlns:a="http://schemas.openxmlformats.org/drawingml/2006/main">
               <a:ext uri="{FF2B5EF4-FFF2-40B4-BE49-F238E27FC236}">
-                <a16:creationId xmlns:a16="http://schemas.microsoft.com/office/drawing/2014/main" id="{B7D8C9C6-87EA-485A-B5C7-3DDAC8945F72}"/>
+                <a16:creationId xmlns:a16="http://schemas.microsoft.com/office/drawing/2014/main" id="{08F2157A-C9ED-42DF-B2C4-8DEC50222605}"/>
               </a:ext>
             </a:extLst>
           </p:cNvPr>
@@ -9727,7 +9727,7 @@
           <p:cNvPr id="7" name="route-number-1">
             <a:extLst xmlns:a="http://schemas.openxmlformats.org/drawingml/2006/main">
               <a:ext uri="{FF2B5EF4-FFF2-40B4-BE49-F238E27FC236}">
-                <a16:creationId xmlns:a16="http://schemas.microsoft.com/office/drawing/2014/main" id="{CD22CFC1-5DFF-49DC-8BBA-17A86315A0FD}"/>
+                <a16:creationId xmlns:a16="http://schemas.microsoft.com/office/drawing/2014/main" id="{95CFD0CB-131F-44A8-94E4-777C9B708D85}"/>
               </a:ext>
             </a:extLst>
           </p:cNvPr>
@@ -9784,7 +9784,7 @@
           <p:cNvPr id="8" name="route-1">
             <a:extLst xmlns:a="http://schemas.openxmlformats.org/drawingml/2006/main">
               <a:ext uri="{FF2B5EF4-FFF2-40B4-BE49-F238E27FC236}">
-                <a16:creationId xmlns:a16="http://schemas.microsoft.com/office/drawing/2014/main" id="{9EF0C330-3260-4768-AA44-32FC34ED8EBE}"/>
+                <a16:creationId xmlns:a16="http://schemas.microsoft.com/office/drawing/2014/main" id="{F6E25AC8-7F4F-4549-9895-21BD015835B6}"/>
               </a:ext>
             </a:extLst>
           </p:cNvPr>
@@ -9841,7 +9841,7 @@
           <p:cNvPr id="9" name="route-number-2">
             <a:extLst xmlns:a="http://schemas.openxmlformats.org/drawingml/2006/main">
               <a:ext uri="{FF2B5EF4-FFF2-40B4-BE49-F238E27FC236}">
-                <a16:creationId xmlns:a16="http://schemas.microsoft.com/office/drawing/2014/main" id="{FB7311F6-A677-44DE-905B-B08DD51C8BD5}"/>
+                <a16:creationId xmlns:a16="http://schemas.microsoft.com/office/drawing/2014/main" id="{E0704AB0-FAAD-4001-99C6-E215BAB4D56F}"/>
               </a:ext>
             </a:extLst>
           </p:cNvPr>
@@ -9898,7 +9898,7 @@
           <p:cNvPr id="10" name="route-2">
             <a:extLst xmlns:a="http://schemas.openxmlformats.org/drawingml/2006/main">
               <a:ext uri="{FF2B5EF4-FFF2-40B4-BE49-F238E27FC236}">
-                <a16:creationId xmlns:a16="http://schemas.microsoft.com/office/drawing/2014/main" id="{03726A27-2226-45F5-8346-CA625E5F1BEB}"/>
+                <a16:creationId xmlns:a16="http://schemas.microsoft.com/office/drawing/2014/main" id="{4CBDAB71-620B-4E1F-899A-0DBECDF05781}"/>
               </a:ext>
             </a:extLst>
           </p:cNvPr>
@@ -9955,7 +9955,7 @@
           <p:cNvPr id="11" name="route-number-3">
             <a:extLst xmlns:a="http://schemas.openxmlformats.org/drawingml/2006/main">
               <a:ext uri="{FF2B5EF4-FFF2-40B4-BE49-F238E27FC236}">
-                <a16:creationId xmlns:a16="http://schemas.microsoft.com/office/drawing/2014/main" id="{C3FF6B15-0075-4317-B2AC-7D5557C70BE4}"/>
+                <a16:creationId xmlns:a16="http://schemas.microsoft.com/office/drawing/2014/main" id="{4729ACEF-CE12-41CE-9D99-9FB7201D9E40}"/>
               </a:ext>
             </a:extLst>
           </p:cNvPr>
@@ -10012,7 +10012,7 @@
           <p:cNvPr id="12" name="route-3">
             <a:extLst xmlns:a="http://schemas.openxmlformats.org/drawingml/2006/main">
               <a:ext uri="{FF2B5EF4-FFF2-40B4-BE49-F238E27FC236}">
-                <a16:creationId xmlns:a16="http://schemas.microsoft.com/office/drawing/2014/main" id="{D97E690B-E98F-484B-B019-7DEC7B0A4413}"/>
+                <a16:creationId xmlns:a16="http://schemas.microsoft.com/office/drawing/2014/main" id="{5FC8F1D0-8EB0-4B8B-894D-727B7C86CF39}"/>
               </a:ext>
             </a:extLst>
           </p:cNvPr>
@@ -10069,7 +10069,7 @@
           <p:cNvPr id="13" name="route-number-4">
             <a:extLst xmlns:a="http://schemas.openxmlformats.org/drawingml/2006/main">
               <a:ext uri="{FF2B5EF4-FFF2-40B4-BE49-F238E27FC236}">
-                <a16:creationId xmlns:a16="http://schemas.microsoft.com/office/drawing/2014/main" id="{A306C11F-F199-408E-84A6-4ABDC7BBACF8}"/>
+                <a16:creationId xmlns:a16="http://schemas.microsoft.com/office/drawing/2014/main" id="{41A0DD25-FC32-46F4-AFBE-F5796CCDE279}"/>
               </a:ext>
             </a:extLst>
           </p:cNvPr>
@@ -10126,7 +10126,7 @@
           <p:cNvPr id="14" name="route-4">
             <a:extLst xmlns:a="http://schemas.openxmlformats.org/drawingml/2006/main">
               <a:ext uri="{FF2B5EF4-FFF2-40B4-BE49-F238E27FC236}">
-                <a16:creationId xmlns:a16="http://schemas.microsoft.com/office/drawing/2014/main" id="{268E134A-58DF-4335-8052-0F70BE0AD0D4}"/>
+                <a16:creationId xmlns:a16="http://schemas.microsoft.com/office/drawing/2014/main" id="{8786818C-328E-4E39-8784-DFF7E600799A}"/>
               </a:ext>
             </a:extLst>
           </p:cNvPr>
@@ -10183,7 +10183,7 @@
           <p:cNvPr id="15" name="route-number-5">
             <a:extLst xmlns:a="http://schemas.openxmlformats.org/drawingml/2006/main">
               <a:ext uri="{FF2B5EF4-FFF2-40B4-BE49-F238E27FC236}">
-                <a16:creationId xmlns:a16="http://schemas.microsoft.com/office/drawing/2014/main" id="{2190D79D-8B95-41AD-894F-C527A297F809}"/>
+                <a16:creationId xmlns:a16="http://schemas.microsoft.com/office/drawing/2014/main" id="{78416836-BEEC-4E44-85AB-FFA87D64224A}"/>
               </a:ext>
             </a:extLst>
           </p:cNvPr>
@@ -10240,7 +10240,7 @@
           <p:cNvPr id="16" name="route-5">
             <a:extLst xmlns:a="http://schemas.openxmlformats.org/drawingml/2006/main">
               <a:ext uri="{FF2B5EF4-FFF2-40B4-BE49-F238E27FC236}">
-                <a16:creationId xmlns:a16="http://schemas.microsoft.com/office/drawing/2014/main" id="{7DAE091B-22A3-452F-AAB7-6807F4751D97}"/>
+                <a16:creationId xmlns:a16="http://schemas.microsoft.com/office/drawing/2014/main" id="{ABE36E30-DAE8-4292-BAF5-C1A6378D2C45}"/>
               </a:ext>
             </a:extLst>
           </p:cNvPr>
@@ -10297,7 +10297,7 @@
           <p:cNvPr id="17" name="route-number-6">
             <a:extLst xmlns:a="http://schemas.openxmlformats.org/drawingml/2006/main">
               <a:ext uri="{FF2B5EF4-FFF2-40B4-BE49-F238E27FC236}">
-                <a16:creationId xmlns:a16="http://schemas.microsoft.com/office/drawing/2014/main" id="{C71F1483-0064-45D0-B48B-2EB7E2DCC692}"/>
+                <a16:creationId xmlns:a16="http://schemas.microsoft.com/office/drawing/2014/main" id="{5D3F8974-21B4-400F-8D7C-EA80318B6271}"/>
               </a:ext>
             </a:extLst>
           </p:cNvPr>
@@ -10354,7 +10354,7 @@
           <p:cNvPr id="18" name="route-6">
             <a:extLst xmlns:a="http://schemas.openxmlformats.org/drawingml/2006/main">
               <a:ext uri="{FF2B5EF4-FFF2-40B4-BE49-F238E27FC236}">
-                <a16:creationId xmlns:a16="http://schemas.microsoft.com/office/drawing/2014/main" id="{F50E2D5F-6A52-4169-96EA-3066878B9DFA}"/>
+                <a16:creationId xmlns:a16="http://schemas.microsoft.com/office/drawing/2014/main" id="{143E491D-48ED-4B14-B76C-6C68B1BFD756}"/>
               </a:ext>
             </a:extLst>
           </p:cNvPr>
@@ -10411,7 +10411,7 @@
           <p:cNvPr id="19" name="route-number-7">
             <a:extLst xmlns:a="http://schemas.openxmlformats.org/drawingml/2006/main">
               <a:ext uri="{FF2B5EF4-FFF2-40B4-BE49-F238E27FC236}">
-                <a16:creationId xmlns:a16="http://schemas.microsoft.com/office/drawing/2014/main" id="{34BEA3A1-B987-4FAC-960E-AC973C8FD0ED}"/>
+                <a16:creationId xmlns:a16="http://schemas.microsoft.com/office/drawing/2014/main" id="{162DD48E-AD94-4A09-89A0-2569BC914891}"/>
               </a:ext>
             </a:extLst>
           </p:cNvPr>
@@ -10468,7 +10468,7 @@
           <p:cNvPr id="20" name="route-7">
             <a:extLst xmlns:a="http://schemas.openxmlformats.org/drawingml/2006/main">
               <a:ext uri="{FF2B5EF4-FFF2-40B4-BE49-F238E27FC236}">
-                <a16:creationId xmlns:a16="http://schemas.microsoft.com/office/drawing/2014/main" id="{DA1BB703-346A-416A-8DDE-05A168D043B6}"/>
+                <a16:creationId xmlns:a16="http://schemas.microsoft.com/office/drawing/2014/main" id="{9C4797F2-AA58-4703-9D71-DE2C64B57C72}"/>
               </a:ext>
             </a:extLst>
           </p:cNvPr>
@@ -10525,7 +10525,7 @@
           <p:cNvPr id="21" name="Lesdoelen">
             <a:extLst xmlns:a="http://schemas.openxmlformats.org/drawingml/2006/main">
               <a:ext uri="{FF2B5EF4-FFF2-40B4-BE49-F238E27FC236}">
-                <a16:creationId xmlns:a16="http://schemas.microsoft.com/office/drawing/2014/main" id="{8ACC9703-DEE8-4A4A-9957-693C71F47B5B}"/>
+                <a16:creationId xmlns:a16="http://schemas.microsoft.com/office/drawing/2014/main" id="{E81E1EBD-0405-4B2F-A650-28D5C4DDAD02}"/>
               </a:ext>
             </a:extLst>
           </p:cNvPr>
@@ -10582,7 +10582,7 @@
           <p:cNvPr id="22" name="overview-goals">
             <a:extLst xmlns:a="http://schemas.openxmlformats.org/drawingml/2006/main">
               <a:ext uri="{FF2B5EF4-FFF2-40B4-BE49-F238E27FC236}">
-                <a16:creationId xmlns:a16="http://schemas.microsoft.com/office/drawing/2014/main" id="{C100F98C-8B8D-40DA-A974-9D0B7B56E52C}"/>
+                <a16:creationId xmlns:a16="http://schemas.microsoft.com/office/drawing/2014/main" id="{5DD30518-55E5-45DD-808C-BC190D89725E}"/>
               </a:ext>
             </a:extLst>
           </p:cNvPr>
@@ -10708,7 +10708,7 @@
           <p:cNvPr id="23" name="">
             <a:extLst xmlns:a="http://schemas.openxmlformats.org/drawingml/2006/main">
               <a:ext uri="{FF2B5EF4-FFF2-40B4-BE49-F238E27FC236}">
-                <a16:creationId xmlns:a16="http://schemas.microsoft.com/office/drawing/2014/main" id="{1396AF66-06D5-4400-8D21-F737695C917C}"/>
+                <a16:creationId xmlns:a16="http://schemas.microsoft.com/office/drawing/2014/main" id="{7CF534CA-14BB-4F3E-ABC3-789C5D360FB5}"/>
               </a:ext>
             </a:extLst>
           </p:cNvPr>
@@ -10737,7 +10737,7 @@
           <p:cNvPr id="24" name="Startopdracht">
             <a:extLst xmlns:a="http://schemas.openxmlformats.org/drawingml/2006/main">
               <a:ext uri="{FF2B5EF4-FFF2-40B4-BE49-F238E27FC236}">
-                <a16:creationId xmlns:a16="http://schemas.microsoft.com/office/drawing/2014/main" id="{0B127BA5-2984-45E3-BC1D-31D155770D61}"/>
+                <a16:creationId xmlns:a16="http://schemas.microsoft.com/office/drawing/2014/main" id="{5DDDFDB0-CC7A-4494-84CA-0CB2CBB59F0B}"/>
               </a:ext>
             </a:extLst>
           </p:cNvPr>
@@ -10794,7 +10794,7 @@
           <p:cNvPr id="25" name="overview-start">
             <a:extLst xmlns:a="http://schemas.openxmlformats.org/drawingml/2006/main">
               <a:ext uri="{FF2B5EF4-FFF2-40B4-BE49-F238E27FC236}">
-                <a16:creationId xmlns:a16="http://schemas.microsoft.com/office/drawing/2014/main" id="{59B86C77-5091-4D74-8675-4B83CBE101B3}"/>
+                <a16:creationId xmlns:a16="http://schemas.microsoft.com/office/drawing/2014/main" id="{22BD1C64-6ABC-47FA-8C25-863700D69C2C}"/>
               </a:ext>
             </a:extLst>
           </p:cNvPr>
@@ -10897,7 +10897,7 @@
           <p:cNvPr id="26" name="">
             <a:extLst xmlns:a="http://schemas.openxmlformats.org/drawingml/2006/main">
               <a:ext uri="{FF2B5EF4-FFF2-40B4-BE49-F238E27FC236}">
-                <a16:creationId xmlns:a16="http://schemas.microsoft.com/office/drawing/2014/main" id="{38AD96B2-4C8C-46B0-892E-E3779E91FBAF}"/>
+                <a16:creationId xmlns:a16="http://schemas.microsoft.com/office/drawing/2014/main" id="{CACF70F5-6DEB-45E1-B053-E452AC20EEDF}"/>
               </a:ext>
             </a:extLst>
           </p:cNvPr>
@@ -10926,7 +10926,7 @@
           <p:cNvPr id="27" name="Huiswerk">
             <a:extLst xmlns:a="http://schemas.openxmlformats.org/drawingml/2006/main">
               <a:ext uri="{FF2B5EF4-FFF2-40B4-BE49-F238E27FC236}">
-                <a16:creationId xmlns:a16="http://schemas.microsoft.com/office/drawing/2014/main" id="{BD97314B-CE60-4590-AACD-C4A7CBE46C56}"/>
+                <a16:creationId xmlns:a16="http://schemas.microsoft.com/office/drawing/2014/main" id="{84639CB2-1CA7-4AE6-9B12-18399909BCC6}"/>
               </a:ext>
             </a:extLst>
           </p:cNvPr>
@@ -10983,7 +10983,7 @@
           <p:cNvPr id="28" name="overview-homework">
             <a:extLst xmlns:a="http://schemas.openxmlformats.org/drawingml/2006/main">
               <a:ext uri="{FF2B5EF4-FFF2-40B4-BE49-F238E27FC236}">
-                <a16:creationId xmlns:a16="http://schemas.microsoft.com/office/drawing/2014/main" id="{CA68E454-550D-4617-959F-6BA00D9220DB}"/>
+                <a16:creationId xmlns:a16="http://schemas.microsoft.com/office/drawing/2014/main" id="{16FB212B-B9B4-4A4D-92AF-A1BBDD7C634A}"/>
               </a:ext>
             </a:extLst>
           </p:cNvPr>
@@ -11130,7 +11130,7 @@
     </p:spTree>
     <p:extLst>
       <p:ext uri="{BB962C8B-B14F-4D97-AF65-F5344CB8AC3E}">
-        <p14:creationId xmlns:p14="http://schemas.microsoft.com/office/powerpoint/2010/main" val="1176452267"/>
+        <p14:creationId xmlns:p14="http://schemas.microsoft.com/office/powerpoint/2010/main" val="292850042"/>
       </p:ext>
     </p:extLst>
   </p:cSld>
@@ -11161,7 +11161,7 @@
           <p:cNvPr id="9" name="De opbrengstlijn van één prijsnemer">
             <a:extLst xmlns:a="http://schemas.openxmlformats.org/drawingml/2006/main">
               <a:ext uri="{FF2B5EF4-FFF2-40B4-BE49-F238E27FC236}">
-                <a16:creationId xmlns:a16="http://schemas.microsoft.com/office/drawing/2014/main" id="{6E88E1E2-4345-4699-A9F9-48BE6CB1D5DC}"/>
+                <a16:creationId xmlns:a16="http://schemas.microsoft.com/office/drawing/2014/main" id="{F4876BC7-DDAF-4260-A58B-911783540283}"/>
               </a:ext>
             </a:extLst>
           </p:cNvPr>
@@ -11218,7 +11218,7 @@
           <p:cNvPr id="2" name="">
             <a:extLst xmlns:a="http://schemas.openxmlformats.org/drawingml/2006/main">
               <a:ext uri="{FF2B5EF4-FFF2-40B4-BE49-F238E27FC236}">
-                <a16:creationId xmlns:a16="http://schemas.microsoft.com/office/drawing/2014/main" id="{5DB5711F-5CD4-44A7-A38F-4DD951C74077}"/>
+                <a16:creationId xmlns:a16="http://schemas.microsoft.com/office/drawing/2014/main" id="{A35FCD02-1B2B-4E0B-867D-93CF987052B0}"/>
               </a:ext>
             </a:extLst>
           </p:cNvPr>
@@ -11247,7 +11247,7 @@
           <p:cNvPr id="3" name="§3.2.1 Volkomen concurrentie">
             <a:extLst xmlns:a="http://schemas.openxmlformats.org/drawingml/2006/main">
               <a:ext uri="{FF2B5EF4-FFF2-40B4-BE49-F238E27FC236}">
-                <a16:creationId xmlns:a16="http://schemas.microsoft.com/office/drawing/2014/main" id="{A9B2EE19-D16C-43C0-981A-1FC1FD215FAC}"/>
+                <a16:creationId xmlns:a16="http://schemas.microsoft.com/office/drawing/2014/main" id="{B7E49F99-7CE0-447F-9AE4-D36E495B2744}"/>
               </a:ext>
             </a:extLst>
           </p:cNvPr>
@@ -11304,7 +11304,7 @@
           <p:cNvPr id="4" name="10">
             <a:extLst xmlns:a="http://schemas.openxmlformats.org/drawingml/2006/main">
               <a:ext uri="{FF2B5EF4-FFF2-40B4-BE49-F238E27FC236}">
-                <a16:creationId xmlns:a16="http://schemas.microsoft.com/office/drawing/2014/main" id="{E2E4FE12-9CAD-47B9-922B-3E9598269FDB}"/>
+                <a16:creationId xmlns:a16="http://schemas.microsoft.com/office/drawing/2014/main" id="{DF8FE613-058C-49E3-B985-C359B7465923}"/>
               </a:ext>
             </a:extLst>
           </p:cNvPr>
@@ -11361,7 +11361,7 @@
           <p:cNvPr id="5" name="Uitlegvoorbeeld — niet uit het boek">
             <a:extLst xmlns:a="http://schemas.openxmlformats.org/drawingml/2006/main">
               <a:ext uri="{FF2B5EF4-FFF2-40B4-BE49-F238E27FC236}">
-                <a16:creationId xmlns:a16="http://schemas.microsoft.com/office/drawing/2014/main" id="{9D6D916A-1458-406C-9737-0CEE160D507E}"/>
+                <a16:creationId xmlns:a16="http://schemas.microsoft.com/office/drawing/2014/main" id="{5CB283BE-4DA4-4FB5-954C-62CC5B2B804D}"/>
               </a:ext>
             </a:extLst>
           </p:cNvPr>
@@ -11425,7 +11425,7 @@
         </p:xfrm>
         <a:graphic xmlns:a="http://schemas.openxmlformats.org/drawingml/2006/main">
           <a:graphicData uri="http://schemas.openxmlformats.org/drawingml/2006/chart">
-            <c:chart xmlns:r="http://schemas.openxmlformats.org/officeDocument/2006/relationships" xmlns:c="http://schemas.openxmlformats.org/drawingml/2006/chart" r:id="Reb147a9085324ac1"/>
+            <c:chart xmlns:r="http://schemas.openxmlformats.org/officeDocument/2006/relationships" xmlns:c="http://schemas.openxmlformats.org/drawingml/2006/chart" r:id="R89c55e7d7af34ec6"/>
           </a:graphicData>
         </a:graphic>
       </p:graphicFrame>
@@ -11434,7 +11434,7 @@
           <p:cNvPr id="7" name="P = GO = MO&#10;= € 2,50 per kg">
             <a:extLst xmlns:a="http://schemas.openxmlformats.org/drawingml/2006/main">
               <a:ext uri="{FF2B5EF4-FFF2-40B4-BE49-F238E27FC236}">
-                <a16:creationId xmlns:a16="http://schemas.microsoft.com/office/drawing/2014/main" id="{E85D5213-7C8D-4B11-98E6-88EB1A50EE23}"/>
+                <a16:creationId xmlns:a16="http://schemas.microsoft.com/office/drawing/2014/main" id="{FA410EAC-0EB4-4358-8A33-60958D9711A5}"/>
               </a:ext>
             </a:extLst>
           </p:cNvPr>
@@ -11514,7 +11514,7 @@
           <p:cNvPr id="8" name="TO = 2,50 × q&#10;TO groeit met q.">
             <a:extLst xmlns:a="http://schemas.openxmlformats.org/drawingml/2006/main">
               <a:ext uri="{FF2B5EF4-FFF2-40B4-BE49-F238E27FC236}">
-                <a16:creationId xmlns:a16="http://schemas.microsoft.com/office/drawing/2014/main" id="{EE8C952F-E0C2-4796-AA0B-17DD2A05AD65}"/>
+                <a16:creationId xmlns:a16="http://schemas.microsoft.com/office/drawing/2014/main" id="{7D6E24DD-92EE-4C58-B2C0-D36A2A7BFE9F}"/>
               </a:ext>
             </a:extLst>
           </p:cNvPr>
@@ -11592,7 +11592,7 @@
     </p:spTree>
     <p:extLst>
       <p:ext uri="{BB962C8B-B14F-4D97-AF65-F5344CB8AC3E}">
-        <p14:creationId xmlns:p14="http://schemas.microsoft.com/office/powerpoint/2010/main" val="946925666"/>
+        <p14:creationId xmlns:p14="http://schemas.microsoft.com/office/powerpoint/2010/main" val="1039600464"/>
       </p:ext>
     </p:extLst>
   </p:cSld>
@@ -11623,7 +11623,7 @@
           <p:cNvPr id="9" name="Een prijs boven de marktprijs">
             <a:extLst xmlns:a="http://schemas.openxmlformats.org/drawingml/2006/main">
               <a:ext uri="{FF2B5EF4-FFF2-40B4-BE49-F238E27FC236}">
-                <a16:creationId xmlns:a16="http://schemas.microsoft.com/office/drawing/2014/main" id="{91064D97-06BE-448A-9D25-4D70EC8FC311}"/>
+                <a16:creationId xmlns:a16="http://schemas.microsoft.com/office/drawing/2014/main" id="{1B750DF2-27BA-4672-A105-A7E181EBD863}"/>
               </a:ext>
             </a:extLst>
           </p:cNvPr>
@@ -11680,7 +11680,7 @@
           <p:cNvPr id="2" name="">
             <a:extLst xmlns:a="http://schemas.openxmlformats.org/drawingml/2006/main">
               <a:ext uri="{FF2B5EF4-FFF2-40B4-BE49-F238E27FC236}">
-                <a16:creationId xmlns:a16="http://schemas.microsoft.com/office/drawing/2014/main" id="{1ED15AB4-3BF5-4C49-B5F8-DA93E1379680}"/>
+                <a16:creationId xmlns:a16="http://schemas.microsoft.com/office/drawing/2014/main" id="{7D4B42BD-26B5-45C2-93AC-375DBFD36629}"/>
               </a:ext>
             </a:extLst>
           </p:cNvPr>
@@ -11709,7 +11709,7 @@
           <p:cNvPr id="3" name="§3.2.1 Volkomen concurrentie">
             <a:extLst xmlns:a="http://schemas.openxmlformats.org/drawingml/2006/main">
               <a:ext uri="{FF2B5EF4-FFF2-40B4-BE49-F238E27FC236}">
-                <a16:creationId xmlns:a16="http://schemas.microsoft.com/office/drawing/2014/main" id="{AF550419-6537-4CF6-867B-588965C79019}"/>
+                <a16:creationId xmlns:a16="http://schemas.microsoft.com/office/drawing/2014/main" id="{0AAECF44-57D7-4B37-AC1A-EE1CF3996449}"/>
               </a:ext>
             </a:extLst>
           </p:cNvPr>
@@ -11766,7 +11766,7 @@
           <p:cNvPr id="4" name="11">
             <a:extLst xmlns:a="http://schemas.openxmlformats.org/drawingml/2006/main">
               <a:ext uri="{FF2B5EF4-FFF2-40B4-BE49-F238E27FC236}">
-                <a16:creationId xmlns:a16="http://schemas.microsoft.com/office/drawing/2014/main" id="{5CA4C1BB-30DF-4E5F-8D76-459AFA16427E}"/>
+                <a16:creationId xmlns:a16="http://schemas.microsoft.com/office/drawing/2014/main" id="{962409FC-25B1-47F9-831C-51AA6224937B}"/>
               </a:ext>
             </a:extLst>
           </p:cNvPr>
@@ -11823,7 +11823,7 @@
           <p:cNvPr id="5" name="Uitlegvoorbeeld — niet uit het boek">
             <a:extLst xmlns:a="http://schemas.openxmlformats.org/drawingml/2006/main">
               <a:ext uri="{FF2B5EF4-FFF2-40B4-BE49-F238E27FC236}">
-                <a16:creationId xmlns:a16="http://schemas.microsoft.com/office/drawing/2014/main" id="{5F9BCEEE-7475-4B74-8A65-0D1C7FB475E0}"/>
+                <a16:creationId xmlns:a16="http://schemas.microsoft.com/office/drawing/2014/main" id="{ADF1D848-972D-4B93-ACA7-825865AC9147}"/>
               </a:ext>
             </a:extLst>
           </p:cNvPr>
@@ -12052,7 +12052,7 @@
           <p:cNvPr id="7" name="Kopers kennen de prijzen en kopen elders.">
             <a:extLst xmlns:a="http://schemas.openxmlformats.org/drawingml/2006/main">
               <a:ext uri="{FF2B5EF4-FFF2-40B4-BE49-F238E27FC236}">
-                <a16:creationId xmlns:a16="http://schemas.microsoft.com/office/drawing/2014/main" id="{E0FDFE34-3D8B-4278-B5A9-6BF390DDCBD1}"/>
+                <a16:creationId xmlns:a16="http://schemas.microsoft.com/office/drawing/2014/main" id="{6597BD4A-2685-4F00-8BEB-1E6D2730E707}"/>
               </a:ext>
             </a:extLst>
           </p:cNvPr>
@@ -12109,7 +12109,7 @@
           <p:cNvPr id="8" name="Sam verliest in dit model zijn afzet.">
             <a:extLst xmlns:a="http://schemas.openxmlformats.org/drawingml/2006/main">
               <a:ext uri="{FF2B5EF4-FFF2-40B4-BE49-F238E27FC236}">
-                <a16:creationId xmlns:a16="http://schemas.microsoft.com/office/drawing/2014/main" id="{6AAB81A9-6B39-4CBC-BAE8-2558B0E1DCE0}"/>
+                <a16:creationId xmlns:a16="http://schemas.microsoft.com/office/drawing/2014/main" id="{35E13717-E427-48DF-BB18-C623240535E4}"/>
               </a:ext>
             </a:extLst>
           </p:cNvPr>
@@ -12164,7 +12164,7 @@
     </p:spTree>
     <p:extLst>
       <p:ext uri="{BB962C8B-B14F-4D97-AF65-F5344CB8AC3E}">
-        <p14:creationId xmlns:p14="http://schemas.microsoft.com/office/powerpoint/2010/main" val="1839432613"/>
+        <p14:creationId xmlns:p14="http://schemas.microsoft.com/office/powerpoint/2010/main" val="1916904590"/>
       </p:ext>
     </p:extLst>
   </p:cSld>
@@ -12195,7 +12195,7 @@
           <p:cNvPr id="10" name="Een lagere prijs bij dezelfde afzet">
             <a:extLst xmlns:a="http://schemas.openxmlformats.org/drawingml/2006/main">
               <a:ext uri="{FF2B5EF4-FFF2-40B4-BE49-F238E27FC236}">
-                <a16:creationId xmlns:a16="http://schemas.microsoft.com/office/drawing/2014/main" id="{1245A0E1-3E5B-4A2F-9BFB-768C8A761800}"/>
+                <a16:creationId xmlns:a16="http://schemas.microsoft.com/office/drawing/2014/main" id="{F1831F9D-A3C7-42BF-A4F0-B039833CEB0C}"/>
               </a:ext>
             </a:extLst>
           </p:cNvPr>
@@ -12252,7 +12252,7 @@
           <p:cNvPr id="2" name="">
             <a:extLst xmlns:a="http://schemas.openxmlformats.org/drawingml/2006/main">
               <a:ext uri="{FF2B5EF4-FFF2-40B4-BE49-F238E27FC236}">
-                <a16:creationId xmlns:a16="http://schemas.microsoft.com/office/drawing/2014/main" id="{A667BF1D-DED6-449E-8AC1-1B2B1521A729}"/>
+                <a16:creationId xmlns:a16="http://schemas.microsoft.com/office/drawing/2014/main" id="{D2FA902A-9C8E-46FF-8F11-B3B8973CCDF7}"/>
               </a:ext>
             </a:extLst>
           </p:cNvPr>
@@ -12281,7 +12281,7 @@
           <p:cNvPr id="3" name="§3.2.1 Volkomen concurrentie">
             <a:extLst xmlns:a="http://schemas.openxmlformats.org/drawingml/2006/main">
               <a:ext uri="{FF2B5EF4-FFF2-40B4-BE49-F238E27FC236}">
-                <a16:creationId xmlns:a16="http://schemas.microsoft.com/office/drawing/2014/main" id="{794026B7-D66B-4F87-B29E-07DEE44A2191}"/>
+                <a16:creationId xmlns:a16="http://schemas.microsoft.com/office/drawing/2014/main" id="{2E97D564-FCF7-487F-89BF-F1ED18F77E1D}"/>
               </a:ext>
             </a:extLst>
           </p:cNvPr>
@@ -12338,7 +12338,7 @@
           <p:cNvPr id="4" name="12">
             <a:extLst xmlns:a="http://schemas.openxmlformats.org/drawingml/2006/main">
               <a:ext uri="{FF2B5EF4-FFF2-40B4-BE49-F238E27FC236}">
-                <a16:creationId xmlns:a16="http://schemas.microsoft.com/office/drawing/2014/main" id="{D5BBD9C6-CE26-47D3-9DD8-475DA72929C8}"/>
+                <a16:creationId xmlns:a16="http://schemas.microsoft.com/office/drawing/2014/main" id="{F19D974E-B1E5-477A-9C85-6402BD4DD987}"/>
               </a:ext>
             </a:extLst>
           </p:cNvPr>
@@ -12395,7 +12395,7 @@
           <p:cNvPr id="5" name="Uitlegvoorbeeld — niet uit het boek">
             <a:extLst xmlns:a="http://schemas.openxmlformats.org/drawingml/2006/main">
               <a:ext uri="{FF2B5EF4-FFF2-40B4-BE49-F238E27FC236}">
-                <a16:creationId xmlns:a16="http://schemas.microsoft.com/office/drawing/2014/main" id="{D0867FDD-E7D9-4923-9D02-3FC04AB979F5}"/>
+                <a16:creationId xmlns:a16="http://schemas.microsoft.com/office/drawing/2014/main" id="{57A6E3C4-3523-4FF1-B412-3DF71AAB53FE}"/>
               </a:ext>
             </a:extLst>
           </p:cNvPr>
@@ -12452,7 +12452,7 @@
           <p:cNvPr id="6" name="Sam verkoopt in beide gevallen 60 kg per dag.">
             <a:extLst xmlns:a="http://schemas.openxmlformats.org/drawingml/2006/main">
               <a:ext uri="{FF2B5EF4-FFF2-40B4-BE49-F238E27FC236}">
-                <a16:creationId xmlns:a16="http://schemas.microsoft.com/office/drawing/2014/main" id="{FAE3AB00-13C0-4B1D-B469-4243A9609F4D}"/>
+                <a16:creationId xmlns:a16="http://schemas.microsoft.com/office/drawing/2014/main" id="{007346EE-1868-46D5-946E-3526F0A2F0EF}"/>
               </a:ext>
             </a:extLst>
           </p:cNvPr>
@@ -12681,7 +12681,7 @@
           <p:cNvPr id="8" name="TO daalt € 15. De kosten bij dezelfde q blijven gelijk.">
             <a:extLst xmlns:a="http://schemas.openxmlformats.org/drawingml/2006/main">
               <a:ext uri="{FF2B5EF4-FFF2-40B4-BE49-F238E27FC236}">
-                <a16:creationId xmlns:a16="http://schemas.microsoft.com/office/drawing/2014/main" id="{0CE89794-89D1-48A9-8762-28CEF95B0138}"/>
+                <a16:creationId xmlns:a16="http://schemas.microsoft.com/office/drawing/2014/main" id="{C2A7E86F-B667-43C4-9783-87064058F1DE}"/>
               </a:ext>
             </a:extLst>
           </p:cNvPr>
@@ -12738,7 +12738,7 @@
           <p:cNvPr id="9" name="De winst daalt dus € 15 per dag.">
             <a:extLst xmlns:a="http://schemas.openxmlformats.org/drawingml/2006/main">
               <a:ext uri="{FF2B5EF4-FFF2-40B4-BE49-F238E27FC236}">
-                <a16:creationId xmlns:a16="http://schemas.microsoft.com/office/drawing/2014/main" id="{97AADFD2-4D8C-4617-A163-279797F484D4}"/>
+                <a16:creationId xmlns:a16="http://schemas.microsoft.com/office/drawing/2014/main" id="{EC3B899A-AAC8-4958-BB22-E22A04E693C5}"/>
               </a:ext>
             </a:extLst>
           </p:cNvPr>
@@ -12793,7 +12793,7 @@
     </p:spTree>
     <p:extLst>
       <p:ext uri="{BB962C8B-B14F-4D97-AF65-F5344CB8AC3E}">
-        <p14:creationId xmlns:p14="http://schemas.microsoft.com/office/powerpoint/2010/main" val="2095166545"/>
+        <p14:creationId xmlns:p14="http://schemas.microsoft.com/office/powerpoint/2010/main" val="1802438472"/>
       </p:ext>
     </p:extLst>
   </p:cSld>
@@ -12824,7 +12824,7 @@
           <p:cNvPr id="8" name="Wanneer past het model?">
             <a:extLst xmlns:a="http://schemas.openxmlformats.org/drawingml/2006/main">
               <a:ext uri="{FF2B5EF4-FFF2-40B4-BE49-F238E27FC236}">
-                <a16:creationId xmlns:a16="http://schemas.microsoft.com/office/drawing/2014/main" id="{C7C6ECA6-4B63-4A6D-B4F2-6EA7807E3A71}"/>
+                <a16:creationId xmlns:a16="http://schemas.microsoft.com/office/drawing/2014/main" id="{B0974DAA-DFB3-4122-B6FC-0E95C0B2BC78}"/>
               </a:ext>
             </a:extLst>
           </p:cNvPr>
@@ -12881,7 +12881,7 @@
           <p:cNvPr id="2" name="">
             <a:extLst xmlns:a="http://schemas.openxmlformats.org/drawingml/2006/main">
               <a:ext uri="{FF2B5EF4-FFF2-40B4-BE49-F238E27FC236}">
-                <a16:creationId xmlns:a16="http://schemas.microsoft.com/office/drawing/2014/main" id="{57835389-21E8-4990-941F-C8524361CE7C}"/>
+                <a16:creationId xmlns:a16="http://schemas.microsoft.com/office/drawing/2014/main" id="{1AAFCBB9-17DC-4EA0-B10C-3EAC320C41BA}"/>
               </a:ext>
             </a:extLst>
           </p:cNvPr>
@@ -12910,7 +12910,7 @@
           <p:cNvPr id="3" name="§3.2.1 Volkomen concurrentie">
             <a:extLst xmlns:a="http://schemas.openxmlformats.org/drawingml/2006/main">
               <a:ext uri="{FF2B5EF4-FFF2-40B4-BE49-F238E27FC236}">
-                <a16:creationId xmlns:a16="http://schemas.microsoft.com/office/drawing/2014/main" id="{53722FD8-2375-4BF4-958C-A855F7C47E49}"/>
+                <a16:creationId xmlns:a16="http://schemas.microsoft.com/office/drawing/2014/main" id="{DE5C5DC3-A286-474F-9D8E-5B12483F8B26}"/>
               </a:ext>
             </a:extLst>
           </p:cNvPr>
@@ -12967,7 +12967,7 @@
           <p:cNvPr id="4" name="13">
             <a:extLst xmlns:a="http://schemas.openxmlformats.org/drawingml/2006/main">
               <a:ext uri="{FF2B5EF4-FFF2-40B4-BE49-F238E27FC236}">
-                <a16:creationId xmlns:a16="http://schemas.microsoft.com/office/drawing/2014/main" id="{751C478D-2397-4A10-897A-3CE3E55B8B8D}"/>
+                <a16:creationId xmlns:a16="http://schemas.microsoft.com/office/drawing/2014/main" id="{08212EC3-9A0F-49E6-A9B1-BD4D1B86C4A8}"/>
               </a:ext>
             </a:extLst>
           </p:cNvPr>
@@ -13024,7 +13024,7 @@
           <p:cNvPr id="5" name="Uitlegvoorbeeld — niet uit het boek">
             <a:extLst xmlns:a="http://schemas.openxmlformats.org/drawingml/2006/main">
               <a:ext uri="{FF2B5EF4-FFF2-40B4-BE49-F238E27FC236}">
-                <a16:creationId xmlns:a16="http://schemas.microsoft.com/office/drawing/2014/main" id="{2EEA7209-EA14-4105-94FF-E6AA51F39C1E}"/>
+                <a16:creationId xmlns:a16="http://schemas.microsoft.com/office/drawing/2014/main" id="{DB78142B-38CA-4209-9916-08498AACBB92}"/>
               </a:ext>
             </a:extLst>
           </p:cNvPr>
@@ -13253,7 +13253,7 @@
           <p:cNvPr id="7" name="Een andere modelaanname vraagt om een nieuwe beoordeling.">
             <a:extLst xmlns:a="http://schemas.openxmlformats.org/drawingml/2006/main">
               <a:ext uri="{FF2B5EF4-FFF2-40B4-BE49-F238E27FC236}">
-                <a16:creationId xmlns:a16="http://schemas.microsoft.com/office/drawing/2014/main" id="{DE1B0F35-58DE-4A9B-8AD4-DE1260EE060B}"/>
+                <a16:creationId xmlns:a16="http://schemas.microsoft.com/office/drawing/2014/main" id="{F02D3DE0-A612-47FC-9725-C89DB2052387}"/>
               </a:ext>
             </a:extLst>
           </p:cNvPr>
@@ -13308,7 +13308,7 @@
     </p:spTree>
     <p:extLst>
       <p:ext uri="{BB962C8B-B14F-4D97-AF65-F5344CB8AC3E}">
-        <p14:creationId xmlns:p14="http://schemas.microsoft.com/office/powerpoint/2010/main" val="637202793"/>
+        <p14:creationId xmlns:p14="http://schemas.microsoft.com/office/powerpoint/2010/main" val="618109563"/>
       </p:ext>
     </p:extLst>
   </p:cSld>
@@ -13339,7 +13339,7 @@
           <p:cNvPr id="10" name="Korte check bij het uitlegvoorbeeld">
             <a:extLst xmlns:a="http://schemas.openxmlformats.org/drawingml/2006/main">
               <a:ext uri="{FF2B5EF4-FFF2-40B4-BE49-F238E27FC236}">
-                <a16:creationId xmlns:a16="http://schemas.microsoft.com/office/drawing/2014/main" id="{47320D86-EA7F-4C24-8BE2-7398DEF2A55D}"/>
+                <a16:creationId xmlns:a16="http://schemas.microsoft.com/office/drawing/2014/main" id="{FEF9CA7F-67ED-4A08-9606-CC30682E4EDF}"/>
               </a:ext>
             </a:extLst>
           </p:cNvPr>
@@ -13396,7 +13396,7 @@
           <p:cNvPr id="2" name="">
             <a:extLst xmlns:a="http://schemas.openxmlformats.org/drawingml/2006/main">
               <a:ext uri="{FF2B5EF4-FFF2-40B4-BE49-F238E27FC236}">
-                <a16:creationId xmlns:a16="http://schemas.microsoft.com/office/drawing/2014/main" id="{6E5EF123-9293-4F00-9A0A-99F901228C8F}"/>
+                <a16:creationId xmlns:a16="http://schemas.microsoft.com/office/drawing/2014/main" id="{CC3F91EC-F4AD-41D6-BE99-B307C8264648}"/>
               </a:ext>
             </a:extLst>
           </p:cNvPr>
@@ -13425,7 +13425,7 @@
           <p:cNvPr id="3" name="§3.2.1 Volkomen concurrentie">
             <a:extLst xmlns:a="http://schemas.openxmlformats.org/drawingml/2006/main">
               <a:ext uri="{FF2B5EF4-FFF2-40B4-BE49-F238E27FC236}">
-                <a16:creationId xmlns:a16="http://schemas.microsoft.com/office/drawing/2014/main" id="{D79D8C5F-6294-488E-A8D5-F2BD3938CE90}"/>
+                <a16:creationId xmlns:a16="http://schemas.microsoft.com/office/drawing/2014/main" id="{BD44CED9-2C41-4ABA-9113-B9DDF6B530C5}"/>
               </a:ext>
             </a:extLst>
           </p:cNvPr>
@@ -13482,7 +13482,7 @@
           <p:cNvPr id="4" name="14">
             <a:extLst xmlns:a="http://schemas.openxmlformats.org/drawingml/2006/main">
               <a:ext uri="{FF2B5EF4-FFF2-40B4-BE49-F238E27FC236}">
-                <a16:creationId xmlns:a16="http://schemas.microsoft.com/office/drawing/2014/main" id="{0A9D478A-559B-4D6F-880E-CAEE63033BC8}"/>
+                <a16:creationId xmlns:a16="http://schemas.microsoft.com/office/drawing/2014/main" id="{C379F71B-9E25-4EFA-8FBD-0A97A4EFF2AF}"/>
               </a:ext>
             </a:extLst>
           </p:cNvPr>
@@ -13539,7 +13539,7 @@
           <p:cNvPr id="5" name="Uitlegvoorbeeld — niet uit het boek">
             <a:extLst xmlns:a="http://schemas.openxmlformats.org/drawingml/2006/main">
               <a:ext uri="{FF2B5EF4-FFF2-40B4-BE49-F238E27FC236}">
-                <a16:creationId xmlns:a16="http://schemas.microsoft.com/office/drawing/2014/main" id="{F18BFBA1-4A55-4C93-BF6E-C82F4B724C35}"/>
+                <a16:creationId xmlns:a16="http://schemas.microsoft.com/office/drawing/2014/main" id="{E54A346D-83BA-4AB3-925B-06C33D79717E}"/>
               </a:ext>
             </a:extLst>
           </p:cNvPr>
@@ -13596,7 +13596,7 @@
           <p:cNvPr id="6" name="Sam verkoopt nu 100 kg per dag voor € 2,50 per kg.">
             <a:extLst xmlns:a="http://schemas.openxmlformats.org/drawingml/2006/main">
               <a:ext uri="{FF2B5EF4-FFF2-40B4-BE49-F238E27FC236}">
-                <a16:creationId xmlns:a16="http://schemas.microsoft.com/office/drawing/2014/main" id="{DB426C84-94BD-4B08-B7B6-18B2123ACB14}"/>
+                <a16:creationId xmlns:a16="http://schemas.microsoft.com/office/drawing/2014/main" id="{F1C22728-4318-4C8B-AAD9-19CD8DD8FFA8}"/>
               </a:ext>
             </a:extLst>
           </p:cNvPr>
@@ -13653,7 +13653,7 @@
           <p:cNvPr id="7" name="Wat zijn TO en GO, inclusief eenheid?">
             <a:extLst xmlns:a="http://schemas.openxmlformats.org/drawingml/2006/main">
               <a:ext uri="{FF2B5EF4-FFF2-40B4-BE49-F238E27FC236}">
-                <a16:creationId xmlns:a16="http://schemas.microsoft.com/office/drawing/2014/main" id="{E52B96EC-4FC5-4091-B886-82433F092750}"/>
+                <a16:creationId xmlns:a16="http://schemas.microsoft.com/office/drawing/2014/main" id="{C109AB9C-5C11-4D21-A8A4-FCE837D0DBF7}"/>
               </a:ext>
             </a:extLst>
           </p:cNvPr>
@@ -13710,7 +13710,7 @@
           <p:cNvPr id="8" name="Wat is MO als Sam daarna 10 kg extra verkoopt?">
             <a:extLst xmlns:a="http://schemas.openxmlformats.org/drawingml/2006/main">
               <a:ext uri="{FF2B5EF4-FFF2-40B4-BE49-F238E27FC236}">
-                <a16:creationId xmlns:a16="http://schemas.microsoft.com/office/drawing/2014/main" id="{9895D7DE-D2EE-4D54-81BE-8DC191A2E1F7}"/>
+                <a16:creationId xmlns:a16="http://schemas.microsoft.com/office/drawing/2014/main" id="{663393FE-7BD6-4398-A2E7-16CA9BDECB11}"/>
               </a:ext>
             </a:extLst>
           </p:cNvPr>
@@ -13767,7 +13767,7 @@
           <p:cNvPr id="9" name="Welke hoeveelheid hoort links: Q of q?">
             <a:extLst xmlns:a="http://schemas.openxmlformats.org/drawingml/2006/main">
               <a:ext uri="{FF2B5EF4-FFF2-40B4-BE49-F238E27FC236}">
-                <a16:creationId xmlns:a16="http://schemas.microsoft.com/office/drawing/2014/main" id="{A4528BDE-1B0E-4272-BFDB-1653411B4A4B}"/>
+                <a16:creationId xmlns:a16="http://schemas.microsoft.com/office/drawing/2014/main" id="{670321B8-5787-4479-AAEA-C09D66C2BA42}"/>
               </a:ext>
             </a:extLst>
           </p:cNvPr>
@@ -13822,7 +13822,7 @@
     </p:spTree>
     <p:extLst>
       <p:ext uri="{BB962C8B-B14F-4D97-AF65-F5344CB8AC3E}">
-        <p14:creationId xmlns:p14="http://schemas.microsoft.com/office/powerpoint/2010/main" val="1224383267"/>
+        <p14:creationId xmlns:p14="http://schemas.microsoft.com/office/powerpoint/2010/main" val="1310050818"/>
       </p:ext>
     </p:extLst>
   </p:cSld>
@@ -13850,10 +13850,10 @@
       </p:grpSpPr>
       <p:sp>
         <p:nvSpPr>
-          <p:cNvPr id="29" name="Deze les: §3.2.1 Volkomen concurrentie">
+          <p:cNvPr id="29" name="Deze les: §3.2.1 Volkomen concurrentie: kenmerken">
             <a:extLst xmlns:a="http://schemas.openxmlformats.org/drawingml/2006/main">
               <a:ext uri="{FF2B5EF4-FFF2-40B4-BE49-F238E27FC236}">
-                <a16:creationId xmlns:a16="http://schemas.microsoft.com/office/drawing/2014/main" id="{CCA369EA-3438-441A-94A5-3F12712AA6B9}"/>
+                <a16:creationId xmlns:a16="http://schemas.microsoft.com/office/drawing/2014/main" id="{F3B2A1E9-5C4D-47D0-9EF1-9565F6FB973B}"/>
               </a:ext>
             </a:extLst>
           </p:cNvPr>
@@ -13900,7 +13900,7 @@
                 <a:ea typeface="Arial"/>
                 <a:cs typeface="Arial"/>
               </a:rPr>
-              <a:t>Deze les: §3.2.1 Volkomen concurrentie</a:t>
+              <a:t>Deze les: §3.2.1 Volkomen concurrentie: kenmerken</a:t>
             </a:r>
           </a:p>
         </p:txBody>
@@ -13910,7 +13910,7 @@
           <p:cNvPr id="2" name="">
             <a:extLst xmlns:a="http://schemas.openxmlformats.org/drawingml/2006/main">
               <a:ext uri="{FF2B5EF4-FFF2-40B4-BE49-F238E27FC236}">
-                <a16:creationId xmlns:a16="http://schemas.microsoft.com/office/drawing/2014/main" id="{6F522DF8-2A47-482A-B6B9-B30AF7EBC1D4}"/>
+                <a16:creationId xmlns:a16="http://schemas.microsoft.com/office/drawing/2014/main" id="{06CE1C2D-A1BF-41CD-B82C-57B0862F61B5}"/>
               </a:ext>
             </a:extLst>
           </p:cNvPr>
@@ -13939,7 +13939,7 @@
           <p:cNvPr id="3" name="§3.2.1 Volkomen concurrentie">
             <a:extLst xmlns:a="http://schemas.openxmlformats.org/drawingml/2006/main">
               <a:ext uri="{FF2B5EF4-FFF2-40B4-BE49-F238E27FC236}">
-                <a16:creationId xmlns:a16="http://schemas.microsoft.com/office/drawing/2014/main" id="{1BE7EA12-9609-4B66-8CD6-E17C3D6BF147}"/>
+                <a16:creationId xmlns:a16="http://schemas.microsoft.com/office/drawing/2014/main" id="{069F20F9-05FB-4C26-B5A4-3E52B19D149B}"/>
               </a:ext>
             </a:extLst>
           </p:cNvPr>
@@ -13996,7 +13996,7 @@
           <p:cNvPr id="4" name="15">
             <a:extLst xmlns:a="http://schemas.openxmlformats.org/drawingml/2006/main">
               <a:ext uri="{FF2B5EF4-FFF2-40B4-BE49-F238E27FC236}">
-                <a16:creationId xmlns:a16="http://schemas.microsoft.com/office/drawing/2014/main" id="{8E0FC156-EF3D-4B34-8185-8F2106CB28CE}"/>
+                <a16:creationId xmlns:a16="http://schemas.microsoft.com/office/drawing/2014/main" id="{183EB99C-91B3-4825-992B-562E2A3CB968}"/>
               </a:ext>
             </a:extLst>
           </p:cNvPr>
@@ -14053,7 +14053,7 @@
           <p:cNvPr id="5" name="phase">
             <a:extLst xmlns:a="http://schemas.openxmlformats.org/drawingml/2006/main">
               <a:ext uri="{FF2B5EF4-FFF2-40B4-BE49-F238E27FC236}">
-                <a16:creationId xmlns:a16="http://schemas.microsoft.com/office/drawing/2014/main" id="{1D91C769-2CFA-436F-99AC-4C33AF150838}"/>
+                <a16:creationId xmlns:a16="http://schemas.microsoft.com/office/drawing/2014/main" id="{CEACABC2-39B7-40D4-B98B-77B6E4EA3CD5}"/>
               </a:ext>
             </a:extLst>
           </p:cNvPr>
@@ -14110,7 +14110,7 @@
           <p:cNvPr id="6" name="Lesroute">
             <a:extLst xmlns:a="http://schemas.openxmlformats.org/drawingml/2006/main">
               <a:ext uri="{FF2B5EF4-FFF2-40B4-BE49-F238E27FC236}">
-                <a16:creationId xmlns:a16="http://schemas.microsoft.com/office/drawing/2014/main" id="{73112ECF-F416-4D8F-9B27-E0F6B3A04124}"/>
+                <a16:creationId xmlns:a16="http://schemas.microsoft.com/office/drawing/2014/main" id="{5441D519-2233-4A20-AC29-9A4EC396DB7F}"/>
               </a:ext>
             </a:extLst>
           </p:cNvPr>
@@ -14167,7 +14167,7 @@
           <p:cNvPr id="7" name="route-number-1">
             <a:extLst xmlns:a="http://schemas.openxmlformats.org/drawingml/2006/main">
               <a:ext uri="{FF2B5EF4-FFF2-40B4-BE49-F238E27FC236}">
-                <a16:creationId xmlns:a16="http://schemas.microsoft.com/office/drawing/2014/main" id="{D6B20814-A1AC-4278-B8CC-0BDA7FDE369B}"/>
+                <a16:creationId xmlns:a16="http://schemas.microsoft.com/office/drawing/2014/main" id="{F32A5156-3F7F-4F5B-BB2D-58D090944587}"/>
               </a:ext>
             </a:extLst>
           </p:cNvPr>
@@ -14224,7 +14224,7 @@
           <p:cNvPr id="8" name="route-1">
             <a:extLst xmlns:a="http://schemas.openxmlformats.org/drawingml/2006/main">
               <a:ext uri="{FF2B5EF4-FFF2-40B4-BE49-F238E27FC236}">
-                <a16:creationId xmlns:a16="http://schemas.microsoft.com/office/drawing/2014/main" id="{E4FAC528-B6B8-45C1-8485-4BB4BF46465D}"/>
+                <a16:creationId xmlns:a16="http://schemas.microsoft.com/office/drawing/2014/main" id="{36002FA6-9979-4DE6-966D-BB3FECD065EB}"/>
               </a:ext>
             </a:extLst>
           </p:cNvPr>
@@ -14281,7 +14281,7 @@
           <p:cNvPr id="9" name="route-number-2">
             <a:extLst xmlns:a="http://schemas.openxmlformats.org/drawingml/2006/main">
               <a:ext uri="{FF2B5EF4-FFF2-40B4-BE49-F238E27FC236}">
-                <a16:creationId xmlns:a16="http://schemas.microsoft.com/office/drawing/2014/main" id="{AFDB3299-6F6E-470B-A38E-F5A20BFC90D9}"/>
+                <a16:creationId xmlns:a16="http://schemas.microsoft.com/office/drawing/2014/main" id="{8B807256-4240-4248-B509-402B15330336}"/>
               </a:ext>
             </a:extLst>
           </p:cNvPr>
@@ -14338,7 +14338,7 @@
           <p:cNvPr id="10" name="route-2">
             <a:extLst xmlns:a="http://schemas.openxmlformats.org/drawingml/2006/main">
               <a:ext uri="{FF2B5EF4-FFF2-40B4-BE49-F238E27FC236}">
-                <a16:creationId xmlns:a16="http://schemas.microsoft.com/office/drawing/2014/main" id="{C0FB0277-26A8-4F35-85D1-4134122CB933}"/>
+                <a16:creationId xmlns:a16="http://schemas.microsoft.com/office/drawing/2014/main" id="{050A86BC-E677-43FC-AA7F-E3E4A246CF73}"/>
               </a:ext>
             </a:extLst>
           </p:cNvPr>
@@ -14395,7 +14395,7 @@
           <p:cNvPr id="11" name="route-number-3">
             <a:extLst xmlns:a="http://schemas.openxmlformats.org/drawingml/2006/main">
               <a:ext uri="{FF2B5EF4-FFF2-40B4-BE49-F238E27FC236}">
-                <a16:creationId xmlns:a16="http://schemas.microsoft.com/office/drawing/2014/main" id="{53FE7B2B-DF56-42D9-A5F1-95ED161BFEC1}"/>
+                <a16:creationId xmlns:a16="http://schemas.microsoft.com/office/drawing/2014/main" id="{A55C6476-D3E7-4B2B-A8C3-7DAF558181F0}"/>
               </a:ext>
             </a:extLst>
           </p:cNvPr>
@@ -14452,7 +14452,7 @@
           <p:cNvPr id="12" name="route-3">
             <a:extLst xmlns:a="http://schemas.openxmlformats.org/drawingml/2006/main">
               <a:ext uri="{FF2B5EF4-FFF2-40B4-BE49-F238E27FC236}">
-                <a16:creationId xmlns:a16="http://schemas.microsoft.com/office/drawing/2014/main" id="{66181E2F-312A-49C5-9639-2C95DCA082C7}"/>
+                <a16:creationId xmlns:a16="http://schemas.microsoft.com/office/drawing/2014/main" id="{6BF68469-F7A1-477E-8E23-4F6D607C7E6B}"/>
               </a:ext>
             </a:extLst>
           </p:cNvPr>
@@ -14509,7 +14509,7 @@
           <p:cNvPr id="13" name="route-number-4">
             <a:extLst xmlns:a="http://schemas.openxmlformats.org/drawingml/2006/main">
               <a:ext uri="{FF2B5EF4-FFF2-40B4-BE49-F238E27FC236}">
-                <a16:creationId xmlns:a16="http://schemas.microsoft.com/office/drawing/2014/main" id="{67D35F53-D27A-4005-8E69-46F98CE13BB3}"/>
+                <a16:creationId xmlns:a16="http://schemas.microsoft.com/office/drawing/2014/main" id="{F8D2F9A8-816B-4714-A683-6316755FE4A2}"/>
               </a:ext>
             </a:extLst>
           </p:cNvPr>
@@ -14566,7 +14566,7 @@
           <p:cNvPr id="14" name="route-4">
             <a:extLst xmlns:a="http://schemas.openxmlformats.org/drawingml/2006/main">
               <a:ext uri="{FF2B5EF4-FFF2-40B4-BE49-F238E27FC236}">
-                <a16:creationId xmlns:a16="http://schemas.microsoft.com/office/drawing/2014/main" id="{91C9195C-64B7-4D02-896D-86771544CB8A}"/>
+                <a16:creationId xmlns:a16="http://schemas.microsoft.com/office/drawing/2014/main" id="{03A764EB-E9A2-4984-9E5A-46B69038ED6F}"/>
               </a:ext>
             </a:extLst>
           </p:cNvPr>
@@ -14623,7 +14623,7 @@
           <p:cNvPr id="15" name="route-number-5">
             <a:extLst xmlns:a="http://schemas.openxmlformats.org/drawingml/2006/main">
               <a:ext uri="{FF2B5EF4-FFF2-40B4-BE49-F238E27FC236}">
-                <a16:creationId xmlns:a16="http://schemas.microsoft.com/office/drawing/2014/main" id="{0398CAA6-4667-446A-BE4F-871D05F0658B}"/>
+                <a16:creationId xmlns:a16="http://schemas.microsoft.com/office/drawing/2014/main" id="{5D90F767-ECEC-410B-9B13-F9D4EF69BAA9}"/>
               </a:ext>
             </a:extLst>
           </p:cNvPr>
@@ -14680,7 +14680,7 @@
           <p:cNvPr id="16" name="route-5">
             <a:extLst xmlns:a="http://schemas.openxmlformats.org/drawingml/2006/main">
               <a:ext uri="{FF2B5EF4-FFF2-40B4-BE49-F238E27FC236}">
-                <a16:creationId xmlns:a16="http://schemas.microsoft.com/office/drawing/2014/main" id="{3D74271A-7BC3-44D5-81E8-DECB1C916CB2}"/>
+                <a16:creationId xmlns:a16="http://schemas.microsoft.com/office/drawing/2014/main" id="{36712C30-D6E9-463A-B582-EFC1F51DFAF6}"/>
               </a:ext>
             </a:extLst>
           </p:cNvPr>
@@ -14737,7 +14737,7 @@
           <p:cNvPr id="17" name="route-number-6">
             <a:extLst xmlns:a="http://schemas.openxmlformats.org/drawingml/2006/main">
               <a:ext uri="{FF2B5EF4-FFF2-40B4-BE49-F238E27FC236}">
-                <a16:creationId xmlns:a16="http://schemas.microsoft.com/office/drawing/2014/main" id="{2B204A5E-80DA-4BA0-B864-2876B3C15514}"/>
+                <a16:creationId xmlns:a16="http://schemas.microsoft.com/office/drawing/2014/main" id="{0455BFCC-F261-434D-BD9A-204C0D2C17E1}"/>
               </a:ext>
             </a:extLst>
           </p:cNvPr>
@@ -14794,7 +14794,7 @@
           <p:cNvPr id="18" name="route-6">
             <a:extLst xmlns:a="http://schemas.openxmlformats.org/drawingml/2006/main">
               <a:ext uri="{FF2B5EF4-FFF2-40B4-BE49-F238E27FC236}">
-                <a16:creationId xmlns:a16="http://schemas.microsoft.com/office/drawing/2014/main" id="{FB495A01-C438-4344-A937-5255C33F456A}"/>
+                <a16:creationId xmlns:a16="http://schemas.microsoft.com/office/drawing/2014/main" id="{82897A9D-2E29-476C-AD50-E05DAB940CF9}"/>
               </a:ext>
             </a:extLst>
           </p:cNvPr>
@@ -14851,7 +14851,7 @@
           <p:cNvPr id="19" name="route-number-7">
             <a:extLst xmlns:a="http://schemas.openxmlformats.org/drawingml/2006/main">
               <a:ext uri="{FF2B5EF4-FFF2-40B4-BE49-F238E27FC236}">
-                <a16:creationId xmlns:a16="http://schemas.microsoft.com/office/drawing/2014/main" id="{028A6588-380C-47BF-A3D5-AE50DB395FC3}"/>
+                <a16:creationId xmlns:a16="http://schemas.microsoft.com/office/drawing/2014/main" id="{2E689365-3EE4-4BA9-9561-75F7D0FA049F}"/>
               </a:ext>
             </a:extLst>
           </p:cNvPr>
@@ -14908,7 +14908,7 @@
           <p:cNvPr id="20" name="route-7">
             <a:extLst xmlns:a="http://schemas.openxmlformats.org/drawingml/2006/main">
               <a:ext uri="{FF2B5EF4-FFF2-40B4-BE49-F238E27FC236}">
-                <a16:creationId xmlns:a16="http://schemas.microsoft.com/office/drawing/2014/main" id="{992A48B0-349F-4762-B7B6-A97D4B8B39E6}"/>
+                <a16:creationId xmlns:a16="http://schemas.microsoft.com/office/drawing/2014/main" id="{B1EDEB59-A417-4033-8B8D-07FF75DE8D27}"/>
               </a:ext>
             </a:extLst>
           </p:cNvPr>
@@ -14965,7 +14965,7 @@
           <p:cNvPr id="21" name="Lesdoelen">
             <a:extLst xmlns:a="http://schemas.openxmlformats.org/drawingml/2006/main">
               <a:ext uri="{FF2B5EF4-FFF2-40B4-BE49-F238E27FC236}">
-                <a16:creationId xmlns:a16="http://schemas.microsoft.com/office/drawing/2014/main" id="{34AB5625-7B4F-4A5E-9320-2B316CA0DE7F}"/>
+                <a16:creationId xmlns:a16="http://schemas.microsoft.com/office/drawing/2014/main" id="{2D3FC250-9B3C-4F76-A2C9-D68A724F57F9}"/>
               </a:ext>
             </a:extLst>
           </p:cNvPr>
@@ -15022,7 +15022,7 @@
           <p:cNvPr id="22" name="overview-goals">
             <a:extLst xmlns:a="http://schemas.openxmlformats.org/drawingml/2006/main">
               <a:ext uri="{FF2B5EF4-FFF2-40B4-BE49-F238E27FC236}">
-                <a16:creationId xmlns:a16="http://schemas.microsoft.com/office/drawing/2014/main" id="{FCF6156F-C913-4CB6-A0A1-94F973D024D0}"/>
+                <a16:creationId xmlns:a16="http://schemas.microsoft.com/office/drawing/2014/main" id="{4A10C90D-5D19-4D6D-B12A-988CECF51A00}"/>
               </a:ext>
             </a:extLst>
           </p:cNvPr>
@@ -15148,7 +15148,7 @@
           <p:cNvPr id="23" name="">
             <a:extLst xmlns:a="http://schemas.openxmlformats.org/drawingml/2006/main">
               <a:ext uri="{FF2B5EF4-FFF2-40B4-BE49-F238E27FC236}">
-                <a16:creationId xmlns:a16="http://schemas.microsoft.com/office/drawing/2014/main" id="{63CA9870-A698-4FF8-B49F-5A74B6BD437C}"/>
+                <a16:creationId xmlns:a16="http://schemas.microsoft.com/office/drawing/2014/main" id="{9C4AA7F2-D033-4CE9-86E4-A590B35F1E8C}"/>
               </a:ext>
             </a:extLst>
           </p:cNvPr>
@@ -15177,7 +15177,7 @@
           <p:cNvPr id="24" name="Startopdracht">
             <a:extLst xmlns:a="http://schemas.openxmlformats.org/drawingml/2006/main">
               <a:ext uri="{FF2B5EF4-FFF2-40B4-BE49-F238E27FC236}">
-                <a16:creationId xmlns:a16="http://schemas.microsoft.com/office/drawing/2014/main" id="{FC294DC3-F92E-48F2-9BEB-EA3167CBC956}"/>
+                <a16:creationId xmlns:a16="http://schemas.microsoft.com/office/drawing/2014/main" id="{9EEC021F-4D43-4595-BB27-8104629CD6C8}"/>
               </a:ext>
             </a:extLst>
           </p:cNvPr>
@@ -15234,7 +15234,7 @@
           <p:cNvPr id="25" name="overview-start">
             <a:extLst xmlns:a="http://schemas.openxmlformats.org/drawingml/2006/main">
               <a:ext uri="{FF2B5EF4-FFF2-40B4-BE49-F238E27FC236}">
-                <a16:creationId xmlns:a16="http://schemas.microsoft.com/office/drawing/2014/main" id="{B1D078E4-0CED-4861-B4F5-5BF777D00C03}"/>
+                <a16:creationId xmlns:a16="http://schemas.microsoft.com/office/drawing/2014/main" id="{CD960301-ABE1-44B9-B97A-1A50146C52BD}"/>
               </a:ext>
             </a:extLst>
           </p:cNvPr>
@@ -15337,7 +15337,7 @@
           <p:cNvPr id="26" name="">
             <a:extLst xmlns:a="http://schemas.openxmlformats.org/drawingml/2006/main">
               <a:ext uri="{FF2B5EF4-FFF2-40B4-BE49-F238E27FC236}">
-                <a16:creationId xmlns:a16="http://schemas.microsoft.com/office/drawing/2014/main" id="{5597DCB5-69B5-4152-9DD7-E1871FF79047}"/>
+                <a16:creationId xmlns:a16="http://schemas.microsoft.com/office/drawing/2014/main" id="{3F999F3D-206D-42C4-AF14-49ABA3637604}"/>
               </a:ext>
             </a:extLst>
           </p:cNvPr>
@@ -15366,7 +15366,7 @@
           <p:cNvPr id="27" name="Huiswerk">
             <a:extLst xmlns:a="http://schemas.openxmlformats.org/drawingml/2006/main">
               <a:ext uri="{FF2B5EF4-FFF2-40B4-BE49-F238E27FC236}">
-                <a16:creationId xmlns:a16="http://schemas.microsoft.com/office/drawing/2014/main" id="{D4557266-6EA0-4A7A-8737-B3BBBF29D6BC}"/>
+                <a16:creationId xmlns:a16="http://schemas.microsoft.com/office/drawing/2014/main" id="{32B3F26E-F257-4DE4-A65F-0044EF5F6C87}"/>
               </a:ext>
             </a:extLst>
           </p:cNvPr>
@@ -15423,7 +15423,7 @@
           <p:cNvPr id="28" name="overview-homework">
             <a:extLst xmlns:a="http://schemas.openxmlformats.org/drawingml/2006/main">
               <a:ext uri="{FF2B5EF4-FFF2-40B4-BE49-F238E27FC236}">
-                <a16:creationId xmlns:a16="http://schemas.microsoft.com/office/drawing/2014/main" id="{618E7A3C-292A-441C-B451-2474D12EFC9F}"/>
+                <a16:creationId xmlns:a16="http://schemas.microsoft.com/office/drawing/2014/main" id="{FE6D8ECD-281B-4C39-A73E-5667882A286D}"/>
               </a:ext>
             </a:extLst>
           </p:cNvPr>
@@ -15570,7 +15570,7 @@
     </p:spTree>
     <p:extLst>
       <p:ext uri="{BB962C8B-B14F-4D97-AF65-F5344CB8AC3E}">
-        <p14:creationId xmlns:p14="http://schemas.microsoft.com/office/powerpoint/2010/main" val="2024564010"/>
+        <p14:creationId xmlns:p14="http://schemas.microsoft.com/office/powerpoint/2010/main" val="1718483736"/>
       </p:ext>
     </p:extLst>
   </p:cSld>
@@ -15601,7 +15601,7 @@
           <p:cNvPr id="11" name="Doelopgave 7: Wortelveiling">
             <a:extLst xmlns:a="http://schemas.openxmlformats.org/drawingml/2006/main">
               <a:ext uri="{FF2B5EF4-FFF2-40B4-BE49-F238E27FC236}">
-                <a16:creationId xmlns:a16="http://schemas.microsoft.com/office/drawing/2014/main" id="{4579E5F3-9616-4632-ACB4-93DD1E81AEBD}"/>
+                <a16:creationId xmlns:a16="http://schemas.microsoft.com/office/drawing/2014/main" id="{EA51EB88-0B4B-4220-AE8B-CD8C5418D799}"/>
               </a:ext>
             </a:extLst>
           </p:cNvPr>
@@ -15658,7 +15658,7 @@
           <p:cNvPr id="2" name="">
             <a:extLst xmlns:a="http://schemas.openxmlformats.org/drawingml/2006/main">
               <a:ext uri="{FF2B5EF4-FFF2-40B4-BE49-F238E27FC236}">
-                <a16:creationId xmlns:a16="http://schemas.microsoft.com/office/drawing/2014/main" id="{9ED10396-3165-4160-9B40-DAA640C5AFBD}"/>
+                <a16:creationId xmlns:a16="http://schemas.microsoft.com/office/drawing/2014/main" id="{8355A591-1413-4A52-B379-469524E999EF}"/>
               </a:ext>
             </a:extLst>
           </p:cNvPr>
@@ -15687,7 +15687,7 @@
           <p:cNvPr id="3" name="§3.2.1 Volkomen concurrentie · Opgave 7 · Boekpagina 60">
             <a:extLst xmlns:a="http://schemas.openxmlformats.org/drawingml/2006/main">
               <a:ext uri="{FF2B5EF4-FFF2-40B4-BE49-F238E27FC236}">
-                <a16:creationId xmlns:a16="http://schemas.microsoft.com/office/drawing/2014/main" id="{FF1EC0ED-86BE-4C89-9445-54E049732E41}"/>
+                <a16:creationId xmlns:a16="http://schemas.microsoft.com/office/drawing/2014/main" id="{91D1DA93-8404-42AC-B95F-08F8CB3C5F41}"/>
               </a:ext>
             </a:extLst>
           </p:cNvPr>
@@ -15744,7 +15744,7 @@
           <p:cNvPr id="4" name="16">
             <a:extLst xmlns:a="http://schemas.openxmlformats.org/drawingml/2006/main">
               <a:ext uri="{FF2B5EF4-FFF2-40B4-BE49-F238E27FC236}">
-                <a16:creationId xmlns:a16="http://schemas.microsoft.com/office/drawing/2014/main" id="{EBBD7E52-5218-4CC6-9208-A35153C93F52}"/>
+                <a16:creationId xmlns:a16="http://schemas.microsoft.com/office/drawing/2014/main" id="{C19C2CE3-F2B1-40BC-827C-41D5ACB5A1A8}"/>
               </a:ext>
             </a:extLst>
           </p:cNvPr>
@@ -15801,7 +15801,7 @@
           <p:cNvPr id="5" name="Veel kleine telers bieden wortelen van dezelfde kwaliteit aan. Kopers ">
             <a:extLst xmlns:a="http://schemas.openxmlformats.org/drawingml/2006/main">
               <a:ext uri="{FF2B5EF4-FFF2-40B4-BE49-F238E27FC236}">
-                <a16:creationId xmlns:a16="http://schemas.microsoft.com/office/drawing/2014/main" id="{BD7407F9-556E-4844-828A-269FB356E51D}"/>
+                <a16:creationId xmlns:a16="http://schemas.microsoft.com/office/drawing/2014/main" id="{DD210114-378A-4D75-9C0B-6AD3E0EC6238}"/>
               </a:ext>
             </a:extLst>
           </p:cNvPr>
@@ -15858,7 +15858,7 @@
           <p:cNvPr id="6" name="De hele markt">
             <a:extLst xmlns:a="http://schemas.openxmlformats.org/drawingml/2006/main">
               <a:ext uri="{FF2B5EF4-FFF2-40B4-BE49-F238E27FC236}">
-                <a16:creationId xmlns:a16="http://schemas.microsoft.com/office/drawing/2014/main" id="{36D27465-50E3-4FC3-899B-2AAE6E7B487A}"/>
+                <a16:creationId xmlns:a16="http://schemas.microsoft.com/office/drawing/2014/main" id="{89F05871-7121-4AC7-A27C-C0ABE74ED25E}"/>
               </a:ext>
             </a:extLst>
           </p:cNvPr>
@@ -15915,7 +15915,7 @@
           <p:cNvPr id="7" name="Eén onderneming: Mila">
             <a:extLst xmlns:a="http://schemas.openxmlformats.org/drawingml/2006/main">
               <a:ext uri="{FF2B5EF4-FFF2-40B4-BE49-F238E27FC236}">
-                <a16:creationId xmlns:a16="http://schemas.microsoft.com/office/drawing/2014/main" id="{B8EA4997-9A84-463F-AC91-1F09923FD9D8}"/>
+                <a16:creationId xmlns:a16="http://schemas.microsoft.com/office/drawing/2014/main" id="{18B6E91A-2227-4020-BBFA-1A8A76976AD3}"/>
               </a:ext>
             </a:extLst>
           </p:cNvPr>
@@ -15979,7 +15979,7 @@
         </p:xfrm>
         <a:graphic xmlns:a="http://schemas.openxmlformats.org/drawingml/2006/main">
           <a:graphicData uri="http://schemas.openxmlformats.org/drawingml/2006/chart">
-            <c:chart xmlns:r="http://schemas.openxmlformats.org/officeDocument/2006/relationships" xmlns:c="http://schemas.openxmlformats.org/drawingml/2006/chart" r:id="R7febf1e3f9de4ca5"/>
+            <c:chart xmlns:r="http://schemas.openxmlformats.org/officeDocument/2006/relationships" xmlns:c="http://schemas.openxmlformats.org/drawingml/2006/chart" r:id="R01283381f9fb47c3"/>
           </a:graphicData>
         </a:graphic>
       </p:graphicFrame>
@@ -15995,7 +15995,7 @@
         </p:xfrm>
         <a:graphic xmlns:a="http://schemas.openxmlformats.org/drawingml/2006/main">
           <a:graphicData uri="http://schemas.openxmlformats.org/drawingml/2006/chart">
-            <c:chart xmlns:r="http://schemas.openxmlformats.org/officeDocument/2006/relationships" xmlns:c="http://schemas.openxmlformats.org/drawingml/2006/chart" r:id="R332adb2631d04eef"/>
+            <c:chart xmlns:r="http://schemas.openxmlformats.org/officeDocument/2006/relationships" xmlns:c="http://schemas.openxmlformats.org/drawingml/2006/chart" r:id="R77e43c44e9204cda"/>
           </a:graphicData>
         </a:graphic>
       </p:graphicFrame>
@@ -16004,7 +16004,7 @@
           <p:cNvPr id="10" name="Figuur 5. Vul alleen de ontbrekende lijn en labels in de ondernemingsg">
             <a:extLst xmlns:a="http://schemas.openxmlformats.org/drawingml/2006/main">
               <a:ext uri="{FF2B5EF4-FFF2-40B4-BE49-F238E27FC236}">
-                <a16:creationId xmlns:a16="http://schemas.microsoft.com/office/drawing/2014/main" id="{7BD665D9-5316-4721-BA52-71E74FA8FD0D}"/>
+                <a16:creationId xmlns:a16="http://schemas.microsoft.com/office/drawing/2014/main" id="{AF6984FB-54A5-4E84-8233-17789FF28BB6}"/>
               </a:ext>
             </a:extLst>
           </p:cNvPr>
@@ -16059,7 +16059,7 @@
     </p:spTree>
     <p:extLst>
       <p:ext uri="{BB962C8B-B14F-4D97-AF65-F5344CB8AC3E}">
-        <p14:creationId xmlns:p14="http://schemas.microsoft.com/office/powerpoint/2010/main" val="1786055704"/>
+        <p14:creationId xmlns:p14="http://schemas.microsoft.com/office/powerpoint/2010/main" val="1559131319"/>
       </p:ext>
     </p:extLst>
   </p:cSld>
@@ -16090,7 +16090,7 @@
           <p:cNvPr id="8" name="Opgave 7: vragen a, b en c">
             <a:extLst xmlns:a="http://schemas.openxmlformats.org/drawingml/2006/main">
               <a:ext uri="{FF2B5EF4-FFF2-40B4-BE49-F238E27FC236}">
-                <a16:creationId xmlns:a16="http://schemas.microsoft.com/office/drawing/2014/main" id="{3B511775-7AEC-4867-8C94-98D7CB1B7864}"/>
+                <a16:creationId xmlns:a16="http://schemas.microsoft.com/office/drawing/2014/main" id="{5F146C0B-9216-4348-8430-75955234C325}"/>
               </a:ext>
             </a:extLst>
           </p:cNvPr>
@@ -16147,7 +16147,7 @@
           <p:cNvPr id="2" name="">
             <a:extLst xmlns:a="http://schemas.openxmlformats.org/drawingml/2006/main">
               <a:ext uri="{FF2B5EF4-FFF2-40B4-BE49-F238E27FC236}">
-                <a16:creationId xmlns:a16="http://schemas.microsoft.com/office/drawing/2014/main" id="{DA3EA0CB-D282-47BE-8B28-6CD2247EDD3B}"/>
+                <a16:creationId xmlns:a16="http://schemas.microsoft.com/office/drawing/2014/main" id="{A3B44435-5888-4636-80E4-5AB85F08E726}"/>
               </a:ext>
             </a:extLst>
           </p:cNvPr>
@@ -16176,7 +16176,7 @@
           <p:cNvPr id="3" name="§3.2.1 Volkomen concurrentie · Opgave 7 · Boekpagina 60">
             <a:extLst xmlns:a="http://schemas.openxmlformats.org/drawingml/2006/main">
               <a:ext uri="{FF2B5EF4-FFF2-40B4-BE49-F238E27FC236}">
-                <a16:creationId xmlns:a16="http://schemas.microsoft.com/office/drawing/2014/main" id="{17137525-9427-491F-86C9-B6F2DD97242E}"/>
+                <a16:creationId xmlns:a16="http://schemas.microsoft.com/office/drawing/2014/main" id="{5991E300-3740-4A91-95CF-926FB6D65BC4}"/>
               </a:ext>
             </a:extLst>
           </p:cNvPr>
@@ -16233,7 +16233,7 @@
           <p:cNvPr id="4" name="17">
             <a:extLst xmlns:a="http://schemas.openxmlformats.org/drawingml/2006/main">
               <a:ext uri="{FF2B5EF4-FFF2-40B4-BE49-F238E27FC236}">
-                <a16:creationId xmlns:a16="http://schemas.microsoft.com/office/drawing/2014/main" id="{5E825257-6B75-48DE-A994-E31B05664AE4}"/>
+                <a16:creationId xmlns:a16="http://schemas.microsoft.com/office/drawing/2014/main" id="{981BDA7C-CB00-4794-B500-159173384306}"/>
               </a:ext>
             </a:extLst>
           </p:cNvPr>
@@ -16290,7 +16290,7 @@
           <p:cNvPr id="5" name="a. (2p) Lees de marktprijs en de markthoeveelheid af. Noem één kenmerk">
             <a:extLst xmlns:a="http://schemas.openxmlformats.org/drawingml/2006/main">
               <a:ext uri="{FF2B5EF4-FFF2-40B4-BE49-F238E27FC236}">
-                <a16:creationId xmlns:a16="http://schemas.microsoft.com/office/drawing/2014/main" id="{6EAC6031-3202-41AB-BD8D-31D5BDBA2049}"/>
+                <a16:creationId xmlns:a16="http://schemas.microsoft.com/office/drawing/2014/main" id="{B92EB967-6E1A-470D-9E90-9D6B4034C0C2}"/>
               </a:ext>
             </a:extLst>
           </p:cNvPr>
@@ -16347,7 +16347,7 @@
           <p:cNvPr id="6" name="b. (2p) Teken rechts de opbrengstlijn van Mila. Label die als P = GO =">
             <a:extLst xmlns:a="http://schemas.openxmlformats.org/drawingml/2006/main">
               <a:ext uri="{FF2B5EF4-FFF2-40B4-BE49-F238E27FC236}">
-                <a16:creationId xmlns:a16="http://schemas.microsoft.com/office/drawing/2014/main" id="{9C74E774-C714-43DB-AE4E-027A2E821DB4}"/>
+                <a16:creationId xmlns:a16="http://schemas.microsoft.com/office/drawing/2014/main" id="{0E9ADA17-47BD-47A6-890D-41193F243723}"/>
               </a:ext>
             </a:extLst>
           </p:cNvPr>
@@ -16404,7 +16404,7 @@
           <p:cNvPr id="7" name="c. (3p) Bereken bij q = 120 kg de TO en GO. Bereken MO wanneer Mila va">
             <a:extLst xmlns:a="http://schemas.openxmlformats.org/drawingml/2006/main">
               <a:ext uri="{FF2B5EF4-FFF2-40B4-BE49-F238E27FC236}">
-                <a16:creationId xmlns:a16="http://schemas.microsoft.com/office/drawing/2014/main" id="{2AC34358-51A2-41BA-9255-2D4B0BF4212F}"/>
+                <a16:creationId xmlns:a16="http://schemas.microsoft.com/office/drawing/2014/main" id="{23A627DE-D007-4626-861C-256386013E42}"/>
               </a:ext>
             </a:extLst>
           </p:cNvPr>
@@ -16459,7 +16459,7 @@
     </p:spTree>
     <p:extLst>
       <p:ext uri="{BB962C8B-B14F-4D97-AF65-F5344CB8AC3E}">
-        <p14:creationId xmlns:p14="http://schemas.microsoft.com/office/powerpoint/2010/main" val="1222722878"/>
+        <p14:creationId xmlns:p14="http://schemas.microsoft.com/office/powerpoint/2010/main" val="921381771"/>
       </p:ext>
     </p:extLst>
   </p:cSld>
@@ -16490,7 +16490,7 @@
           <p:cNvPr id="7" name="Opgave 7: vragen d en e">
             <a:extLst xmlns:a="http://schemas.openxmlformats.org/drawingml/2006/main">
               <a:ext uri="{FF2B5EF4-FFF2-40B4-BE49-F238E27FC236}">
-                <a16:creationId xmlns:a16="http://schemas.microsoft.com/office/drawing/2014/main" id="{C7B983E0-8EED-48C2-B912-B492D248B2C5}"/>
+                <a16:creationId xmlns:a16="http://schemas.microsoft.com/office/drawing/2014/main" id="{09FD9B69-2F00-4406-930D-96D6EC58F017}"/>
               </a:ext>
             </a:extLst>
           </p:cNvPr>
@@ -16547,7 +16547,7 @@
           <p:cNvPr id="2" name="">
             <a:extLst xmlns:a="http://schemas.openxmlformats.org/drawingml/2006/main">
               <a:ext uri="{FF2B5EF4-FFF2-40B4-BE49-F238E27FC236}">
-                <a16:creationId xmlns:a16="http://schemas.microsoft.com/office/drawing/2014/main" id="{5A8590B8-CF50-439A-8063-67A0B43D5F15}"/>
+                <a16:creationId xmlns:a16="http://schemas.microsoft.com/office/drawing/2014/main" id="{1CD68A7D-2B0B-4150-BACF-E013CA39D6F1}"/>
               </a:ext>
             </a:extLst>
           </p:cNvPr>
@@ -16576,7 +16576,7 @@
           <p:cNvPr id="3" name="§3.2.1 Volkomen concurrentie · Opgave 7 · Boekpagina 60">
             <a:extLst xmlns:a="http://schemas.openxmlformats.org/drawingml/2006/main">
               <a:ext uri="{FF2B5EF4-FFF2-40B4-BE49-F238E27FC236}">
-                <a16:creationId xmlns:a16="http://schemas.microsoft.com/office/drawing/2014/main" id="{25377E56-2D43-4476-A688-99B2E10AC7FB}"/>
+                <a16:creationId xmlns:a16="http://schemas.microsoft.com/office/drawing/2014/main" id="{EED0A113-0352-4901-ADB5-1E918C8D035D}"/>
               </a:ext>
             </a:extLst>
           </p:cNvPr>
@@ -16633,7 +16633,7 @@
           <p:cNvPr id="4" name="18">
             <a:extLst xmlns:a="http://schemas.openxmlformats.org/drawingml/2006/main">
               <a:ext uri="{FF2B5EF4-FFF2-40B4-BE49-F238E27FC236}">
-                <a16:creationId xmlns:a16="http://schemas.microsoft.com/office/drawing/2014/main" id="{2BEF7162-F04A-46AD-A1BB-1B6A5E4DD760}"/>
+                <a16:creationId xmlns:a16="http://schemas.microsoft.com/office/drawing/2014/main" id="{F0AF02E3-9A8F-475C-81CB-986F13E334EA}"/>
               </a:ext>
             </a:extLst>
           </p:cNvPr>
@@ -16690,7 +16690,7 @@
           <p:cNvPr id="5" name="d. (2p) Mila overweegt € 3,20 te vragen.&#10;Leg uit waarom zij in dit mod">
             <a:extLst xmlns:a="http://schemas.openxmlformats.org/drawingml/2006/main">
               <a:ext uri="{FF2B5EF4-FFF2-40B4-BE49-F238E27FC236}">
-                <a16:creationId xmlns:a16="http://schemas.microsoft.com/office/drawing/2014/main" id="{A7161E71-4F4D-4AC3-95CB-57BFC8B3D687}"/>
+                <a16:creationId xmlns:a16="http://schemas.microsoft.com/office/drawing/2014/main" id="{DA896C83-8951-4C9F-A3D2-3BCDC4BB513C}"/>
               </a:ext>
             </a:extLst>
           </p:cNvPr>
@@ -16770,7 +16770,7 @@
           <p:cNvPr id="6" name="e. (2p) Een klasgenoot zegt: “De markt verkoopt 4.000 kg, dus de lijn ">
             <a:extLst xmlns:a="http://schemas.openxmlformats.org/drawingml/2006/main">
               <a:ext uri="{FF2B5EF4-FFF2-40B4-BE49-F238E27FC236}">
-                <a16:creationId xmlns:a16="http://schemas.microsoft.com/office/drawing/2014/main" id="{3F6A7A52-0067-4152-A213-7126D170516F}"/>
+                <a16:creationId xmlns:a16="http://schemas.microsoft.com/office/drawing/2014/main" id="{46977F3A-6501-45ED-B91C-78F7E09D9186}"/>
               </a:ext>
             </a:extLst>
           </p:cNvPr>
@@ -16825,7 +16825,7 @@
     </p:spTree>
     <p:extLst>
       <p:ext uri="{BB962C8B-B14F-4D97-AF65-F5344CB8AC3E}">
-        <p14:creationId xmlns:p14="http://schemas.microsoft.com/office/powerpoint/2010/main" val="613256715"/>
+        <p14:creationId xmlns:p14="http://schemas.microsoft.com/office/powerpoint/2010/main" val="329460467"/>
       </p:ext>
     </p:extLst>
   </p:cSld>
@@ -16856,7 +16856,7 @@
           <p:cNvPr id="10" name="Opgave 7a: evenwicht en prijsnemerschap">
             <a:extLst xmlns:a="http://schemas.openxmlformats.org/drawingml/2006/main">
               <a:ext uri="{FF2B5EF4-FFF2-40B4-BE49-F238E27FC236}">
-                <a16:creationId xmlns:a16="http://schemas.microsoft.com/office/drawing/2014/main" id="{1A7F17FE-E2E8-4CA8-8A60-FB2A9E2E797C}"/>
+                <a16:creationId xmlns:a16="http://schemas.microsoft.com/office/drawing/2014/main" id="{D50634A2-385D-4FBB-A30E-6CA60EE2F8FE}"/>
               </a:ext>
             </a:extLst>
           </p:cNvPr>
@@ -16913,7 +16913,7 @@
           <p:cNvPr id="2" name="">
             <a:extLst xmlns:a="http://schemas.openxmlformats.org/drawingml/2006/main">
               <a:ext uri="{FF2B5EF4-FFF2-40B4-BE49-F238E27FC236}">
-                <a16:creationId xmlns:a16="http://schemas.microsoft.com/office/drawing/2014/main" id="{2B0BC5DF-17FE-4B1A-B66D-0EFEA9B698FC}"/>
+                <a16:creationId xmlns:a16="http://schemas.microsoft.com/office/drawing/2014/main" id="{D79A2FD4-B2C2-4FB0-B6BA-A6105739D00A}"/>
               </a:ext>
             </a:extLst>
           </p:cNvPr>
@@ -16942,7 +16942,7 @@
           <p:cNvPr id="3" name="§3.2.1 Volkomen concurrentie · Opgave 7 · Boekpagina 60">
             <a:extLst xmlns:a="http://schemas.openxmlformats.org/drawingml/2006/main">
               <a:ext uri="{FF2B5EF4-FFF2-40B4-BE49-F238E27FC236}">
-                <a16:creationId xmlns:a16="http://schemas.microsoft.com/office/drawing/2014/main" id="{9C217177-62C3-408C-803E-817B307877B7}"/>
+                <a16:creationId xmlns:a16="http://schemas.microsoft.com/office/drawing/2014/main" id="{899B4CE0-7616-4BB1-9C42-F8ED2BE6C412}"/>
               </a:ext>
             </a:extLst>
           </p:cNvPr>
@@ -16999,7 +16999,7 @@
           <p:cNvPr id="4" name="19">
             <a:extLst xmlns:a="http://schemas.openxmlformats.org/drawingml/2006/main">
               <a:ext uri="{FF2B5EF4-FFF2-40B4-BE49-F238E27FC236}">
-                <a16:creationId xmlns:a16="http://schemas.microsoft.com/office/drawing/2014/main" id="{19C7F810-F8F5-47E3-994A-BC906FC76672}"/>
+                <a16:creationId xmlns:a16="http://schemas.microsoft.com/office/drawing/2014/main" id="{FBE64121-7316-4EBE-A957-3025EB013466}"/>
               </a:ext>
             </a:extLst>
           </p:cNvPr>
@@ -17063,7 +17063,7 @@
         </p:xfrm>
         <a:graphic xmlns:a="http://schemas.openxmlformats.org/drawingml/2006/main">
           <a:graphicData uri="http://schemas.openxmlformats.org/drawingml/2006/chart">
-            <c:chart xmlns:r="http://schemas.openxmlformats.org/officeDocument/2006/relationships" xmlns:c="http://schemas.openxmlformats.org/drawingml/2006/chart" r:id="Rd371e4c894d1478c"/>
+            <c:chart xmlns:r="http://schemas.openxmlformats.org/officeDocument/2006/relationships" xmlns:c="http://schemas.openxmlformats.org/drawingml/2006/chart" r:id="R766273a2db4f4e87"/>
           </a:graphicData>
         </a:graphic>
       </p:graphicFrame>
@@ -17072,7 +17072,7 @@
           <p:cNvPr id="6" name="P = € 3 per kg">
             <a:extLst xmlns:a="http://schemas.openxmlformats.org/drawingml/2006/main">
               <a:ext uri="{FF2B5EF4-FFF2-40B4-BE49-F238E27FC236}">
-                <a16:creationId xmlns:a16="http://schemas.microsoft.com/office/drawing/2014/main" id="{2C1F1EE2-1456-4BAC-9350-F5344BF541A3}"/>
+                <a16:creationId xmlns:a16="http://schemas.microsoft.com/office/drawing/2014/main" id="{F7AF986D-7DBD-4D46-82D5-44C79111DA2A}"/>
               </a:ext>
             </a:extLst>
           </p:cNvPr>
@@ -17129,7 +17129,7 @@
           <p:cNvPr id="7" name="Q = 4 × 1.000&#10;= 4.000 kg per dag">
             <a:extLst xmlns:a="http://schemas.openxmlformats.org/drawingml/2006/main">
               <a:ext uri="{FF2B5EF4-FFF2-40B4-BE49-F238E27FC236}">
-                <a16:creationId xmlns:a16="http://schemas.microsoft.com/office/drawing/2014/main" id="{4D46266A-98F4-44C7-8E87-C25F876AA1E8}"/>
+                <a16:creationId xmlns:a16="http://schemas.microsoft.com/office/drawing/2014/main" id="{BF2802D1-84CF-4529-95ED-AAD50A84C6AE}"/>
               </a:ext>
             </a:extLst>
           </p:cNvPr>
@@ -17209,7 +17209,7 @@
           <p:cNvPr id="8" name="Bijvoorbeeld:&#10;veel kleine telers.">
             <a:extLst xmlns:a="http://schemas.openxmlformats.org/drawingml/2006/main">
               <a:ext uri="{FF2B5EF4-FFF2-40B4-BE49-F238E27FC236}">
-                <a16:creationId xmlns:a16="http://schemas.microsoft.com/office/drawing/2014/main" id="{897E66E9-1B64-46CC-A534-B07F9BA65E85}"/>
+                <a16:creationId xmlns:a16="http://schemas.microsoft.com/office/drawing/2014/main" id="{1F3EB6DF-89C6-41E1-8B32-20EA78A0D70D}"/>
               </a:ext>
             </a:extLst>
           </p:cNvPr>
@@ -17289,7 +17289,7 @@
           <p:cNvPr id="9" name="Eén teler heeft&#10;nauwelijks prijsinvloed.">
             <a:extLst xmlns:a="http://schemas.openxmlformats.org/drawingml/2006/main">
               <a:ext uri="{FF2B5EF4-FFF2-40B4-BE49-F238E27FC236}">
-                <a16:creationId xmlns:a16="http://schemas.microsoft.com/office/drawing/2014/main" id="{3FE6CE22-C3F9-4561-81DD-5E0D378BF6F6}"/>
+                <a16:creationId xmlns:a16="http://schemas.microsoft.com/office/drawing/2014/main" id="{4667BF60-DEDF-4057-A3D6-1EA063AFCF7E}"/>
               </a:ext>
             </a:extLst>
           </p:cNvPr>
@@ -17367,7 +17367,7 @@
     </p:spTree>
     <p:extLst>
       <p:ext uri="{BB962C8B-B14F-4D97-AF65-F5344CB8AC3E}">
-        <p14:creationId xmlns:p14="http://schemas.microsoft.com/office/powerpoint/2010/main" val="1637314843"/>
+        <p14:creationId xmlns:p14="http://schemas.microsoft.com/office/powerpoint/2010/main" val="727734043"/>
       </p:ext>
     </p:extLst>
   </p:cSld>
@@ -17398,7 +17398,7 @@
           <p:cNvPr id="13" name="Wat kun je na deze les?">
             <a:extLst xmlns:a="http://schemas.openxmlformats.org/drawingml/2006/main">
               <a:ext uri="{FF2B5EF4-FFF2-40B4-BE49-F238E27FC236}">
-                <a16:creationId xmlns:a16="http://schemas.microsoft.com/office/drawing/2014/main" id="{6F985273-4A87-4F8C-B442-E881E66A3B6A}"/>
+                <a16:creationId xmlns:a16="http://schemas.microsoft.com/office/drawing/2014/main" id="{94122636-EFA5-4788-81DB-982F8C5D276D}"/>
               </a:ext>
             </a:extLst>
           </p:cNvPr>
@@ -17455,7 +17455,7 @@
           <p:cNvPr id="2" name="">
             <a:extLst xmlns:a="http://schemas.openxmlformats.org/drawingml/2006/main">
               <a:ext uri="{FF2B5EF4-FFF2-40B4-BE49-F238E27FC236}">
-                <a16:creationId xmlns:a16="http://schemas.microsoft.com/office/drawing/2014/main" id="{8988482F-8565-43E8-9BB9-0CB70885F170}"/>
+                <a16:creationId xmlns:a16="http://schemas.microsoft.com/office/drawing/2014/main" id="{4CB6D0D0-ABB7-4412-BCA8-F27321A8B15E}"/>
               </a:ext>
             </a:extLst>
           </p:cNvPr>
@@ -17484,7 +17484,7 @@
           <p:cNvPr id="3" name="§3.2.1 Volkomen concurrentie">
             <a:extLst xmlns:a="http://schemas.openxmlformats.org/drawingml/2006/main">
               <a:ext uri="{FF2B5EF4-FFF2-40B4-BE49-F238E27FC236}">
-                <a16:creationId xmlns:a16="http://schemas.microsoft.com/office/drawing/2014/main" id="{CCB96EE8-BAF9-4AFE-9815-EBCC95EB2739}"/>
+                <a16:creationId xmlns:a16="http://schemas.microsoft.com/office/drawing/2014/main" id="{15E67A23-E9E6-4D9A-8660-4AE7B62FA928}"/>
               </a:ext>
             </a:extLst>
           </p:cNvPr>
@@ -17541,7 +17541,7 @@
           <p:cNvPr id="4" name="2">
             <a:extLst xmlns:a="http://schemas.openxmlformats.org/drawingml/2006/main">
               <a:ext uri="{FF2B5EF4-FFF2-40B4-BE49-F238E27FC236}">
-                <a16:creationId xmlns:a16="http://schemas.microsoft.com/office/drawing/2014/main" id="{F96AEA6B-9A39-4032-95D6-4BE3AD0D0116}"/>
+                <a16:creationId xmlns:a16="http://schemas.microsoft.com/office/drawing/2014/main" id="{46869A96-6949-4FF0-A765-6CB34156D401}"/>
               </a:ext>
             </a:extLst>
           </p:cNvPr>
@@ -17598,7 +17598,7 @@
           <p:cNvPr id="5" name="Prijsnemerschap">
             <a:extLst xmlns:a="http://schemas.openxmlformats.org/drawingml/2006/main">
               <a:ext uri="{FF2B5EF4-FFF2-40B4-BE49-F238E27FC236}">
-                <a16:creationId xmlns:a16="http://schemas.microsoft.com/office/drawing/2014/main" id="{3B200950-2982-4BE6-9283-B89D3F207BE0}"/>
+                <a16:creationId xmlns:a16="http://schemas.microsoft.com/office/drawing/2014/main" id="{56C3D8E0-873B-417F-B884-AF3D603FA4C2}"/>
               </a:ext>
             </a:extLst>
           </p:cNvPr>
@@ -17655,7 +17655,7 @@
           <p:cNvPr id="6" name="Je verklaart waarom één kleine onderneming de marktprijs overneemt.">
             <a:extLst xmlns:a="http://schemas.openxmlformats.org/drawingml/2006/main">
               <a:ext uri="{FF2B5EF4-FFF2-40B4-BE49-F238E27FC236}">
-                <a16:creationId xmlns:a16="http://schemas.microsoft.com/office/drawing/2014/main" id="{41D9585B-8DBF-4791-9460-D13CA6A72FBD}"/>
+                <a16:creationId xmlns:a16="http://schemas.microsoft.com/office/drawing/2014/main" id="{4F8B8F86-4AFE-475A-ADEF-CA6FB64F3131}"/>
               </a:ext>
             </a:extLst>
           </p:cNvPr>
@@ -17712,7 +17712,7 @@
           <p:cNvPr id="7" name="">
             <a:extLst xmlns:a="http://schemas.openxmlformats.org/drawingml/2006/main">
               <a:ext uri="{FF2B5EF4-FFF2-40B4-BE49-F238E27FC236}">
-                <a16:creationId xmlns:a16="http://schemas.microsoft.com/office/drawing/2014/main" id="{A66D5498-58D7-47AD-9DF8-0FD2A88EA973}"/>
+                <a16:creationId xmlns:a16="http://schemas.microsoft.com/office/drawing/2014/main" id="{508C347E-DDBE-4B6D-A985-CFA49C374BD5}"/>
               </a:ext>
             </a:extLst>
           </p:cNvPr>
@@ -17741,7 +17741,7 @@
           <p:cNvPr id="8" name="Markt en onderneming">
             <a:extLst xmlns:a="http://schemas.openxmlformats.org/drawingml/2006/main">
               <a:ext uri="{FF2B5EF4-FFF2-40B4-BE49-F238E27FC236}">
-                <a16:creationId xmlns:a16="http://schemas.microsoft.com/office/drawing/2014/main" id="{5238F82E-C288-41D4-84DD-B284B691ABA0}"/>
+                <a16:creationId xmlns:a16="http://schemas.microsoft.com/office/drawing/2014/main" id="{B718F0D9-39F0-48B3-9959-8AE6C809B8F0}"/>
               </a:ext>
             </a:extLst>
           </p:cNvPr>
@@ -17798,7 +17798,7 @@
           <p:cNvPr id="9" name="Je neemt de prijs over en onderscheidt Q van q.">
             <a:extLst xmlns:a="http://schemas.openxmlformats.org/drawingml/2006/main">
               <a:ext uri="{FF2B5EF4-FFF2-40B4-BE49-F238E27FC236}">
-                <a16:creationId xmlns:a16="http://schemas.microsoft.com/office/drawing/2014/main" id="{A4F4DB7C-68CA-45D8-B17F-405161F5AA02}"/>
+                <a16:creationId xmlns:a16="http://schemas.microsoft.com/office/drawing/2014/main" id="{C006BD56-F950-4C5C-8B96-73AD91ABFCC4}"/>
               </a:ext>
             </a:extLst>
           </p:cNvPr>
@@ -17855,7 +17855,7 @@
           <p:cNvPr id="10" name="">
             <a:extLst xmlns:a="http://schemas.openxmlformats.org/drawingml/2006/main">
               <a:ext uri="{FF2B5EF4-FFF2-40B4-BE49-F238E27FC236}">
-                <a16:creationId xmlns:a16="http://schemas.microsoft.com/office/drawing/2014/main" id="{999080D8-B589-4A23-B7C4-7C380D65BB46}"/>
+                <a16:creationId xmlns:a16="http://schemas.microsoft.com/office/drawing/2014/main" id="{EA0FEBF8-8A4D-4921-BE92-861E1310778E}"/>
               </a:ext>
             </a:extLst>
           </p:cNvPr>
@@ -17884,7 +17884,7 @@
           <p:cNvPr id="11" name="Opbrengsten en prijskeuze">
             <a:extLst xmlns:a="http://schemas.openxmlformats.org/drawingml/2006/main">
               <a:ext uri="{FF2B5EF4-FFF2-40B4-BE49-F238E27FC236}">
-                <a16:creationId xmlns:a16="http://schemas.microsoft.com/office/drawing/2014/main" id="{35B27927-7A6F-4985-B60A-0DDAC3C27DA1}"/>
+                <a16:creationId xmlns:a16="http://schemas.microsoft.com/office/drawing/2014/main" id="{A21F30BE-8F3E-465E-A43F-41A7B41F27A6}"/>
               </a:ext>
             </a:extLst>
           </p:cNvPr>
@@ -17941,7 +17941,7 @@
           <p:cNvPr id="12" name="Je berekent TO, GO en MO en beoordeelt een hogere of lagere prijs.">
             <a:extLst xmlns:a="http://schemas.openxmlformats.org/drawingml/2006/main">
               <a:ext uri="{FF2B5EF4-FFF2-40B4-BE49-F238E27FC236}">
-                <a16:creationId xmlns:a16="http://schemas.microsoft.com/office/drawing/2014/main" id="{D4F7E3CA-68A5-4B48-AFF9-C469DC36D28C}"/>
+                <a16:creationId xmlns:a16="http://schemas.microsoft.com/office/drawing/2014/main" id="{768787DC-7F74-48B8-AA3A-1AFCAE89FD73}"/>
               </a:ext>
             </a:extLst>
           </p:cNvPr>
@@ -17996,7 +17996,7 @@
     </p:spTree>
     <p:extLst>
       <p:ext uri="{BB962C8B-B14F-4D97-AF65-F5344CB8AC3E}">
-        <p14:creationId xmlns:p14="http://schemas.microsoft.com/office/powerpoint/2010/main" val="526913513"/>
+        <p14:creationId xmlns:p14="http://schemas.microsoft.com/office/powerpoint/2010/main" val="1497462717"/>
       </p:ext>
     </p:extLst>
   </p:cSld>
@@ -18027,7 +18027,7 @@
           <p:cNvPr id="8" name="Opgave 7b: Mila’s opbrengstlijn">
             <a:extLst xmlns:a="http://schemas.openxmlformats.org/drawingml/2006/main">
               <a:ext uri="{FF2B5EF4-FFF2-40B4-BE49-F238E27FC236}">
-                <a16:creationId xmlns:a16="http://schemas.microsoft.com/office/drawing/2014/main" id="{F6AD6466-4BEE-4A83-83FF-C2E93C74EB8E}"/>
+                <a16:creationId xmlns:a16="http://schemas.microsoft.com/office/drawing/2014/main" id="{7DE4987C-07E6-4F75-BA44-B9D5D4DD4F0A}"/>
               </a:ext>
             </a:extLst>
           </p:cNvPr>
@@ -18084,7 +18084,7 @@
           <p:cNvPr id="2" name="">
             <a:extLst xmlns:a="http://schemas.openxmlformats.org/drawingml/2006/main">
               <a:ext uri="{FF2B5EF4-FFF2-40B4-BE49-F238E27FC236}">
-                <a16:creationId xmlns:a16="http://schemas.microsoft.com/office/drawing/2014/main" id="{2ABA0F2D-059A-4F8A-8C1D-93904CC6A8CB}"/>
+                <a16:creationId xmlns:a16="http://schemas.microsoft.com/office/drawing/2014/main" id="{C693AB65-73BC-4BA3-B19C-74CC89FF3387}"/>
               </a:ext>
             </a:extLst>
           </p:cNvPr>
@@ -18113,7 +18113,7 @@
           <p:cNvPr id="3" name="§3.2.1 Volkomen concurrentie · Opgave 7 · Boekpagina 60">
             <a:extLst xmlns:a="http://schemas.openxmlformats.org/drawingml/2006/main">
               <a:ext uri="{FF2B5EF4-FFF2-40B4-BE49-F238E27FC236}">
-                <a16:creationId xmlns:a16="http://schemas.microsoft.com/office/drawing/2014/main" id="{5B20FC5E-ADE4-4A67-B582-814D87AA17C5}"/>
+                <a16:creationId xmlns:a16="http://schemas.microsoft.com/office/drawing/2014/main" id="{DD7299B6-2551-4AF8-88E8-9FCF62542A3D}"/>
               </a:ext>
             </a:extLst>
           </p:cNvPr>
@@ -18170,7 +18170,7 @@
           <p:cNvPr id="4" name="20">
             <a:extLst xmlns:a="http://schemas.openxmlformats.org/drawingml/2006/main">
               <a:ext uri="{FF2B5EF4-FFF2-40B4-BE49-F238E27FC236}">
-                <a16:creationId xmlns:a16="http://schemas.microsoft.com/office/drawing/2014/main" id="{56E2F45A-CBE7-494C-9FF6-BD6239E7B220}"/>
+                <a16:creationId xmlns:a16="http://schemas.microsoft.com/office/drawing/2014/main" id="{8F16D615-B350-4F99-8151-62E90CC70E70}"/>
               </a:ext>
             </a:extLst>
           </p:cNvPr>
@@ -18234,7 +18234,7 @@
         </p:xfrm>
         <a:graphic xmlns:a="http://schemas.openxmlformats.org/drawingml/2006/main">
           <a:graphicData uri="http://schemas.openxmlformats.org/drawingml/2006/chart">
-            <c:chart xmlns:r="http://schemas.openxmlformats.org/officeDocument/2006/relationships" xmlns:c="http://schemas.openxmlformats.org/drawingml/2006/chart" r:id="Redbe9e2dc5fc4016"/>
+            <c:chart xmlns:r="http://schemas.openxmlformats.org/officeDocument/2006/relationships" xmlns:c="http://schemas.openxmlformats.org/drawingml/2006/chart" r:id="R2815766236f043d3"/>
           </a:graphicData>
         </a:graphic>
       </p:graphicFrame>
@@ -18243,7 +18243,7 @@
           <p:cNvPr id="6" name="P = GO = MO&#10;= € 3 per kg">
             <a:extLst xmlns:a="http://schemas.openxmlformats.org/drawingml/2006/main">
               <a:ext uri="{FF2B5EF4-FFF2-40B4-BE49-F238E27FC236}">
-                <a16:creationId xmlns:a16="http://schemas.microsoft.com/office/drawing/2014/main" id="{1F3187B1-DA99-41FE-B27E-E27DFD179A64}"/>
+                <a16:creationId xmlns:a16="http://schemas.microsoft.com/office/drawing/2014/main" id="{1E87A94A-3AA8-488E-889D-E476DC129ECF}"/>
               </a:ext>
             </a:extLst>
           </p:cNvPr>
@@ -18323,7 +18323,7 @@
           <p:cNvPr id="7" name="Horizontaal op 3&#10;Tot q = 160&#10;Eenheid: € per kg">
             <a:extLst xmlns:a="http://schemas.openxmlformats.org/drawingml/2006/main">
               <a:ext uri="{FF2B5EF4-FFF2-40B4-BE49-F238E27FC236}">
-                <a16:creationId xmlns:a16="http://schemas.microsoft.com/office/drawing/2014/main" id="{8BDB75FE-D931-483D-88B7-FB74821FFFD7}"/>
+                <a16:creationId xmlns:a16="http://schemas.microsoft.com/office/drawing/2014/main" id="{A732FD4A-A5A5-4F97-A791-1171099302C4}"/>
               </a:ext>
             </a:extLst>
           </p:cNvPr>
@@ -18424,7 +18424,7 @@
     </p:spTree>
     <p:extLst>
       <p:ext uri="{BB962C8B-B14F-4D97-AF65-F5344CB8AC3E}">
-        <p14:creationId xmlns:p14="http://schemas.microsoft.com/office/powerpoint/2010/main" val="2129037686"/>
+        <p14:creationId xmlns:p14="http://schemas.microsoft.com/office/powerpoint/2010/main" val="7065201"/>
       </p:ext>
     </p:extLst>
   </p:cSld>
@@ -18455,7 +18455,7 @@
           <p:cNvPr id="11" name="Opgave 7c: TO en GO bij 120 kg">
             <a:extLst xmlns:a="http://schemas.openxmlformats.org/drawingml/2006/main">
               <a:ext uri="{FF2B5EF4-FFF2-40B4-BE49-F238E27FC236}">
-                <a16:creationId xmlns:a16="http://schemas.microsoft.com/office/drawing/2014/main" id="{60C50BB9-42DE-49BD-9F9B-B08C08338EC3}"/>
+                <a16:creationId xmlns:a16="http://schemas.microsoft.com/office/drawing/2014/main" id="{A19FADDA-FE2C-401F-9CC7-6684E1BC5FEA}"/>
               </a:ext>
             </a:extLst>
           </p:cNvPr>
@@ -18512,7 +18512,7 @@
           <p:cNvPr id="2" name="">
             <a:extLst xmlns:a="http://schemas.openxmlformats.org/drawingml/2006/main">
               <a:ext uri="{FF2B5EF4-FFF2-40B4-BE49-F238E27FC236}">
-                <a16:creationId xmlns:a16="http://schemas.microsoft.com/office/drawing/2014/main" id="{AF9BF1F7-1040-460C-9C37-ADF14CCB000A}"/>
+                <a16:creationId xmlns:a16="http://schemas.microsoft.com/office/drawing/2014/main" id="{B2EBC497-02E6-42BA-8DF6-50BF1A4CD141}"/>
               </a:ext>
             </a:extLst>
           </p:cNvPr>
@@ -18541,7 +18541,7 @@
           <p:cNvPr id="3" name="§3.2.1 Volkomen concurrentie · Opgave 7 · Boekpagina 60">
             <a:extLst xmlns:a="http://schemas.openxmlformats.org/drawingml/2006/main">
               <a:ext uri="{FF2B5EF4-FFF2-40B4-BE49-F238E27FC236}">
-                <a16:creationId xmlns:a16="http://schemas.microsoft.com/office/drawing/2014/main" id="{01EE44DB-E3F6-464D-A8C2-94FA24D3A537}"/>
+                <a16:creationId xmlns:a16="http://schemas.microsoft.com/office/drawing/2014/main" id="{83317943-7D59-4836-A74B-6BA1311FE661}"/>
               </a:ext>
             </a:extLst>
           </p:cNvPr>
@@ -18598,7 +18598,7 @@
           <p:cNvPr id="4" name="21">
             <a:extLst xmlns:a="http://schemas.openxmlformats.org/drawingml/2006/main">
               <a:ext uri="{FF2B5EF4-FFF2-40B4-BE49-F238E27FC236}">
-                <a16:creationId xmlns:a16="http://schemas.microsoft.com/office/drawing/2014/main" id="{59F66CA8-8F17-46E4-8AF0-13625D23B800}"/>
+                <a16:creationId xmlns:a16="http://schemas.microsoft.com/office/drawing/2014/main" id="{9FF22025-D799-4BD1-8B65-14D15F5D6968}"/>
               </a:ext>
             </a:extLst>
           </p:cNvPr>
@@ -18655,7 +18655,7 @@
           <p:cNvPr id="5" name="TO = P × q">
             <a:extLst xmlns:a="http://schemas.openxmlformats.org/drawingml/2006/main">
               <a:ext uri="{FF2B5EF4-FFF2-40B4-BE49-F238E27FC236}">
-                <a16:creationId xmlns:a16="http://schemas.microsoft.com/office/drawing/2014/main" id="{0BF58101-0100-4038-98F5-0D26A878764E}"/>
+                <a16:creationId xmlns:a16="http://schemas.microsoft.com/office/drawing/2014/main" id="{91DDC05B-5F5F-4A0F-B184-F29E0D84067C}"/>
               </a:ext>
             </a:extLst>
           </p:cNvPr>
@@ -18712,7 +18712,7 @@
           <p:cNvPr id="6" name="TO = 3 × 120 = € 360 per dag">
             <a:extLst xmlns:a="http://schemas.openxmlformats.org/drawingml/2006/main">
               <a:ext uri="{FF2B5EF4-FFF2-40B4-BE49-F238E27FC236}">
-                <a16:creationId xmlns:a16="http://schemas.microsoft.com/office/drawing/2014/main" id="{1DDA9CC0-30D2-4473-811A-D569F562502F}"/>
+                <a16:creationId xmlns:a16="http://schemas.microsoft.com/office/drawing/2014/main" id="{7D6DF27F-4C30-4FE1-8E49-2EC1670848FC}"/>
               </a:ext>
             </a:extLst>
           </p:cNvPr>
@@ -18769,7 +18769,7 @@
           <p:cNvPr id="7" name="">
             <a:extLst xmlns:a="http://schemas.openxmlformats.org/drawingml/2006/main">
               <a:ext uri="{FF2B5EF4-FFF2-40B4-BE49-F238E27FC236}">
-                <a16:creationId xmlns:a16="http://schemas.microsoft.com/office/drawing/2014/main" id="{76A6DA3D-AE09-43CC-B349-C169161D3CC4}"/>
+                <a16:creationId xmlns:a16="http://schemas.microsoft.com/office/drawing/2014/main" id="{CED9FA2F-4A63-4B1B-886A-66AA795A47AA}"/>
               </a:ext>
             </a:extLst>
           </p:cNvPr>
@@ -18798,7 +18798,7 @@
           <p:cNvPr id="8" name="GO = TO / q">
             <a:extLst xmlns:a="http://schemas.openxmlformats.org/drawingml/2006/main">
               <a:ext uri="{FF2B5EF4-FFF2-40B4-BE49-F238E27FC236}">
-                <a16:creationId xmlns:a16="http://schemas.microsoft.com/office/drawing/2014/main" id="{8C711547-A106-4A6A-8CFF-DBA298FB363C}"/>
+                <a16:creationId xmlns:a16="http://schemas.microsoft.com/office/drawing/2014/main" id="{02179897-8726-48F1-AA42-8A1C59DA1915}"/>
               </a:ext>
             </a:extLst>
           </p:cNvPr>
@@ -18855,7 +18855,7 @@
           <p:cNvPr id="9" name="GO = 360 / 120 = € 3 per kg">
             <a:extLst xmlns:a="http://schemas.openxmlformats.org/drawingml/2006/main">
               <a:ext uri="{FF2B5EF4-FFF2-40B4-BE49-F238E27FC236}">
-                <a16:creationId xmlns:a16="http://schemas.microsoft.com/office/drawing/2014/main" id="{FE11A8FE-8184-4C11-8B33-0CB938B1EA4A}"/>
+                <a16:creationId xmlns:a16="http://schemas.microsoft.com/office/drawing/2014/main" id="{D498814C-FCA2-4127-AA37-B9C9CF984D55}"/>
               </a:ext>
             </a:extLst>
           </p:cNvPr>
@@ -18912,7 +18912,7 @@
           <p:cNvPr id="10" name="Controle: GO is gelijk aan de marktprijs.">
             <a:extLst xmlns:a="http://schemas.openxmlformats.org/drawingml/2006/main">
               <a:ext uri="{FF2B5EF4-FFF2-40B4-BE49-F238E27FC236}">
-                <a16:creationId xmlns:a16="http://schemas.microsoft.com/office/drawing/2014/main" id="{5ECCC06B-6ACA-41B2-B101-862145C16778}"/>
+                <a16:creationId xmlns:a16="http://schemas.microsoft.com/office/drawing/2014/main" id="{569A3CB5-23ED-48AC-ABF9-4BE4DE828812}"/>
               </a:ext>
             </a:extLst>
           </p:cNvPr>
@@ -18967,7 +18967,7 @@
     </p:spTree>
     <p:extLst>
       <p:ext uri="{BB962C8B-B14F-4D97-AF65-F5344CB8AC3E}">
-        <p14:creationId xmlns:p14="http://schemas.microsoft.com/office/powerpoint/2010/main" val="1969556691"/>
+        <p14:creationId xmlns:p14="http://schemas.microsoft.com/office/powerpoint/2010/main" val="951534631"/>
       </p:ext>
     </p:extLst>
   </p:cSld>
@@ -18998,7 +18998,7 @@
           <p:cNvPr id="9" name="Opgave 7c: MO bij 20 kg extra">
             <a:extLst xmlns:a="http://schemas.openxmlformats.org/drawingml/2006/main">
               <a:ext uri="{FF2B5EF4-FFF2-40B4-BE49-F238E27FC236}">
-                <a16:creationId xmlns:a16="http://schemas.microsoft.com/office/drawing/2014/main" id="{DA42D9B9-7811-4587-B4AF-331D75EF5DF0}"/>
+                <a16:creationId xmlns:a16="http://schemas.microsoft.com/office/drawing/2014/main" id="{9D1D6F66-6880-4E0B-A824-EDDAF485D386}"/>
               </a:ext>
             </a:extLst>
           </p:cNvPr>
@@ -19055,7 +19055,7 @@
           <p:cNvPr id="2" name="">
             <a:extLst xmlns:a="http://schemas.openxmlformats.org/drawingml/2006/main">
               <a:ext uri="{FF2B5EF4-FFF2-40B4-BE49-F238E27FC236}">
-                <a16:creationId xmlns:a16="http://schemas.microsoft.com/office/drawing/2014/main" id="{5AC89A35-C9DF-48CE-ADD4-39455CC6D9E0}"/>
+                <a16:creationId xmlns:a16="http://schemas.microsoft.com/office/drawing/2014/main" id="{E7205AA4-0440-4B4E-A5A3-AAA8A02721F2}"/>
               </a:ext>
             </a:extLst>
           </p:cNvPr>
@@ -19084,7 +19084,7 @@
           <p:cNvPr id="3" name="§3.2.1 Volkomen concurrentie · Opgave 7 · Boekpagina 60">
             <a:extLst xmlns:a="http://schemas.openxmlformats.org/drawingml/2006/main">
               <a:ext uri="{FF2B5EF4-FFF2-40B4-BE49-F238E27FC236}">
-                <a16:creationId xmlns:a16="http://schemas.microsoft.com/office/drawing/2014/main" id="{6B3B7636-228D-4A2A-B9EA-79B6EF1FAF24}"/>
+                <a16:creationId xmlns:a16="http://schemas.microsoft.com/office/drawing/2014/main" id="{81B3FF1A-581A-4851-97F2-37A801605F37}"/>
               </a:ext>
             </a:extLst>
           </p:cNvPr>
@@ -19141,7 +19141,7 @@
           <p:cNvPr id="4" name="22">
             <a:extLst xmlns:a="http://schemas.openxmlformats.org/drawingml/2006/main">
               <a:ext uri="{FF2B5EF4-FFF2-40B4-BE49-F238E27FC236}">
-                <a16:creationId xmlns:a16="http://schemas.microsoft.com/office/drawing/2014/main" id="{54763F90-6AB9-4B12-8465-147DFFEB2D40}"/>
+                <a16:creationId xmlns:a16="http://schemas.microsoft.com/office/drawing/2014/main" id="{EB2022EF-90CA-48D0-A178-09B678B9B732}"/>
               </a:ext>
             </a:extLst>
           </p:cNvPr>
@@ -19370,7 +19370,7 @@
           <p:cNvPr id="6" name="ΔTO = 420 − 360 = € 60 per dag">
             <a:extLst xmlns:a="http://schemas.openxmlformats.org/drawingml/2006/main">
               <a:ext uri="{FF2B5EF4-FFF2-40B4-BE49-F238E27FC236}">
-                <a16:creationId xmlns:a16="http://schemas.microsoft.com/office/drawing/2014/main" id="{2F4FD8C1-9377-42BE-8AEE-F8C7CC684868}"/>
+                <a16:creationId xmlns:a16="http://schemas.microsoft.com/office/drawing/2014/main" id="{F29AE118-83F1-4ABE-A26D-F2F4D705D575}"/>
               </a:ext>
             </a:extLst>
           </p:cNvPr>
@@ -19427,7 +19427,7 @@
           <p:cNvPr id="7" name="Δq = 140 − 120 = 20 kg per dag">
             <a:extLst xmlns:a="http://schemas.openxmlformats.org/drawingml/2006/main">
               <a:ext uri="{FF2B5EF4-FFF2-40B4-BE49-F238E27FC236}">
-                <a16:creationId xmlns:a16="http://schemas.microsoft.com/office/drawing/2014/main" id="{164EFE92-9754-45BE-9358-962282A82DE7}"/>
+                <a16:creationId xmlns:a16="http://schemas.microsoft.com/office/drawing/2014/main" id="{2077563E-9064-4E23-8A44-3929E0C24BA9}"/>
               </a:ext>
             </a:extLst>
           </p:cNvPr>
@@ -19484,7 +19484,7 @@
           <p:cNvPr id="8" name="MO = ΔTO / Δq = 60 / 20 = € 3 per kg">
             <a:extLst xmlns:a="http://schemas.openxmlformats.org/drawingml/2006/main">
               <a:ext uri="{FF2B5EF4-FFF2-40B4-BE49-F238E27FC236}">
-                <a16:creationId xmlns:a16="http://schemas.microsoft.com/office/drawing/2014/main" id="{A1FF9622-2BC6-453F-94A5-18B59F8BA60E}"/>
+                <a16:creationId xmlns:a16="http://schemas.microsoft.com/office/drawing/2014/main" id="{92BBA37E-57B8-40F1-B7DE-168764B8010E}"/>
               </a:ext>
             </a:extLst>
           </p:cNvPr>
@@ -19539,7 +19539,7 @@
     </p:spTree>
     <p:extLst>
       <p:ext uri="{BB962C8B-B14F-4D97-AF65-F5344CB8AC3E}">
-        <p14:creationId xmlns:p14="http://schemas.microsoft.com/office/powerpoint/2010/main" val="1699279324"/>
+        <p14:creationId xmlns:p14="http://schemas.microsoft.com/office/powerpoint/2010/main" val="889992219"/>
       </p:ext>
     </p:extLst>
   </p:cSld>
@@ -19570,7 +19570,7 @@
           <p:cNvPr id="8" name="Opgave 7d: waarom kopers vertrekken">
             <a:extLst xmlns:a="http://schemas.openxmlformats.org/drawingml/2006/main">
               <a:ext uri="{FF2B5EF4-FFF2-40B4-BE49-F238E27FC236}">
-                <a16:creationId xmlns:a16="http://schemas.microsoft.com/office/drawing/2014/main" id="{635EAD69-B117-4FEB-908F-AD980FB3E9C4}"/>
+                <a16:creationId xmlns:a16="http://schemas.microsoft.com/office/drawing/2014/main" id="{6CA3B597-C8F5-4AB6-8DCD-3EFD957D4D57}"/>
               </a:ext>
             </a:extLst>
           </p:cNvPr>
@@ -19627,7 +19627,7 @@
           <p:cNvPr id="2" name="">
             <a:extLst xmlns:a="http://schemas.openxmlformats.org/drawingml/2006/main">
               <a:ext uri="{FF2B5EF4-FFF2-40B4-BE49-F238E27FC236}">
-                <a16:creationId xmlns:a16="http://schemas.microsoft.com/office/drawing/2014/main" id="{523197D1-ECAD-46B7-8064-257BB4F7BC4F}"/>
+                <a16:creationId xmlns:a16="http://schemas.microsoft.com/office/drawing/2014/main" id="{C5C2D860-7348-4986-BA1D-E902773B7CBA}"/>
               </a:ext>
             </a:extLst>
           </p:cNvPr>
@@ -19656,7 +19656,7 @@
           <p:cNvPr id="3" name="§3.2.1 Volkomen concurrentie · Opgave 7 · Boekpagina 60">
             <a:extLst xmlns:a="http://schemas.openxmlformats.org/drawingml/2006/main">
               <a:ext uri="{FF2B5EF4-FFF2-40B4-BE49-F238E27FC236}">
-                <a16:creationId xmlns:a16="http://schemas.microsoft.com/office/drawing/2014/main" id="{4C3CF28D-3AF2-43E1-B4DC-A191A4AA145A}"/>
+                <a16:creationId xmlns:a16="http://schemas.microsoft.com/office/drawing/2014/main" id="{C549BAFA-DD20-49BC-9D4E-99D28A18FCF2}"/>
               </a:ext>
             </a:extLst>
           </p:cNvPr>
@@ -19713,7 +19713,7 @@
           <p:cNvPr id="4" name="23">
             <a:extLst xmlns:a="http://schemas.openxmlformats.org/drawingml/2006/main">
               <a:ext uri="{FF2B5EF4-FFF2-40B4-BE49-F238E27FC236}">
-                <a16:creationId xmlns:a16="http://schemas.microsoft.com/office/drawing/2014/main" id="{3C52DC16-4EF1-4DB8-981E-E7C15709FE43}"/>
+                <a16:creationId xmlns:a16="http://schemas.microsoft.com/office/drawing/2014/main" id="{D0CAC177-7528-4633-8AFC-0461EAB4810B}"/>
               </a:ext>
             </a:extLst>
           </p:cNvPr>
@@ -19942,7 +19942,7 @@
           <p:cNvPr id="6" name="Kopers kennen de prijzen en kunnen elders kopen.">
             <a:extLst xmlns:a="http://schemas.openxmlformats.org/drawingml/2006/main">
               <a:ext uri="{FF2B5EF4-FFF2-40B4-BE49-F238E27FC236}">
-                <a16:creationId xmlns:a16="http://schemas.microsoft.com/office/drawing/2014/main" id="{D60E030E-C447-491F-B451-17D360DA98DB}"/>
+                <a16:creationId xmlns:a16="http://schemas.microsoft.com/office/drawing/2014/main" id="{322A1AE0-37DD-4768-B23B-96205DDAD94F}"/>
               </a:ext>
             </a:extLst>
           </p:cNvPr>
@@ -19999,7 +19999,7 @@
           <p:cNvPr id="7" name="Daarom verliest Mila in dit model haar kopers.">
             <a:extLst xmlns:a="http://schemas.openxmlformats.org/drawingml/2006/main">
               <a:ext uri="{FF2B5EF4-FFF2-40B4-BE49-F238E27FC236}">
-                <a16:creationId xmlns:a16="http://schemas.microsoft.com/office/drawing/2014/main" id="{16FB5C3D-B921-4785-B6BC-C06177A7E5BC}"/>
+                <a16:creationId xmlns:a16="http://schemas.microsoft.com/office/drawing/2014/main" id="{F0614090-7FEF-4E00-A85F-39DADBE27BE4}"/>
               </a:ext>
             </a:extLst>
           </p:cNvPr>
@@ -20054,7 +20054,7 @@
     </p:spTree>
     <p:extLst>
       <p:ext uri="{BB962C8B-B14F-4D97-AF65-F5344CB8AC3E}">
-        <p14:creationId xmlns:p14="http://schemas.microsoft.com/office/powerpoint/2010/main" val="316104709"/>
+        <p14:creationId xmlns:p14="http://schemas.microsoft.com/office/powerpoint/2010/main" val="1327571332"/>
       </p:ext>
     </p:extLst>
   </p:cSld>
@@ -20085,7 +20085,7 @@
           <p:cNvPr id="8" name="Opgave 7e: Q is de markt, q is Mila">
             <a:extLst xmlns:a="http://schemas.openxmlformats.org/drawingml/2006/main">
               <a:ext uri="{FF2B5EF4-FFF2-40B4-BE49-F238E27FC236}">
-                <a16:creationId xmlns:a16="http://schemas.microsoft.com/office/drawing/2014/main" id="{7DF4B1C2-01B2-4AC1-A996-F0DCA33F5590}"/>
+                <a16:creationId xmlns:a16="http://schemas.microsoft.com/office/drawing/2014/main" id="{3983E614-4E28-42C7-B0FE-9AB9AD6651AD}"/>
               </a:ext>
             </a:extLst>
           </p:cNvPr>
@@ -20142,7 +20142,7 @@
           <p:cNvPr id="2" name="">
             <a:extLst xmlns:a="http://schemas.openxmlformats.org/drawingml/2006/main">
               <a:ext uri="{FF2B5EF4-FFF2-40B4-BE49-F238E27FC236}">
-                <a16:creationId xmlns:a16="http://schemas.microsoft.com/office/drawing/2014/main" id="{AC27947B-7515-43AD-B97B-DF1F3AC3CF0D}"/>
+                <a16:creationId xmlns:a16="http://schemas.microsoft.com/office/drawing/2014/main" id="{71112F1F-ADC6-409C-9082-FFA26FD570B0}"/>
               </a:ext>
             </a:extLst>
           </p:cNvPr>
@@ -20171,7 +20171,7 @@
           <p:cNvPr id="3" name="§3.2.1 Volkomen concurrentie · Opgave 7 · Boekpagina 60">
             <a:extLst xmlns:a="http://schemas.openxmlformats.org/drawingml/2006/main">
               <a:ext uri="{FF2B5EF4-FFF2-40B4-BE49-F238E27FC236}">
-                <a16:creationId xmlns:a16="http://schemas.microsoft.com/office/drawing/2014/main" id="{1D5E8B95-E7F4-4997-9351-B6BBBB811649}"/>
+                <a16:creationId xmlns:a16="http://schemas.microsoft.com/office/drawing/2014/main" id="{01CF83C7-54A2-4FA3-8C2E-D68F1A6EFD94}"/>
               </a:ext>
             </a:extLst>
           </p:cNvPr>
@@ -20228,7 +20228,7 @@
           <p:cNvPr id="4" name="24">
             <a:extLst xmlns:a="http://schemas.openxmlformats.org/drawingml/2006/main">
               <a:ext uri="{FF2B5EF4-FFF2-40B4-BE49-F238E27FC236}">
-                <a16:creationId xmlns:a16="http://schemas.microsoft.com/office/drawing/2014/main" id="{FC852352-0324-45E1-A8BE-A4902A11D857}"/>
+                <a16:creationId xmlns:a16="http://schemas.microsoft.com/office/drawing/2014/main" id="{0A480F1B-9FCB-4AD5-976D-8A847CCD44A1}"/>
               </a:ext>
             </a:extLst>
           </p:cNvPr>
@@ -20507,7 +20507,7 @@
           <p:cNvPr id="6" name="Alleen de prijs verhuist naar Mila’s grafiek.">
             <a:extLst xmlns:a="http://schemas.openxmlformats.org/drawingml/2006/main">
               <a:ext uri="{FF2B5EF4-FFF2-40B4-BE49-F238E27FC236}">
-                <a16:creationId xmlns:a16="http://schemas.microsoft.com/office/drawing/2014/main" id="{4BA73C04-F70A-4A5B-8C3B-E25409FD3F00}"/>
+                <a16:creationId xmlns:a16="http://schemas.microsoft.com/office/drawing/2014/main" id="{1F41B6CE-CB94-4FF9-9B86-D1D0A20604A0}"/>
               </a:ext>
             </a:extLst>
           </p:cNvPr>
@@ -20564,7 +20564,7 @@
           <p:cNvPr id="7" name="Haar lijn eindigt bij q = 160, niet bij de markthoeveelheid.">
             <a:extLst xmlns:a="http://schemas.openxmlformats.org/drawingml/2006/main">
               <a:ext uri="{FF2B5EF4-FFF2-40B4-BE49-F238E27FC236}">
-                <a16:creationId xmlns:a16="http://schemas.microsoft.com/office/drawing/2014/main" id="{7B46E9E1-1D48-4B98-8D83-97D8E8D3490E}"/>
+                <a16:creationId xmlns:a16="http://schemas.microsoft.com/office/drawing/2014/main" id="{1D24F023-7BD8-4A8B-BF8C-1A159762F0F7}"/>
               </a:ext>
             </a:extLst>
           </p:cNvPr>
@@ -20619,7 +20619,7 @@
     </p:spTree>
     <p:extLst>
       <p:ext uri="{BB962C8B-B14F-4D97-AF65-F5344CB8AC3E}">
-        <p14:creationId xmlns:p14="http://schemas.microsoft.com/office/powerpoint/2010/main" val="1320961649"/>
+        <p14:creationId xmlns:p14="http://schemas.microsoft.com/office/powerpoint/2010/main" val="1960501021"/>
       </p:ext>
     </p:extLst>
   </p:cSld>
@@ -20647,10 +20647,10 @@
       </p:grpSpPr>
       <p:sp>
         <p:nvSpPr>
-          <p:cNvPr id="29" name="Deze les: §3.2.1 Volkomen concurrentie">
+          <p:cNvPr id="29" name="Deze les: §3.2.1 Volkomen concurrentie: kenmerken">
             <a:extLst xmlns:a="http://schemas.openxmlformats.org/drawingml/2006/main">
               <a:ext uri="{FF2B5EF4-FFF2-40B4-BE49-F238E27FC236}">
-                <a16:creationId xmlns:a16="http://schemas.microsoft.com/office/drawing/2014/main" id="{3D7DC11B-F6A7-45FB-9B67-F2FC62B85B0C}"/>
+                <a16:creationId xmlns:a16="http://schemas.microsoft.com/office/drawing/2014/main" id="{A46C5C64-A02F-4540-9967-A5894C976CA6}"/>
               </a:ext>
             </a:extLst>
           </p:cNvPr>
@@ -20697,7 +20697,7 @@
                 <a:ea typeface="Arial"/>
                 <a:cs typeface="Arial"/>
               </a:rPr>
-              <a:t>Deze les: §3.2.1 Volkomen concurrentie</a:t>
+              <a:t>Deze les: §3.2.1 Volkomen concurrentie: kenmerken</a:t>
             </a:r>
           </a:p>
         </p:txBody>
@@ -20707,7 +20707,7 @@
           <p:cNvPr id="2" name="">
             <a:extLst xmlns:a="http://schemas.openxmlformats.org/drawingml/2006/main">
               <a:ext uri="{FF2B5EF4-FFF2-40B4-BE49-F238E27FC236}">
-                <a16:creationId xmlns:a16="http://schemas.microsoft.com/office/drawing/2014/main" id="{F191F464-F5F1-4A3C-ACDF-740955426E43}"/>
+                <a16:creationId xmlns:a16="http://schemas.microsoft.com/office/drawing/2014/main" id="{83F49931-9EB3-42CA-A609-919D7ECDDA27}"/>
               </a:ext>
             </a:extLst>
           </p:cNvPr>
@@ -20736,7 +20736,7 @@
           <p:cNvPr id="3" name="§3.2.1 Volkomen concurrentie">
             <a:extLst xmlns:a="http://schemas.openxmlformats.org/drawingml/2006/main">
               <a:ext uri="{FF2B5EF4-FFF2-40B4-BE49-F238E27FC236}">
-                <a16:creationId xmlns:a16="http://schemas.microsoft.com/office/drawing/2014/main" id="{D91FF988-F764-4B6A-8A15-56FA4ED4E6FF}"/>
+                <a16:creationId xmlns:a16="http://schemas.microsoft.com/office/drawing/2014/main" id="{4102A648-443B-4521-A1C0-B9DEA448AEF3}"/>
               </a:ext>
             </a:extLst>
           </p:cNvPr>
@@ -20793,7 +20793,7 @@
           <p:cNvPr id="4" name="25">
             <a:extLst xmlns:a="http://schemas.openxmlformats.org/drawingml/2006/main">
               <a:ext uri="{FF2B5EF4-FFF2-40B4-BE49-F238E27FC236}">
-                <a16:creationId xmlns:a16="http://schemas.microsoft.com/office/drawing/2014/main" id="{A13E0ECA-9F10-4E41-96D6-7FB386B2709E}"/>
+                <a16:creationId xmlns:a16="http://schemas.microsoft.com/office/drawing/2014/main" id="{BA6240D5-56AA-4BA4-9FF2-2BA9FE855E2B}"/>
               </a:ext>
             </a:extLst>
           </p:cNvPr>
@@ -20850,7 +20850,7 @@
           <p:cNvPr id="5" name="phase">
             <a:extLst xmlns:a="http://schemas.openxmlformats.org/drawingml/2006/main">
               <a:ext uri="{FF2B5EF4-FFF2-40B4-BE49-F238E27FC236}">
-                <a16:creationId xmlns:a16="http://schemas.microsoft.com/office/drawing/2014/main" id="{36C7773B-16C3-4188-B787-188B428591F9}"/>
+                <a16:creationId xmlns:a16="http://schemas.microsoft.com/office/drawing/2014/main" id="{ECE3E649-6BA6-4875-910C-97CAA55267A5}"/>
               </a:ext>
             </a:extLst>
           </p:cNvPr>
@@ -20907,7 +20907,7 @@
           <p:cNvPr id="6" name="Lesroute">
             <a:extLst xmlns:a="http://schemas.openxmlformats.org/drawingml/2006/main">
               <a:ext uri="{FF2B5EF4-FFF2-40B4-BE49-F238E27FC236}">
-                <a16:creationId xmlns:a16="http://schemas.microsoft.com/office/drawing/2014/main" id="{741DA4C2-6E24-40F8-8931-501F529885CD}"/>
+                <a16:creationId xmlns:a16="http://schemas.microsoft.com/office/drawing/2014/main" id="{3127B19B-DE6F-44D4-95F6-2DDEEBB7923B}"/>
               </a:ext>
             </a:extLst>
           </p:cNvPr>
@@ -20964,7 +20964,7 @@
           <p:cNvPr id="7" name="route-number-1">
             <a:extLst xmlns:a="http://schemas.openxmlformats.org/drawingml/2006/main">
               <a:ext uri="{FF2B5EF4-FFF2-40B4-BE49-F238E27FC236}">
-                <a16:creationId xmlns:a16="http://schemas.microsoft.com/office/drawing/2014/main" id="{3EDC69B8-BDF6-4296-B7F9-EAEAA882BE0A}"/>
+                <a16:creationId xmlns:a16="http://schemas.microsoft.com/office/drawing/2014/main" id="{F007C083-980D-48CB-BFED-FEE49948D279}"/>
               </a:ext>
             </a:extLst>
           </p:cNvPr>
@@ -21021,7 +21021,7 @@
           <p:cNvPr id="8" name="route-1">
             <a:extLst xmlns:a="http://schemas.openxmlformats.org/drawingml/2006/main">
               <a:ext uri="{FF2B5EF4-FFF2-40B4-BE49-F238E27FC236}">
-                <a16:creationId xmlns:a16="http://schemas.microsoft.com/office/drawing/2014/main" id="{96ED73E8-7586-4EFF-B112-8152637E2207}"/>
+                <a16:creationId xmlns:a16="http://schemas.microsoft.com/office/drawing/2014/main" id="{C828A1A8-6347-4C8E-8994-637AECE07488}"/>
               </a:ext>
             </a:extLst>
           </p:cNvPr>
@@ -21078,7 +21078,7 @@
           <p:cNvPr id="9" name="route-number-2">
             <a:extLst xmlns:a="http://schemas.openxmlformats.org/drawingml/2006/main">
               <a:ext uri="{FF2B5EF4-FFF2-40B4-BE49-F238E27FC236}">
-                <a16:creationId xmlns:a16="http://schemas.microsoft.com/office/drawing/2014/main" id="{9ADB6028-93B6-4AB7-ABAE-8E6EA7D8BF36}"/>
+                <a16:creationId xmlns:a16="http://schemas.microsoft.com/office/drawing/2014/main" id="{834CB212-A81C-40A9-9E89-99B9D75B39C9}"/>
               </a:ext>
             </a:extLst>
           </p:cNvPr>
@@ -21135,7 +21135,7 @@
           <p:cNvPr id="10" name="route-2">
             <a:extLst xmlns:a="http://schemas.openxmlformats.org/drawingml/2006/main">
               <a:ext uri="{FF2B5EF4-FFF2-40B4-BE49-F238E27FC236}">
-                <a16:creationId xmlns:a16="http://schemas.microsoft.com/office/drawing/2014/main" id="{541DC087-0589-4D63-88D3-BFB827C21EF0}"/>
+                <a16:creationId xmlns:a16="http://schemas.microsoft.com/office/drawing/2014/main" id="{4E746FB7-D3D8-4162-9266-1E2082A1AC34}"/>
               </a:ext>
             </a:extLst>
           </p:cNvPr>
@@ -21192,7 +21192,7 @@
           <p:cNvPr id="11" name="route-number-3">
             <a:extLst xmlns:a="http://schemas.openxmlformats.org/drawingml/2006/main">
               <a:ext uri="{FF2B5EF4-FFF2-40B4-BE49-F238E27FC236}">
-                <a16:creationId xmlns:a16="http://schemas.microsoft.com/office/drawing/2014/main" id="{E9D64381-9B56-4F9F-9522-5859F36649BE}"/>
+                <a16:creationId xmlns:a16="http://schemas.microsoft.com/office/drawing/2014/main" id="{7DC9C8ED-1C08-4892-A98B-C3E638B010C7}"/>
               </a:ext>
             </a:extLst>
           </p:cNvPr>
@@ -21249,7 +21249,7 @@
           <p:cNvPr id="12" name="route-3">
             <a:extLst xmlns:a="http://schemas.openxmlformats.org/drawingml/2006/main">
               <a:ext uri="{FF2B5EF4-FFF2-40B4-BE49-F238E27FC236}">
-                <a16:creationId xmlns:a16="http://schemas.microsoft.com/office/drawing/2014/main" id="{EEFF2180-68B3-4DCA-B419-B07821869E64}"/>
+                <a16:creationId xmlns:a16="http://schemas.microsoft.com/office/drawing/2014/main" id="{AA4A2FC4-725E-4424-9CB8-1845975962BE}"/>
               </a:ext>
             </a:extLst>
           </p:cNvPr>
@@ -21306,7 +21306,7 @@
           <p:cNvPr id="13" name="route-number-4">
             <a:extLst xmlns:a="http://schemas.openxmlformats.org/drawingml/2006/main">
               <a:ext uri="{FF2B5EF4-FFF2-40B4-BE49-F238E27FC236}">
-                <a16:creationId xmlns:a16="http://schemas.microsoft.com/office/drawing/2014/main" id="{38FDA5A1-761F-4045-AAF4-74363F66794B}"/>
+                <a16:creationId xmlns:a16="http://schemas.microsoft.com/office/drawing/2014/main" id="{A112EF1E-B704-4C1C-93E3-AECBFAC2DF34}"/>
               </a:ext>
             </a:extLst>
           </p:cNvPr>
@@ -21363,7 +21363,7 @@
           <p:cNvPr id="14" name="route-4">
             <a:extLst xmlns:a="http://schemas.openxmlformats.org/drawingml/2006/main">
               <a:ext uri="{FF2B5EF4-FFF2-40B4-BE49-F238E27FC236}">
-                <a16:creationId xmlns:a16="http://schemas.microsoft.com/office/drawing/2014/main" id="{70D215C3-D647-4138-854C-D76FBBA0EBF2}"/>
+                <a16:creationId xmlns:a16="http://schemas.microsoft.com/office/drawing/2014/main" id="{28796F3A-CA17-48BD-8C30-7A8640599F96}"/>
               </a:ext>
             </a:extLst>
           </p:cNvPr>
@@ -21420,7 +21420,7 @@
           <p:cNvPr id="15" name="route-number-5">
             <a:extLst xmlns:a="http://schemas.openxmlformats.org/drawingml/2006/main">
               <a:ext uri="{FF2B5EF4-FFF2-40B4-BE49-F238E27FC236}">
-                <a16:creationId xmlns:a16="http://schemas.microsoft.com/office/drawing/2014/main" id="{9886365C-5688-4634-A11E-0038C3E1DCBC}"/>
+                <a16:creationId xmlns:a16="http://schemas.microsoft.com/office/drawing/2014/main" id="{FC5990C7-3ED1-4E09-BDB5-9D9572FEC8C7}"/>
               </a:ext>
             </a:extLst>
           </p:cNvPr>
@@ -21477,7 +21477,7 @@
           <p:cNvPr id="16" name="route-5">
             <a:extLst xmlns:a="http://schemas.openxmlformats.org/drawingml/2006/main">
               <a:ext uri="{FF2B5EF4-FFF2-40B4-BE49-F238E27FC236}">
-                <a16:creationId xmlns:a16="http://schemas.microsoft.com/office/drawing/2014/main" id="{2DA18709-0A01-4A35-889D-8207C22EAAB6}"/>
+                <a16:creationId xmlns:a16="http://schemas.microsoft.com/office/drawing/2014/main" id="{ED8593A3-B3A2-4733-BBC7-D56499AD35BD}"/>
               </a:ext>
             </a:extLst>
           </p:cNvPr>
@@ -21534,7 +21534,7 @@
           <p:cNvPr id="17" name="route-number-6">
             <a:extLst xmlns:a="http://schemas.openxmlformats.org/drawingml/2006/main">
               <a:ext uri="{FF2B5EF4-FFF2-40B4-BE49-F238E27FC236}">
-                <a16:creationId xmlns:a16="http://schemas.microsoft.com/office/drawing/2014/main" id="{13939BB9-4978-4568-A547-62E7540FE13C}"/>
+                <a16:creationId xmlns:a16="http://schemas.microsoft.com/office/drawing/2014/main" id="{8225EA4F-F03D-4446-B657-6F1ABC42FA35}"/>
               </a:ext>
             </a:extLst>
           </p:cNvPr>
@@ -21591,7 +21591,7 @@
           <p:cNvPr id="18" name="route-6">
             <a:extLst xmlns:a="http://schemas.openxmlformats.org/drawingml/2006/main">
               <a:ext uri="{FF2B5EF4-FFF2-40B4-BE49-F238E27FC236}">
-                <a16:creationId xmlns:a16="http://schemas.microsoft.com/office/drawing/2014/main" id="{43C84A80-4B3D-4E5F-B595-F82B90A001E2}"/>
+                <a16:creationId xmlns:a16="http://schemas.microsoft.com/office/drawing/2014/main" id="{A424D154-F7C9-4998-8BFB-F45EEB9B7CF6}"/>
               </a:ext>
             </a:extLst>
           </p:cNvPr>
@@ -21648,7 +21648,7 @@
           <p:cNvPr id="19" name="route-number-7">
             <a:extLst xmlns:a="http://schemas.openxmlformats.org/drawingml/2006/main">
               <a:ext uri="{FF2B5EF4-FFF2-40B4-BE49-F238E27FC236}">
-                <a16:creationId xmlns:a16="http://schemas.microsoft.com/office/drawing/2014/main" id="{273B7E21-04BC-47B8-8126-5B1306A8AC0E}"/>
+                <a16:creationId xmlns:a16="http://schemas.microsoft.com/office/drawing/2014/main" id="{905E5304-7BB5-4D65-952D-B2D9E8357524}"/>
               </a:ext>
             </a:extLst>
           </p:cNvPr>
@@ -21705,7 +21705,7 @@
           <p:cNvPr id="20" name="route-7">
             <a:extLst xmlns:a="http://schemas.openxmlformats.org/drawingml/2006/main">
               <a:ext uri="{FF2B5EF4-FFF2-40B4-BE49-F238E27FC236}">
-                <a16:creationId xmlns:a16="http://schemas.microsoft.com/office/drawing/2014/main" id="{1EA544F1-8627-43D8-9335-96D4754D0EDC}"/>
+                <a16:creationId xmlns:a16="http://schemas.microsoft.com/office/drawing/2014/main" id="{EBCAD8BC-7184-422D-92A8-D967365B6428}"/>
               </a:ext>
             </a:extLst>
           </p:cNvPr>
@@ -21762,7 +21762,7 @@
           <p:cNvPr id="21" name="Lesdoelen">
             <a:extLst xmlns:a="http://schemas.openxmlformats.org/drawingml/2006/main">
               <a:ext uri="{FF2B5EF4-FFF2-40B4-BE49-F238E27FC236}">
-                <a16:creationId xmlns:a16="http://schemas.microsoft.com/office/drawing/2014/main" id="{8445781E-25F8-4BF8-963A-3991E50CAAB1}"/>
+                <a16:creationId xmlns:a16="http://schemas.microsoft.com/office/drawing/2014/main" id="{24F70C6A-8165-4E02-923C-E12EB960C6E2}"/>
               </a:ext>
             </a:extLst>
           </p:cNvPr>
@@ -21819,7 +21819,7 @@
           <p:cNvPr id="22" name="overview-goals">
             <a:extLst xmlns:a="http://schemas.openxmlformats.org/drawingml/2006/main">
               <a:ext uri="{FF2B5EF4-FFF2-40B4-BE49-F238E27FC236}">
-                <a16:creationId xmlns:a16="http://schemas.microsoft.com/office/drawing/2014/main" id="{D544A412-3182-462B-938A-53640326A9D8}"/>
+                <a16:creationId xmlns:a16="http://schemas.microsoft.com/office/drawing/2014/main" id="{92BFE1ED-7B6C-48D3-A70D-83F6100369D9}"/>
               </a:ext>
             </a:extLst>
           </p:cNvPr>
@@ -21945,7 +21945,7 @@
           <p:cNvPr id="23" name="">
             <a:extLst xmlns:a="http://schemas.openxmlformats.org/drawingml/2006/main">
               <a:ext uri="{FF2B5EF4-FFF2-40B4-BE49-F238E27FC236}">
-                <a16:creationId xmlns:a16="http://schemas.microsoft.com/office/drawing/2014/main" id="{97694EBC-6D91-4543-B77A-43AB4689E64D}"/>
+                <a16:creationId xmlns:a16="http://schemas.microsoft.com/office/drawing/2014/main" id="{EB67198A-179C-430B-A181-AA06E37C10BD}"/>
               </a:ext>
             </a:extLst>
           </p:cNvPr>
@@ -21974,7 +21974,7 @@
           <p:cNvPr id="24" name="Startopdracht">
             <a:extLst xmlns:a="http://schemas.openxmlformats.org/drawingml/2006/main">
               <a:ext uri="{FF2B5EF4-FFF2-40B4-BE49-F238E27FC236}">
-                <a16:creationId xmlns:a16="http://schemas.microsoft.com/office/drawing/2014/main" id="{953A27E9-1A42-43A4-B150-6E5A5655E16E}"/>
+                <a16:creationId xmlns:a16="http://schemas.microsoft.com/office/drawing/2014/main" id="{441C8877-511D-4B4C-BFAF-B20FB80EB3FA}"/>
               </a:ext>
             </a:extLst>
           </p:cNvPr>
@@ -22031,7 +22031,7 @@
           <p:cNvPr id="25" name="overview-start">
             <a:extLst xmlns:a="http://schemas.openxmlformats.org/drawingml/2006/main">
               <a:ext uri="{FF2B5EF4-FFF2-40B4-BE49-F238E27FC236}">
-                <a16:creationId xmlns:a16="http://schemas.microsoft.com/office/drawing/2014/main" id="{A0834B47-EE60-44FE-8600-941608ADCBD4}"/>
+                <a16:creationId xmlns:a16="http://schemas.microsoft.com/office/drawing/2014/main" id="{14DADEF6-54EE-41F1-A34E-AEFF44A27AEC}"/>
               </a:ext>
             </a:extLst>
           </p:cNvPr>
@@ -22134,7 +22134,7 @@
           <p:cNvPr id="26" name="">
             <a:extLst xmlns:a="http://schemas.openxmlformats.org/drawingml/2006/main">
               <a:ext uri="{FF2B5EF4-FFF2-40B4-BE49-F238E27FC236}">
-                <a16:creationId xmlns:a16="http://schemas.microsoft.com/office/drawing/2014/main" id="{DCE3E21C-5185-46EB-B9F5-D27BBAE3032B}"/>
+                <a16:creationId xmlns:a16="http://schemas.microsoft.com/office/drawing/2014/main" id="{544C7435-349B-4102-9AB0-D85466476007}"/>
               </a:ext>
             </a:extLst>
           </p:cNvPr>
@@ -22163,7 +22163,7 @@
           <p:cNvPr id="27" name="Huiswerk">
             <a:extLst xmlns:a="http://schemas.openxmlformats.org/drawingml/2006/main">
               <a:ext uri="{FF2B5EF4-FFF2-40B4-BE49-F238E27FC236}">
-                <a16:creationId xmlns:a16="http://schemas.microsoft.com/office/drawing/2014/main" id="{DF8FA2D3-3792-4EF2-B9A2-23F459199E2C}"/>
+                <a16:creationId xmlns:a16="http://schemas.microsoft.com/office/drawing/2014/main" id="{2ADDCFCB-201F-42FC-81F0-6EC7CFECD139}"/>
               </a:ext>
             </a:extLst>
           </p:cNvPr>
@@ -22220,7 +22220,7 @@
           <p:cNvPr id="28" name="overview-homework">
             <a:extLst xmlns:a="http://schemas.openxmlformats.org/drawingml/2006/main">
               <a:ext uri="{FF2B5EF4-FFF2-40B4-BE49-F238E27FC236}">
-                <a16:creationId xmlns:a16="http://schemas.microsoft.com/office/drawing/2014/main" id="{BC68DD49-0AE8-45FE-9D7A-68186C0DC375}"/>
+                <a16:creationId xmlns:a16="http://schemas.microsoft.com/office/drawing/2014/main" id="{00874E3B-D8A3-44A3-A2EB-6092C7CFB033}"/>
               </a:ext>
             </a:extLst>
           </p:cNvPr>
@@ -22367,7 +22367,7 @@
     </p:spTree>
     <p:extLst>
       <p:ext uri="{BB962C8B-B14F-4D97-AF65-F5344CB8AC3E}">
-        <p14:creationId xmlns:p14="http://schemas.microsoft.com/office/powerpoint/2010/main" val="300535194"/>
+        <p14:creationId xmlns:p14="http://schemas.microsoft.com/office/powerpoint/2010/main" val="37447283"/>
       </p:ext>
     </p:extLst>
   </p:cSld>
@@ -22398,7 +22398,7 @@
           <p:cNvPr id="7" name="Vier kenmerken van volkomen concurrentie">
             <a:extLst xmlns:a="http://schemas.openxmlformats.org/drawingml/2006/main">
               <a:ext uri="{FF2B5EF4-FFF2-40B4-BE49-F238E27FC236}">
-                <a16:creationId xmlns:a16="http://schemas.microsoft.com/office/drawing/2014/main" id="{BB124F73-6482-4E7A-86B5-126923999F3A}"/>
+                <a16:creationId xmlns:a16="http://schemas.microsoft.com/office/drawing/2014/main" id="{435FD289-1085-415A-9844-CAA47DC8AED7}"/>
               </a:ext>
             </a:extLst>
           </p:cNvPr>
@@ -22455,7 +22455,7 @@
           <p:cNvPr id="2" name="">
             <a:extLst xmlns:a="http://schemas.openxmlformats.org/drawingml/2006/main">
               <a:ext uri="{FF2B5EF4-FFF2-40B4-BE49-F238E27FC236}">
-                <a16:creationId xmlns:a16="http://schemas.microsoft.com/office/drawing/2014/main" id="{65B02130-860F-4E5A-846A-74AEE7D50FEB}"/>
+                <a16:creationId xmlns:a16="http://schemas.microsoft.com/office/drawing/2014/main" id="{E18455BE-EC2A-4409-87CC-5916AC726F28}"/>
               </a:ext>
             </a:extLst>
           </p:cNvPr>
@@ -22484,7 +22484,7 @@
           <p:cNvPr id="3" name="§3.2.1 Volkomen concurrentie">
             <a:extLst xmlns:a="http://schemas.openxmlformats.org/drawingml/2006/main">
               <a:ext uri="{FF2B5EF4-FFF2-40B4-BE49-F238E27FC236}">
-                <a16:creationId xmlns:a16="http://schemas.microsoft.com/office/drawing/2014/main" id="{6A18C5A0-CF36-48D3-8D98-C6B81D2BA712}"/>
+                <a16:creationId xmlns:a16="http://schemas.microsoft.com/office/drawing/2014/main" id="{D24B90C1-C20B-4ACE-BB26-7CBCF2F82A89}"/>
               </a:ext>
             </a:extLst>
           </p:cNvPr>
@@ -22541,7 +22541,7 @@
           <p:cNvPr id="4" name="3">
             <a:extLst xmlns:a="http://schemas.openxmlformats.org/drawingml/2006/main">
               <a:ext uri="{FF2B5EF4-FFF2-40B4-BE49-F238E27FC236}">
-                <a16:creationId xmlns:a16="http://schemas.microsoft.com/office/drawing/2014/main" id="{F0BDC0E3-F582-4ECA-8EFB-6A2DECE44595}"/>
+                <a16:creationId xmlns:a16="http://schemas.microsoft.com/office/drawing/2014/main" id="{0C01DD49-3EE8-4567-A403-9154D29F2A8C}"/>
               </a:ext>
             </a:extLst>
           </p:cNvPr>
@@ -22870,7 +22870,7 @@
           <p:cNvPr id="6" name="Eén onderneming is prijsnemer.">
             <a:extLst xmlns:a="http://schemas.openxmlformats.org/drawingml/2006/main">
               <a:ext uri="{FF2B5EF4-FFF2-40B4-BE49-F238E27FC236}">
-                <a16:creationId xmlns:a16="http://schemas.microsoft.com/office/drawing/2014/main" id="{F8F3852F-829A-4A4B-A56D-0EC8756FD811}"/>
+                <a16:creationId xmlns:a16="http://schemas.microsoft.com/office/drawing/2014/main" id="{8B1291C2-6ECE-4D7C-B85C-EEEB52F29021}"/>
               </a:ext>
             </a:extLst>
           </p:cNvPr>
@@ -22925,7 +22925,7 @@
     </p:spTree>
     <p:extLst>
       <p:ext uri="{BB962C8B-B14F-4D97-AF65-F5344CB8AC3E}">
-        <p14:creationId xmlns:p14="http://schemas.microsoft.com/office/powerpoint/2010/main" val="1076173106"/>
+        <p14:creationId xmlns:p14="http://schemas.microsoft.com/office/powerpoint/2010/main" val="757089481"/>
       </p:ext>
     </p:extLst>
   </p:cSld>
@@ -22956,7 +22956,7 @@
           <p:cNvPr id="9" name="De havermarkt">
             <a:extLst xmlns:a="http://schemas.openxmlformats.org/drawingml/2006/main">
               <a:ext uri="{FF2B5EF4-FFF2-40B4-BE49-F238E27FC236}">
-                <a16:creationId xmlns:a16="http://schemas.microsoft.com/office/drawing/2014/main" id="{2D5462B3-7C8B-4B53-A2A2-B71291E6F210}"/>
+                <a16:creationId xmlns:a16="http://schemas.microsoft.com/office/drawing/2014/main" id="{8964DB98-593D-4781-B2E8-B4D1DE6D25A9}"/>
               </a:ext>
             </a:extLst>
           </p:cNvPr>
@@ -23013,7 +23013,7 @@
           <p:cNvPr id="2" name="">
             <a:extLst xmlns:a="http://schemas.openxmlformats.org/drawingml/2006/main">
               <a:ext uri="{FF2B5EF4-FFF2-40B4-BE49-F238E27FC236}">
-                <a16:creationId xmlns:a16="http://schemas.microsoft.com/office/drawing/2014/main" id="{DA083C77-32E3-48BE-9228-E3AE38D5983D}"/>
+                <a16:creationId xmlns:a16="http://schemas.microsoft.com/office/drawing/2014/main" id="{38AACA63-7720-4E27-9052-45A556F7231B}"/>
               </a:ext>
             </a:extLst>
           </p:cNvPr>
@@ -23042,7 +23042,7 @@
           <p:cNvPr id="3" name="§3.2.1 Volkomen concurrentie">
             <a:extLst xmlns:a="http://schemas.openxmlformats.org/drawingml/2006/main">
               <a:ext uri="{FF2B5EF4-FFF2-40B4-BE49-F238E27FC236}">
-                <a16:creationId xmlns:a16="http://schemas.microsoft.com/office/drawing/2014/main" id="{BB552B11-1826-4083-BD15-919721161C47}"/>
+                <a16:creationId xmlns:a16="http://schemas.microsoft.com/office/drawing/2014/main" id="{97588646-D0B5-4D51-9613-B39D2EBBB0E9}"/>
               </a:ext>
             </a:extLst>
           </p:cNvPr>
@@ -23099,7 +23099,7 @@
           <p:cNvPr id="4" name="4">
             <a:extLst xmlns:a="http://schemas.openxmlformats.org/drawingml/2006/main">
               <a:ext uri="{FF2B5EF4-FFF2-40B4-BE49-F238E27FC236}">
-                <a16:creationId xmlns:a16="http://schemas.microsoft.com/office/drawing/2014/main" id="{13407B0D-C9D5-491E-A6C1-4BB0FA3F98F3}"/>
+                <a16:creationId xmlns:a16="http://schemas.microsoft.com/office/drawing/2014/main" id="{2FA63D95-D154-4728-9A2F-309459649A7C}"/>
               </a:ext>
             </a:extLst>
           </p:cNvPr>
@@ -23156,7 +23156,7 @@
           <p:cNvPr id="5" name="Uitlegvoorbeeld — niet uit het boek">
             <a:extLst xmlns:a="http://schemas.openxmlformats.org/drawingml/2006/main">
               <a:ext uri="{FF2B5EF4-FFF2-40B4-BE49-F238E27FC236}">
-                <a16:creationId xmlns:a16="http://schemas.microsoft.com/office/drawing/2014/main" id="{C88EE72C-4191-4B6E-8892-1E2BCEDE9F3B}"/>
+                <a16:creationId xmlns:a16="http://schemas.microsoft.com/office/drawing/2014/main" id="{3B58AF6D-44A3-4870-8FB4-E6FEDEA53D77}"/>
               </a:ext>
             </a:extLst>
           </p:cNvPr>
@@ -23220,7 +23220,7 @@
         </p:xfrm>
         <a:graphic xmlns:a="http://schemas.openxmlformats.org/drawingml/2006/main">
           <a:graphicData uri="http://schemas.openxmlformats.org/drawingml/2006/chart">
-            <c:chart xmlns:r="http://schemas.openxmlformats.org/officeDocument/2006/relationships" xmlns:c="http://schemas.openxmlformats.org/drawingml/2006/chart" r:id="Ra2e5283c34eb43ac"/>
+            <c:chart xmlns:r="http://schemas.openxmlformats.org/officeDocument/2006/relationships" xmlns:c="http://schemas.openxmlformats.org/drawingml/2006/chart" r:id="R88809efa75eb4d94"/>
           </a:graphicData>
         </a:graphic>
       </p:graphicFrame>
@@ -23229,7 +23229,7 @@
           <p:cNvPr id="7" name="Veel kleine telers&#10;Gelijke kwaliteit&#10;Bekende prijzen&#10;Vrij beginnen of ">
             <a:extLst xmlns:a="http://schemas.openxmlformats.org/drawingml/2006/main">
               <a:ext uri="{FF2B5EF4-FFF2-40B4-BE49-F238E27FC236}">
-                <a16:creationId xmlns:a16="http://schemas.microsoft.com/office/drawing/2014/main" id="{BFC6E021-768D-461A-9D0E-2AFFCC250010}"/>
+                <a16:creationId xmlns:a16="http://schemas.microsoft.com/office/drawing/2014/main" id="{03A85F54-9CF8-438A-9C33-5A2CDB37DE41}"/>
               </a:ext>
             </a:extLst>
           </p:cNvPr>
@@ -23355,7 +23355,7 @@
           <p:cNvPr id="8" name="Q: alle telers samen">
             <a:extLst xmlns:a="http://schemas.openxmlformats.org/drawingml/2006/main">
               <a:ext uri="{FF2B5EF4-FFF2-40B4-BE49-F238E27FC236}">
-                <a16:creationId xmlns:a16="http://schemas.microsoft.com/office/drawing/2014/main" id="{8F3E41E9-729F-4BA9-B905-4B8160784F92}"/>
+                <a16:creationId xmlns:a16="http://schemas.microsoft.com/office/drawing/2014/main" id="{86072416-9FBC-4D8E-8D2C-357C6451850D}"/>
               </a:ext>
             </a:extLst>
           </p:cNvPr>
@@ -23410,7 +23410,7 @@
     </p:spTree>
     <p:extLst>
       <p:ext uri="{BB962C8B-B14F-4D97-AF65-F5344CB8AC3E}">
-        <p14:creationId xmlns:p14="http://schemas.microsoft.com/office/powerpoint/2010/main" val="746285542"/>
+        <p14:creationId xmlns:p14="http://schemas.microsoft.com/office/powerpoint/2010/main" val="1113595499"/>
       </p:ext>
     </p:extLst>
   </p:cSld>
@@ -23441,7 +23441,7 @@
           <p:cNvPr id="9" name="Het marktevenwicht">
             <a:extLst xmlns:a="http://schemas.openxmlformats.org/drawingml/2006/main">
               <a:ext uri="{FF2B5EF4-FFF2-40B4-BE49-F238E27FC236}">
-                <a16:creationId xmlns:a16="http://schemas.microsoft.com/office/drawing/2014/main" id="{194E3B13-2AF1-4DB1-BF00-D40E4C8698A4}"/>
+                <a16:creationId xmlns:a16="http://schemas.microsoft.com/office/drawing/2014/main" id="{D01E8777-5AD3-40DE-BC16-31B85ABAD685}"/>
               </a:ext>
             </a:extLst>
           </p:cNvPr>
@@ -23498,7 +23498,7 @@
           <p:cNvPr id="2" name="">
             <a:extLst xmlns:a="http://schemas.openxmlformats.org/drawingml/2006/main">
               <a:ext uri="{FF2B5EF4-FFF2-40B4-BE49-F238E27FC236}">
-                <a16:creationId xmlns:a16="http://schemas.microsoft.com/office/drawing/2014/main" id="{DB15D505-4DAE-45E0-9300-D4721ACCB68C}"/>
+                <a16:creationId xmlns:a16="http://schemas.microsoft.com/office/drawing/2014/main" id="{29AEC3B7-0816-456D-A998-CF6FBC760634}"/>
               </a:ext>
             </a:extLst>
           </p:cNvPr>
@@ -23527,7 +23527,7 @@
           <p:cNvPr id="3" name="§3.2.1 Volkomen concurrentie">
             <a:extLst xmlns:a="http://schemas.openxmlformats.org/drawingml/2006/main">
               <a:ext uri="{FF2B5EF4-FFF2-40B4-BE49-F238E27FC236}">
-                <a16:creationId xmlns:a16="http://schemas.microsoft.com/office/drawing/2014/main" id="{FCC4970A-54AB-4864-AC9D-120D5528F810}"/>
+                <a16:creationId xmlns:a16="http://schemas.microsoft.com/office/drawing/2014/main" id="{BBF8DEEB-EF89-4CA0-A8DB-74F84A576DFB}"/>
               </a:ext>
             </a:extLst>
           </p:cNvPr>
@@ -23584,7 +23584,7 @@
           <p:cNvPr id="4" name="5">
             <a:extLst xmlns:a="http://schemas.openxmlformats.org/drawingml/2006/main">
               <a:ext uri="{FF2B5EF4-FFF2-40B4-BE49-F238E27FC236}">
-                <a16:creationId xmlns:a16="http://schemas.microsoft.com/office/drawing/2014/main" id="{AD6818E5-D511-4794-94FD-DCC03F7908E4}"/>
+                <a16:creationId xmlns:a16="http://schemas.microsoft.com/office/drawing/2014/main" id="{17BAFD6C-ED5B-4561-BC98-CB1AD6F93709}"/>
               </a:ext>
             </a:extLst>
           </p:cNvPr>
@@ -23641,7 +23641,7 @@
           <p:cNvPr id="5" name="Uitlegvoorbeeld — niet uit het boek">
             <a:extLst xmlns:a="http://schemas.openxmlformats.org/drawingml/2006/main">
               <a:ext uri="{FF2B5EF4-FFF2-40B4-BE49-F238E27FC236}">
-                <a16:creationId xmlns:a16="http://schemas.microsoft.com/office/drawing/2014/main" id="{5173A5E1-79D1-4B9C-A356-78F1AE6EAB5F}"/>
+                <a16:creationId xmlns:a16="http://schemas.microsoft.com/office/drawing/2014/main" id="{991B7BD8-346F-4540-A567-690D2BC9A16E}"/>
               </a:ext>
             </a:extLst>
           </p:cNvPr>
@@ -23705,7 +23705,7 @@
         </p:xfrm>
         <a:graphic xmlns:a="http://schemas.openxmlformats.org/drawingml/2006/main">
           <a:graphicData uri="http://schemas.openxmlformats.org/drawingml/2006/chart">
-            <c:chart xmlns:r="http://schemas.openxmlformats.org/officeDocument/2006/relationships" xmlns:c="http://schemas.openxmlformats.org/drawingml/2006/chart" r:id="R2159e716d44142a0"/>
+            <c:chart xmlns:r="http://schemas.openxmlformats.org/officeDocument/2006/relationships" xmlns:c="http://schemas.openxmlformats.org/drawingml/2006/chart" r:id="R4d04bd1fa36440a5"/>
           </a:graphicData>
         </a:graphic>
       </p:graphicFrame>
@@ -23714,7 +23714,7 @@
           <p:cNvPr id="7" name="P = € 2,50 per kg">
             <a:extLst xmlns:a="http://schemas.openxmlformats.org/drawingml/2006/main">
               <a:ext uri="{FF2B5EF4-FFF2-40B4-BE49-F238E27FC236}">
-                <a16:creationId xmlns:a16="http://schemas.microsoft.com/office/drawing/2014/main" id="{08E230F1-A758-45FA-82BD-696FD1CF24DE}"/>
+                <a16:creationId xmlns:a16="http://schemas.microsoft.com/office/drawing/2014/main" id="{64E61B3A-6902-4546-A39E-2BD0768D66BB}"/>
               </a:ext>
             </a:extLst>
           </p:cNvPr>
@@ -23771,7 +23771,7 @@
           <p:cNvPr id="8" name="Q = 6 × 1.000&#10;= 6.000 kg per dag">
             <a:extLst xmlns:a="http://schemas.openxmlformats.org/drawingml/2006/main">
               <a:ext uri="{FF2B5EF4-FFF2-40B4-BE49-F238E27FC236}">
-                <a16:creationId xmlns:a16="http://schemas.microsoft.com/office/drawing/2014/main" id="{55D92E5C-16CA-434C-AB43-1C418EDF569A}"/>
+                <a16:creationId xmlns:a16="http://schemas.microsoft.com/office/drawing/2014/main" id="{F6F9CA2B-C6D5-4417-BCBE-CCB0E1893102}"/>
               </a:ext>
             </a:extLst>
           </p:cNvPr>
@@ -23849,7 +23849,7 @@
     </p:spTree>
     <p:extLst>
       <p:ext uri="{BB962C8B-B14F-4D97-AF65-F5344CB8AC3E}">
-        <p14:creationId xmlns:p14="http://schemas.microsoft.com/office/powerpoint/2010/main" val="882409905"/>
+        <p14:creationId xmlns:p14="http://schemas.microsoft.com/office/powerpoint/2010/main" val="1119715931"/>
       </p:ext>
     </p:extLst>
   </p:cSld>
@@ -23880,7 +23880,7 @@
           <p:cNvPr id="11" name="De marktprijs en één teler">
             <a:extLst xmlns:a="http://schemas.openxmlformats.org/drawingml/2006/main">
               <a:ext uri="{FF2B5EF4-FFF2-40B4-BE49-F238E27FC236}">
-                <a16:creationId xmlns:a16="http://schemas.microsoft.com/office/drawing/2014/main" id="{9DB87517-0115-4352-B318-3D0A13EBAEC6}"/>
+                <a16:creationId xmlns:a16="http://schemas.microsoft.com/office/drawing/2014/main" id="{7FA7CBB4-11FE-4225-90AE-6CA305F5D3B3}"/>
               </a:ext>
             </a:extLst>
           </p:cNvPr>
@@ -23937,7 +23937,7 @@
           <p:cNvPr id="2" name="">
             <a:extLst xmlns:a="http://schemas.openxmlformats.org/drawingml/2006/main">
               <a:ext uri="{FF2B5EF4-FFF2-40B4-BE49-F238E27FC236}">
-                <a16:creationId xmlns:a16="http://schemas.microsoft.com/office/drawing/2014/main" id="{19952944-998B-4BD2-BBC2-F3EFB6768C5D}"/>
+                <a16:creationId xmlns:a16="http://schemas.microsoft.com/office/drawing/2014/main" id="{D41A43A6-8DF8-4058-B819-B5A36B684C59}"/>
               </a:ext>
             </a:extLst>
           </p:cNvPr>
@@ -23966,7 +23966,7 @@
           <p:cNvPr id="3" name="§3.2.1 Volkomen concurrentie">
             <a:extLst xmlns:a="http://schemas.openxmlformats.org/drawingml/2006/main">
               <a:ext uri="{FF2B5EF4-FFF2-40B4-BE49-F238E27FC236}">
-                <a16:creationId xmlns:a16="http://schemas.microsoft.com/office/drawing/2014/main" id="{3627A159-0CC4-4827-AA97-35A53AE8BB2B}"/>
+                <a16:creationId xmlns:a16="http://schemas.microsoft.com/office/drawing/2014/main" id="{A07B2FFD-6D14-4D1B-AF12-16F145674D2E}"/>
               </a:ext>
             </a:extLst>
           </p:cNvPr>
@@ -24023,7 +24023,7 @@
           <p:cNvPr id="4" name="6">
             <a:extLst xmlns:a="http://schemas.openxmlformats.org/drawingml/2006/main">
               <a:ext uri="{FF2B5EF4-FFF2-40B4-BE49-F238E27FC236}">
-                <a16:creationId xmlns:a16="http://schemas.microsoft.com/office/drawing/2014/main" id="{03B01A63-2B25-41B5-A5B9-8C52EE84F52F}"/>
+                <a16:creationId xmlns:a16="http://schemas.microsoft.com/office/drawing/2014/main" id="{D07CD238-EBBA-479A-A7B6-4410977988CD}"/>
               </a:ext>
             </a:extLst>
           </p:cNvPr>
@@ -24080,7 +24080,7 @@
           <p:cNvPr id="5" name="Uitlegvoorbeeld — niet uit het boek">
             <a:extLst xmlns:a="http://schemas.openxmlformats.org/drawingml/2006/main">
               <a:ext uri="{FF2B5EF4-FFF2-40B4-BE49-F238E27FC236}">
-                <a16:creationId xmlns:a16="http://schemas.microsoft.com/office/drawing/2014/main" id="{8772F89C-B061-431C-9593-DA9E1D1DD8E7}"/>
+                <a16:creationId xmlns:a16="http://schemas.microsoft.com/office/drawing/2014/main" id="{7B3A1175-D831-4C04-8B04-B9C748F167CE}"/>
               </a:ext>
             </a:extLst>
           </p:cNvPr>
@@ -24137,7 +24137,7 @@
           <p:cNvPr id="6" name="De hele havermarkt">
             <a:extLst xmlns:a="http://schemas.openxmlformats.org/drawingml/2006/main">
               <a:ext uri="{FF2B5EF4-FFF2-40B4-BE49-F238E27FC236}">
-                <a16:creationId xmlns:a16="http://schemas.microsoft.com/office/drawing/2014/main" id="{94303B7C-457F-4F75-AB2B-E35CA3DE35C6}"/>
+                <a16:creationId xmlns:a16="http://schemas.microsoft.com/office/drawing/2014/main" id="{01668157-9400-48AF-BF5E-20384ACD48BD}"/>
               </a:ext>
             </a:extLst>
           </p:cNvPr>
@@ -24194,7 +24194,7 @@
           <p:cNvPr id="7" name="Teler Sam: maximaal 180 kg per dag">
             <a:extLst xmlns:a="http://schemas.openxmlformats.org/drawingml/2006/main">
               <a:ext uri="{FF2B5EF4-FFF2-40B4-BE49-F238E27FC236}">
-                <a16:creationId xmlns:a16="http://schemas.microsoft.com/office/drawing/2014/main" id="{C80B828B-A088-4933-AEF6-0CA0AC28C3B7}"/>
+                <a16:creationId xmlns:a16="http://schemas.microsoft.com/office/drawing/2014/main" id="{1899EA51-8F6B-4F17-A108-CA8077F0085B}"/>
               </a:ext>
             </a:extLst>
           </p:cNvPr>
@@ -24258,7 +24258,7 @@
         </p:xfrm>
         <a:graphic xmlns:a="http://schemas.openxmlformats.org/drawingml/2006/main">
           <a:graphicData uri="http://schemas.openxmlformats.org/drawingml/2006/chart">
-            <c:chart xmlns:r="http://schemas.openxmlformats.org/officeDocument/2006/relationships" xmlns:c="http://schemas.openxmlformats.org/drawingml/2006/chart" r:id="Rc07cb54f68284b95"/>
+            <c:chart xmlns:r="http://schemas.openxmlformats.org/officeDocument/2006/relationships" xmlns:c="http://schemas.openxmlformats.org/drawingml/2006/chart" r:id="Re0c0365e73f54a1a"/>
           </a:graphicData>
         </a:graphic>
       </p:graphicFrame>
@@ -24274,7 +24274,7 @@
         </p:xfrm>
         <a:graphic xmlns:a="http://schemas.openxmlformats.org/drawingml/2006/main">
           <a:graphicData uri="http://schemas.openxmlformats.org/drawingml/2006/chart">
-            <c:chart xmlns:r="http://schemas.openxmlformats.org/officeDocument/2006/relationships" xmlns:c="http://schemas.openxmlformats.org/drawingml/2006/chart" r:id="R4eb00f3aa09c4234"/>
+            <c:chart xmlns:r="http://schemas.openxmlformats.org/officeDocument/2006/relationships" xmlns:c="http://schemas.openxmlformats.org/drawingml/2006/chart" r:id="R2ec3191b7c3643d7"/>
           </a:graphicData>
         </a:graphic>
       </p:graphicFrame>
@@ -24283,7 +24283,7 @@
           <p:cNvPr id="10" name="Sam neemt de prijs over: € 2,50 per kg.">
             <a:extLst xmlns:a="http://schemas.openxmlformats.org/drawingml/2006/main">
               <a:ext uri="{FF2B5EF4-FFF2-40B4-BE49-F238E27FC236}">
-                <a16:creationId xmlns:a16="http://schemas.microsoft.com/office/drawing/2014/main" id="{A2453EE5-CC83-4847-8513-DD4D1890DB34}"/>
+                <a16:creationId xmlns:a16="http://schemas.microsoft.com/office/drawing/2014/main" id="{35256128-18F4-45B4-8F37-A1AAE3EC691C}"/>
               </a:ext>
             </a:extLst>
           </p:cNvPr>
@@ -24338,7 +24338,7 @@
     </p:spTree>
     <p:extLst>
       <p:ext uri="{BB962C8B-B14F-4D97-AF65-F5344CB8AC3E}">
-        <p14:creationId xmlns:p14="http://schemas.microsoft.com/office/powerpoint/2010/main" val="364112154"/>
+        <p14:creationId xmlns:p14="http://schemas.microsoft.com/office/powerpoint/2010/main" val="99829258"/>
       </p:ext>
     </p:extLst>
   </p:cSld>
@@ -24369,7 +24369,7 @@
           <p:cNvPr id="11" name="Elke kg brengt dezelfde prijs op">
             <a:extLst xmlns:a="http://schemas.openxmlformats.org/drawingml/2006/main">
               <a:ext uri="{FF2B5EF4-FFF2-40B4-BE49-F238E27FC236}">
-                <a16:creationId xmlns:a16="http://schemas.microsoft.com/office/drawing/2014/main" id="{3987E420-5F8F-4BA5-85DC-E98E061DF8B0}"/>
+                <a16:creationId xmlns:a16="http://schemas.microsoft.com/office/drawing/2014/main" id="{0B7476C4-4CFF-4A70-AAE3-3DAE9DD977F0}"/>
               </a:ext>
             </a:extLst>
           </p:cNvPr>
@@ -24426,7 +24426,7 @@
           <p:cNvPr id="2" name="">
             <a:extLst xmlns:a="http://schemas.openxmlformats.org/drawingml/2006/main">
               <a:ext uri="{FF2B5EF4-FFF2-40B4-BE49-F238E27FC236}">
-                <a16:creationId xmlns:a16="http://schemas.microsoft.com/office/drawing/2014/main" id="{454A60C3-FA55-4670-91D6-DB285D81DFF6}"/>
+                <a16:creationId xmlns:a16="http://schemas.microsoft.com/office/drawing/2014/main" id="{223C99BB-33C0-47DC-91C1-9D327AB27C8E}"/>
               </a:ext>
             </a:extLst>
           </p:cNvPr>
@@ -24455,7 +24455,7 @@
           <p:cNvPr id="3" name="§3.2.1 Volkomen concurrentie">
             <a:extLst xmlns:a="http://schemas.openxmlformats.org/drawingml/2006/main">
               <a:ext uri="{FF2B5EF4-FFF2-40B4-BE49-F238E27FC236}">
-                <a16:creationId xmlns:a16="http://schemas.microsoft.com/office/drawing/2014/main" id="{EF9F1113-B8F2-404D-8C3F-F78738A540A4}"/>
+                <a16:creationId xmlns:a16="http://schemas.microsoft.com/office/drawing/2014/main" id="{C5BC0A4B-A399-4789-B7C2-56FED8539A21}"/>
               </a:ext>
             </a:extLst>
           </p:cNvPr>
@@ -24512,7 +24512,7 @@
           <p:cNvPr id="4" name="7">
             <a:extLst xmlns:a="http://schemas.openxmlformats.org/drawingml/2006/main">
               <a:ext uri="{FF2B5EF4-FFF2-40B4-BE49-F238E27FC236}">
-                <a16:creationId xmlns:a16="http://schemas.microsoft.com/office/drawing/2014/main" id="{B4537AAD-71EA-4FF0-BE9E-B8723F9D5FCB}"/>
+                <a16:creationId xmlns:a16="http://schemas.microsoft.com/office/drawing/2014/main" id="{4B75BDFB-3992-4B94-856C-13C37D1D36C5}"/>
               </a:ext>
             </a:extLst>
           </p:cNvPr>
@@ -24569,7 +24569,7 @@
           <p:cNvPr id="5" name="Uitlegvoorbeeld — niet uit het boek">
             <a:extLst xmlns:a="http://schemas.openxmlformats.org/drawingml/2006/main">
               <a:ext uri="{FF2B5EF4-FFF2-40B4-BE49-F238E27FC236}">
-                <a16:creationId xmlns:a16="http://schemas.microsoft.com/office/drawing/2014/main" id="{0B94FCE9-8704-4374-908A-9BA21F697D2A}"/>
+                <a16:creationId xmlns:a16="http://schemas.microsoft.com/office/drawing/2014/main" id="{53FEE473-6E64-4728-A627-DC399F57A525}"/>
               </a:ext>
             </a:extLst>
           </p:cNvPr>
@@ -24626,7 +24626,7 @@
           <p:cNvPr id="6" name="De hele havermarkt">
             <a:extLst xmlns:a="http://schemas.openxmlformats.org/drawingml/2006/main">
               <a:ext uri="{FF2B5EF4-FFF2-40B4-BE49-F238E27FC236}">
-                <a16:creationId xmlns:a16="http://schemas.microsoft.com/office/drawing/2014/main" id="{88000ADF-C99C-4C3A-AEAE-0268A5139B28}"/>
+                <a16:creationId xmlns:a16="http://schemas.microsoft.com/office/drawing/2014/main" id="{98F0E725-3584-45F8-B985-DB7E7A9C3127}"/>
               </a:ext>
             </a:extLst>
           </p:cNvPr>
@@ -24683,7 +24683,7 @@
           <p:cNvPr id="7" name="Teler Sam: maximaal 180 kg per dag">
             <a:extLst xmlns:a="http://schemas.openxmlformats.org/drawingml/2006/main">
               <a:ext uri="{FF2B5EF4-FFF2-40B4-BE49-F238E27FC236}">
-                <a16:creationId xmlns:a16="http://schemas.microsoft.com/office/drawing/2014/main" id="{963C6A12-8D0A-47A8-A653-B3A8E961261F}"/>
+                <a16:creationId xmlns:a16="http://schemas.microsoft.com/office/drawing/2014/main" id="{A7264562-E6EA-4E75-AED1-5380904FE559}"/>
               </a:ext>
             </a:extLst>
           </p:cNvPr>
@@ -24747,7 +24747,7 @@
         </p:xfrm>
         <a:graphic xmlns:a="http://schemas.openxmlformats.org/drawingml/2006/main">
           <a:graphicData uri="http://schemas.openxmlformats.org/drawingml/2006/chart">
-            <c:chart xmlns:r="http://schemas.openxmlformats.org/officeDocument/2006/relationships" xmlns:c="http://schemas.openxmlformats.org/drawingml/2006/chart" r:id="R97543875c85d462d"/>
+            <c:chart xmlns:r="http://schemas.openxmlformats.org/officeDocument/2006/relationships" xmlns:c="http://schemas.openxmlformats.org/drawingml/2006/chart" r:id="R7b814747cd2e49a1"/>
           </a:graphicData>
         </a:graphic>
       </p:graphicFrame>
@@ -24763,7 +24763,7 @@
         </p:xfrm>
         <a:graphic xmlns:a="http://schemas.openxmlformats.org/drawingml/2006/main">
           <a:graphicData uri="http://schemas.openxmlformats.org/drawingml/2006/chart">
-            <c:chart xmlns:r="http://schemas.openxmlformats.org/officeDocument/2006/relationships" xmlns:c="http://schemas.openxmlformats.org/drawingml/2006/chart" r:id="R83c31c5c85924404"/>
+            <c:chart xmlns:r="http://schemas.openxmlformats.org/officeDocument/2006/relationships" xmlns:c="http://schemas.openxmlformats.org/drawingml/2006/chart" r:id="R7d69cb3d217041b0"/>
           </a:graphicData>
         </a:graphic>
       </p:graphicFrame>
@@ -24772,7 +24772,7 @@
           <p:cNvPr id="10" name="Elke kg brengt € 2,50 op, binnen Sams capaciteit.">
             <a:extLst xmlns:a="http://schemas.openxmlformats.org/drawingml/2006/main">
               <a:ext uri="{FF2B5EF4-FFF2-40B4-BE49-F238E27FC236}">
-                <a16:creationId xmlns:a16="http://schemas.microsoft.com/office/drawing/2014/main" id="{6ED141C5-BCF4-46C4-9B94-76744EB497D7}"/>
+                <a16:creationId xmlns:a16="http://schemas.microsoft.com/office/drawing/2014/main" id="{C693794F-B864-4A27-83C6-CA08258F860F}"/>
               </a:ext>
             </a:extLst>
           </p:cNvPr>
@@ -24827,7 +24827,7 @@
     </p:spTree>
     <p:extLst>
       <p:ext uri="{BB962C8B-B14F-4D97-AF65-F5344CB8AC3E}">
-        <p14:creationId xmlns:p14="http://schemas.microsoft.com/office/powerpoint/2010/main" val="1789354390"/>
+        <p14:creationId xmlns:p14="http://schemas.microsoft.com/office/powerpoint/2010/main" val="776677329"/>
       </p:ext>
     </p:extLst>
   </p:cSld>
@@ -24858,7 +24858,7 @@
           <p:cNvPr id="9" name="Totale en gemiddelde opbrengst">
             <a:extLst xmlns:a="http://schemas.openxmlformats.org/drawingml/2006/main">
               <a:ext uri="{FF2B5EF4-FFF2-40B4-BE49-F238E27FC236}">
-                <a16:creationId xmlns:a16="http://schemas.microsoft.com/office/drawing/2014/main" id="{3783BD16-C335-43F6-A9A0-BD87B820EB4B}"/>
+                <a16:creationId xmlns:a16="http://schemas.microsoft.com/office/drawing/2014/main" id="{ADA3DC78-E681-4BD8-91D4-C4AF8D05C4DB}"/>
               </a:ext>
             </a:extLst>
           </p:cNvPr>
@@ -24915,7 +24915,7 @@
           <p:cNvPr id="2" name="">
             <a:extLst xmlns:a="http://schemas.openxmlformats.org/drawingml/2006/main">
               <a:ext uri="{FF2B5EF4-FFF2-40B4-BE49-F238E27FC236}">
-                <a16:creationId xmlns:a16="http://schemas.microsoft.com/office/drawing/2014/main" id="{EFD9623F-86BF-4E51-963F-19CE13CF5657}"/>
+                <a16:creationId xmlns:a16="http://schemas.microsoft.com/office/drawing/2014/main" id="{206B8D61-9DEC-4251-805E-A43323785217}"/>
               </a:ext>
             </a:extLst>
           </p:cNvPr>
@@ -24944,7 +24944,7 @@
           <p:cNvPr id="3" name="§3.2.1 Volkomen concurrentie">
             <a:extLst xmlns:a="http://schemas.openxmlformats.org/drawingml/2006/main">
               <a:ext uri="{FF2B5EF4-FFF2-40B4-BE49-F238E27FC236}">
-                <a16:creationId xmlns:a16="http://schemas.microsoft.com/office/drawing/2014/main" id="{9C1B046F-1B34-44DD-8AE7-5BA5D4AFA4A3}"/>
+                <a16:creationId xmlns:a16="http://schemas.microsoft.com/office/drawing/2014/main" id="{1EAAD62B-9024-4ADC-A2F6-F3243078038E}"/>
               </a:ext>
             </a:extLst>
           </p:cNvPr>
@@ -25001,7 +25001,7 @@
           <p:cNvPr id="4" name="8">
             <a:extLst xmlns:a="http://schemas.openxmlformats.org/drawingml/2006/main">
               <a:ext uri="{FF2B5EF4-FFF2-40B4-BE49-F238E27FC236}">
-                <a16:creationId xmlns:a16="http://schemas.microsoft.com/office/drawing/2014/main" id="{A0BAE2B3-8CA5-42E1-9705-0031C28A1054}"/>
+                <a16:creationId xmlns:a16="http://schemas.microsoft.com/office/drawing/2014/main" id="{84F49B91-12AB-43E1-A275-0766E9B4B007}"/>
               </a:ext>
             </a:extLst>
           </p:cNvPr>
@@ -25058,7 +25058,7 @@
           <p:cNvPr id="5" name="Uitlegvoorbeeld — niet uit het boek">
             <a:extLst xmlns:a="http://schemas.openxmlformats.org/drawingml/2006/main">
               <a:ext uri="{FF2B5EF4-FFF2-40B4-BE49-F238E27FC236}">
-                <a16:creationId xmlns:a16="http://schemas.microsoft.com/office/drawing/2014/main" id="{7D8F1840-BEFD-4D4E-B108-73BD25FCD842}"/>
+                <a16:creationId xmlns:a16="http://schemas.microsoft.com/office/drawing/2014/main" id="{B91A0DDB-7C83-469A-9BBE-55FE02A2FD09}"/>
               </a:ext>
             </a:extLst>
           </p:cNvPr>
@@ -25115,7 +25115,7 @@
           <p:cNvPr id="6" name="Sam verkoopt 60 kg per dag voor € 2,50 per kg.">
             <a:extLst xmlns:a="http://schemas.openxmlformats.org/drawingml/2006/main">
               <a:ext uri="{FF2B5EF4-FFF2-40B4-BE49-F238E27FC236}">
-                <a16:creationId xmlns:a16="http://schemas.microsoft.com/office/drawing/2014/main" id="{577CA956-A9DC-4637-A2B3-3EB5E26AC282}"/>
+                <a16:creationId xmlns:a16="http://schemas.microsoft.com/office/drawing/2014/main" id="{C9527C2D-6773-456B-A703-36C566D32097}"/>
               </a:ext>
             </a:extLst>
           </p:cNvPr>
@@ -25417,7 +25417,7 @@
           <p:cNvPr id="8" name="GO = P bij één vaste verkoopprijs en q &gt; 0.">
             <a:extLst xmlns:a="http://schemas.openxmlformats.org/drawingml/2006/main">
               <a:ext uri="{FF2B5EF4-FFF2-40B4-BE49-F238E27FC236}">
-                <a16:creationId xmlns:a16="http://schemas.microsoft.com/office/drawing/2014/main" id="{93015819-F97A-4703-9D9F-C32D03AD82DF}"/>
+                <a16:creationId xmlns:a16="http://schemas.microsoft.com/office/drawing/2014/main" id="{CB81F928-1396-4C9E-9B8D-099ECDCDE587}"/>
               </a:ext>
             </a:extLst>
           </p:cNvPr>
@@ -25472,7 +25472,7 @@
     </p:spTree>
     <p:extLst>
       <p:ext uri="{BB962C8B-B14F-4D97-AF65-F5344CB8AC3E}">
-        <p14:creationId xmlns:p14="http://schemas.microsoft.com/office/powerpoint/2010/main" val="255314144"/>
+        <p14:creationId xmlns:p14="http://schemas.microsoft.com/office/powerpoint/2010/main" val="495651180"/>
       </p:ext>
     </p:extLst>
   </p:cSld>
@@ -25503,7 +25503,7 @@
           <p:cNvPr id="10" name="Marginale opbrengst: eerst aftrekken, dan delen">
             <a:extLst xmlns:a="http://schemas.openxmlformats.org/drawingml/2006/main">
               <a:ext uri="{FF2B5EF4-FFF2-40B4-BE49-F238E27FC236}">
-                <a16:creationId xmlns:a16="http://schemas.microsoft.com/office/drawing/2014/main" id="{02BE5C67-2704-4B26-86A0-A8872FA861D7}"/>
+                <a16:creationId xmlns:a16="http://schemas.microsoft.com/office/drawing/2014/main" id="{8479A025-9D4D-44BD-9582-1F1B2513CCFC}"/>
               </a:ext>
             </a:extLst>
           </p:cNvPr>
@@ -25560,7 +25560,7 @@
           <p:cNvPr id="2" name="">
             <a:extLst xmlns:a="http://schemas.openxmlformats.org/drawingml/2006/main">
               <a:ext uri="{FF2B5EF4-FFF2-40B4-BE49-F238E27FC236}">
-                <a16:creationId xmlns:a16="http://schemas.microsoft.com/office/drawing/2014/main" id="{A1974FD9-5300-4131-9942-B9EA101771DC}"/>
+                <a16:creationId xmlns:a16="http://schemas.microsoft.com/office/drawing/2014/main" id="{67E84856-7AFB-4416-9E12-008EB9F9DAB4}"/>
               </a:ext>
             </a:extLst>
           </p:cNvPr>
@@ -25589,7 +25589,7 @@
           <p:cNvPr id="3" name="§3.2.1 Volkomen concurrentie">
             <a:extLst xmlns:a="http://schemas.openxmlformats.org/drawingml/2006/main">
               <a:ext uri="{FF2B5EF4-FFF2-40B4-BE49-F238E27FC236}">
-                <a16:creationId xmlns:a16="http://schemas.microsoft.com/office/drawing/2014/main" id="{5092D398-A2DA-49DB-8214-ADC405902011}"/>
+                <a16:creationId xmlns:a16="http://schemas.microsoft.com/office/drawing/2014/main" id="{3E1A2FD3-6904-4F10-B36B-5E0400FADEA6}"/>
               </a:ext>
             </a:extLst>
           </p:cNvPr>
@@ -25646,7 +25646,7 @@
           <p:cNvPr id="4" name="9">
             <a:extLst xmlns:a="http://schemas.openxmlformats.org/drawingml/2006/main">
               <a:ext uri="{FF2B5EF4-FFF2-40B4-BE49-F238E27FC236}">
-                <a16:creationId xmlns:a16="http://schemas.microsoft.com/office/drawing/2014/main" id="{DC3C9050-3B5F-42FE-8CF5-EA5F9F0EB92C}"/>
+                <a16:creationId xmlns:a16="http://schemas.microsoft.com/office/drawing/2014/main" id="{5B7B52D2-01E0-4A47-ACA6-DFF1D488047A}"/>
               </a:ext>
             </a:extLst>
           </p:cNvPr>
@@ -25703,7 +25703,7 @@
           <p:cNvPr id="5" name="Uitlegvoorbeeld — niet uit het boek">
             <a:extLst xmlns:a="http://schemas.openxmlformats.org/drawingml/2006/main">
               <a:ext uri="{FF2B5EF4-FFF2-40B4-BE49-F238E27FC236}">
-                <a16:creationId xmlns:a16="http://schemas.microsoft.com/office/drawing/2014/main" id="{8B91148F-3FEC-4E4B-942A-23DE44B379D9}"/>
+                <a16:creationId xmlns:a16="http://schemas.microsoft.com/office/drawing/2014/main" id="{2593FBAE-6AF9-413C-93CE-645F35B6CCE1}"/>
               </a:ext>
             </a:extLst>
           </p:cNvPr>
@@ -25932,7 +25932,7 @@
           <p:cNvPr id="7" name="ΔTO = 225 − 150 = € 75 per dag">
             <a:extLst xmlns:a="http://schemas.openxmlformats.org/drawingml/2006/main">
               <a:ext uri="{FF2B5EF4-FFF2-40B4-BE49-F238E27FC236}">
-                <a16:creationId xmlns:a16="http://schemas.microsoft.com/office/drawing/2014/main" id="{E6D505BE-1BF4-4D62-9F88-3E750ED4F2A4}"/>
+                <a16:creationId xmlns:a16="http://schemas.microsoft.com/office/drawing/2014/main" id="{CF0A9CAF-1D29-4DDE-85C5-0B70CD8C781E}"/>
               </a:ext>
             </a:extLst>
           </p:cNvPr>
@@ -25989,7 +25989,7 @@
           <p:cNvPr id="8" name="Δq = 90 − 60 = 30 kg per dag">
             <a:extLst xmlns:a="http://schemas.openxmlformats.org/drawingml/2006/main">
               <a:ext uri="{FF2B5EF4-FFF2-40B4-BE49-F238E27FC236}">
-                <a16:creationId xmlns:a16="http://schemas.microsoft.com/office/drawing/2014/main" id="{29D59B33-31AE-4F47-BD48-18695E9E446F}"/>
+                <a16:creationId xmlns:a16="http://schemas.microsoft.com/office/drawing/2014/main" id="{A89EE521-61B4-43BB-AA03-629EED5A2CB6}"/>
               </a:ext>
             </a:extLst>
           </p:cNvPr>
@@ -26046,7 +26046,7 @@
           <p:cNvPr id="9" name="MO = ΔTO / Δq = 75 / 30 = € 2,50 per kg">
             <a:extLst xmlns:a="http://schemas.openxmlformats.org/drawingml/2006/main">
               <a:ext uri="{FF2B5EF4-FFF2-40B4-BE49-F238E27FC236}">
-                <a16:creationId xmlns:a16="http://schemas.microsoft.com/office/drawing/2014/main" id="{7BB27E41-2DAC-454D-8FD7-CE30F9345CBC}"/>
+                <a16:creationId xmlns:a16="http://schemas.microsoft.com/office/drawing/2014/main" id="{84831309-49F2-4951-9518-BA6D8503721F}"/>
               </a:ext>
             </a:extLst>
           </p:cNvPr>
@@ -26101,7 +26101,7 @@
     </p:spTree>
     <p:extLst>
       <p:ext uri="{BB962C8B-B14F-4D97-AF65-F5344CB8AC3E}">
-        <p14:creationId xmlns:p14="http://schemas.microsoft.com/office/powerpoint/2010/main" val="114518982"/>
+        <p14:creationId xmlns:p14="http://schemas.microsoft.com/office/powerpoint/2010/main" val="135511415"/>
       </p:ext>
     </p:extLst>
   </p:cSld>

</xml_diff>